<commit_message>
Strengthen Lab 2 theory and analysis workflow
</commit_message>
<xml_diff>
--- a/site/docs/MIE402_Lecture03_Single_Pendulum_PreLab2_Fall2026.pptx
+++ b/site/docs/MIE402_Lecture03_Single_Pendulum_PreLab2_Fall2026.pptx
@@ -27,6 +27,7 @@
     <p:sldId id="275" r:id="rId26"/>
     <p:sldId id="276" r:id="rId27"/>
     <p:sldId id="277" r:id="rId28"/>
+    <p:sldId id="278" r:id="rId29"/>
   </p:sldIdLst>
   <p:sldSz cx="12191695" cy="6858000" type="screen4x3"/>
   <p:notesSz cx="6858000" cy="9144000"/>
@@ -3398,7 +3399,7 @@
               </a:defRPr>
             </a:pPr>
             <a:r>
-              <a:t>18-20 min</a:t>
+              <a:t>19-21 min</a:t>
             </a:r>
           </a:p>
         </p:txBody>
@@ -3434,101 +3435,14 @@
               </a:defRPr>
             </a:pPr>
             <a:r>
-              <a:t>From pixels to coordinates</a:t>
-            </a:r>
-          </a:p>
-        </p:txBody>
-      </p:sp>
-      <p:sp>
-        <p:nvSpPr>
-          <p:cNvPr id="5" name="TextBox 4"/>
-          <p:cNvSpPr txBox="1"/>
-          <p:nvPr/>
-        </p:nvSpPr>
-        <p:spPr>
-          <a:xfrm>
-            <a:off x="685800" y="1508760"/>
-            <a:ext cx="5394960" cy="4480560"/>
-          </a:xfrm>
-          <a:prstGeom prst="rect">
-            <a:avLst/>
-          </a:prstGeom>
-          <a:noFill/>
-        </p:spPr>
-        <p:txBody>
-          <a:bodyPr wrap="square">
-            <a:spAutoFit/>
-          </a:bodyPr>
-          <a:lstStyle/>
-          <a:p>
-            <a:pPr>
-              <a:spcAft>
-                <a:spcPts val="1100"/>
-              </a:spcAft>
-              <a:defRPr sz="2100">
-                <a:solidFill>
-                  <a:srgbClr val="161616"/>
-                </a:solidFill>
-                <a:latin typeface="Aptos"/>
-              </a:defRPr>
-            </a:pPr>
-            <a:r>
-              <a:t>Calibration marks have known separation, normally 100 mm.</a:t>
-            </a:r>
-          </a:p>
-          <a:p>
-            <a:pPr>
-              <a:spcAft>
-                <a:spcPts val="1100"/>
-              </a:spcAft>
-              <a:defRPr sz="2100">
-                <a:solidFill>
-                  <a:srgbClr val="161616"/>
-                </a:solidFill>
-                <a:latin typeface="Aptos"/>
-              </a:defRPr>
-            </a:pPr>
-            <a:r>
-              <a:t>Calibration gives pixel-to-millimeter scale.</a:t>
-            </a:r>
-          </a:p>
-          <a:p>
-            <a:pPr>
-              <a:spcAft>
-                <a:spcPts val="1100"/>
-              </a:spcAft>
-              <a:defRPr sz="2100">
-                <a:solidFill>
-                  <a:srgbClr val="161616"/>
-                </a:solidFill>
-                <a:latin typeface="Aptos"/>
-              </a:defRPr>
-            </a:pPr>
-            <a:r>
-              <a:t>Do not move camera or change zoom after calibration.</a:t>
-            </a:r>
-          </a:p>
-          <a:p>
-            <a:pPr>
-              <a:spcAft>
-                <a:spcPts val="1100"/>
-              </a:spcAft>
-              <a:defRPr sz="2100">
-                <a:solidFill>
-                  <a:srgbClr val="161616"/>
-                </a:solidFill>
-                <a:latin typeface="Aptos"/>
-              </a:defRPr>
-            </a:pPr>
-            <a:r>
-              <a:t>App saves time and bob coordinates.</a:t>
+              <a:t>Camera settings and useful video</a:t>
             </a:r>
           </a:p>
         </p:txBody>
       </p:sp>
       <p:pic>
         <p:nvPicPr>
-          <p:cNvPr id="6" name="Picture 5" descr="lab2-analyzer-calibration.jpg"/>
+          <p:cNvPr id="5" name="Picture 4" descr="lab2-camera-record-settings.jpg"/>
           <p:cNvPicPr>
             <a:picLocks noChangeAspect="1"/>
           </p:cNvPicPr>
@@ -3542,14 +3456,125 @@
         </p:blipFill>
         <p:spPr>
           <a:xfrm>
-            <a:off x="6400800" y="1371600"/>
-            <a:ext cx="4754880" cy="4480560"/>
+            <a:off x="594360" y="1463040"/>
+            <a:ext cx="4114800" cy="3063240"/>
           </a:xfrm>
           <a:prstGeom prst="rect">
             <a:avLst/>
           </a:prstGeom>
         </p:spPr>
       </p:pic>
+      <p:pic>
+        <p:nvPicPr>
+          <p:cNvPr id="6" name="Picture 5" descr="lab2-camera-trigger-delay.jpg"/>
+          <p:cNvPicPr>
+            <a:picLocks noChangeAspect="1"/>
+          </p:cNvPicPr>
+          <p:nvPr/>
+        </p:nvPicPr>
+        <p:blipFill>
+          <a:blip r:embed="rId3"/>
+          <a:stretch>
+            <a:fillRect/>
+          </a:stretch>
+        </p:blipFill>
+        <p:spPr>
+          <a:xfrm>
+            <a:off x="4892040" y="1463040"/>
+            <a:ext cx="4114800" cy="3063240"/>
+          </a:xfrm>
+          <a:prstGeom prst="rect">
+            <a:avLst/>
+          </a:prstGeom>
+        </p:spPr>
+      </p:pic>
+      <p:sp>
+        <p:nvSpPr>
+          <p:cNvPr id="7" name="TextBox 6"/>
+          <p:cNvSpPr txBox="1"/>
+          <p:nvPr/>
+        </p:nvSpPr>
+        <p:spPr>
+          <a:xfrm>
+            <a:off x="777240" y="4800600"/>
+            <a:ext cx="10515600" cy="1051560"/>
+          </a:xfrm>
+          <a:prstGeom prst="rect">
+            <a:avLst/>
+          </a:prstGeom>
+          <a:noFill/>
+        </p:spPr>
+        <p:txBody>
+          <a:bodyPr wrap="square">
+            <a:spAutoFit/>
+          </a:bodyPr>
+          <a:lstStyle/>
+          <a:p>
+            <a:pPr>
+              <a:spcAft>
+                <a:spcPts val="1100"/>
+              </a:spcAft>
+              <a:defRPr sz="1700">
+                <a:solidFill>
+                  <a:srgbClr val="161616"/>
+                </a:solidFill>
+                <a:latin typeface="Aptos"/>
+              </a:defRPr>
+            </a:pPr>
+            <a:r>
+              <a:t>Record actual frame rate.</a:t>
+            </a:r>
+          </a:p>
+          <a:p>
+            <a:pPr>
+              <a:spcAft>
+                <a:spcPts val="1100"/>
+              </a:spcAft>
+              <a:defRPr sz="1700">
+                <a:solidFill>
+                  <a:srgbClr val="161616"/>
+                </a:solidFill>
+                <a:latin typeface="Aptos"/>
+              </a:defRPr>
+            </a:pPr>
+            <a:r>
+              <a:t>Use trigger delay that includes release and cycles.</a:t>
+            </a:r>
+          </a:p>
+          <a:p>
+            <a:pPr>
+              <a:spcAft>
+                <a:spcPts val="1100"/>
+              </a:spcAft>
+              <a:defRPr sz="1700">
+                <a:solidFill>
+                  <a:srgbClr val="161616"/>
+                </a:solidFill>
+                <a:latin typeface="Aptos"/>
+              </a:defRPr>
+            </a:pPr>
+            <a:r>
+              <a:t>Test framing before experiment.</a:t>
+            </a:r>
+          </a:p>
+          <a:p>
+            <a:pPr>
+              <a:spcAft>
+                <a:spcPts val="1100"/>
+              </a:spcAft>
+              <a:defRPr sz="1700">
+                <a:solidFill>
+                  <a:srgbClr val="161616"/>
+                </a:solidFill>
+                <a:latin typeface="Aptos"/>
+              </a:defRPr>
+            </a:pPr>
+            <a:r>
+              <a:t>Smooth video does not prove accurate tracking.</a:t>
+            </a:r>
+          </a:p>
+        </p:txBody>
+      </p:sp>
     </p:spTree>
   </p:cSld>
   <p:clrMapOvr>
@@ -3635,7 +3660,7 @@
               </a:defRPr>
             </a:pPr>
             <a:r>
-              <a:t>20-22 min</a:t>
+              <a:t>21-23 min</a:t>
             </a:r>
           </a:p>
         </p:txBody>
@@ -3671,7 +3696,7 @@
               </a:defRPr>
             </a:pPr>
             <a:r>
-              <a:t>From coordinates to a signed angle</a:t>
+              <a:t>From pixels to coordinates</a:t>
             </a:r>
           </a:p>
         </p:txBody>
@@ -3684,44 +3709,8 @@
         </p:nvSpPr>
         <p:spPr>
           <a:xfrm>
-            <a:off x="640080" y="1554480"/>
-            <a:ext cx="10972800" cy="640080"/>
-          </a:xfrm>
-          <a:prstGeom prst="rect">
-            <a:avLst/>
-          </a:prstGeom>
-          <a:noFill/>
-        </p:spPr>
-        <p:txBody>
-          <a:bodyPr wrap="square">
-            <a:spAutoFit/>
-          </a:bodyPr>
-          <a:lstStyle/>
-          <a:p>
-            <a:pPr algn="ctr">
-              <a:defRPr sz="3000" b="1">
-                <a:solidFill>
-                  <a:srgbClr val="881C1C"/>
-                </a:solidFill>
-                <a:latin typeface="Aptos"/>
-              </a:defRPr>
-            </a:pPr>
-            <a:r>
-              <a:t>theta(t) = atan2( xb - xp,  yp - yb )</a:t>
-            </a:r>
-          </a:p>
-        </p:txBody>
-      </p:sp>
-      <p:sp>
-        <p:nvSpPr>
-          <p:cNvPr id="6" name="TextBox 5"/>
-          <p:cNvSpPr txBox="1"/>
-          <p:nvPr/>
-        </p:nvSpPr>
-        <p:spPr>
-          <a:xfrm>
-            <a:off x="868680" y="2880360"/>
-            <a:ext cx="10058400" cy="2286000"/>
+            <a:off x="685800" y="1508760"/>
+            <a:ext cx="5394960" cy="4480560"/>
           </a:xfrm>
           <a:prstGeom prst="rect">
             <a:avLst/>
@@ -3746,7 +3735,7 @@
               </a:defRPr>
             </a:pPr>
             <a:r>
-              <a:t>xp, yp are pivot coordinates; xb, yb are bob-center coordinates.</a:t>
+              <a:t>Calibration marks have known separation, normally 100 mm.</a:t>
             </a:r>
           </a:p>
           <a:p>
@@ -3762,7 +3751,7 @@
               </a:defRPr>
             </a:pPr>
             <a:r>
-              <a:t>atan2 preserves the correct quadrant.</a:t>
+              <a:t>Calibration gives pixel-to-millimeter scale.</a:t>
             </a:r>
           </a:p>
           <a:p>
@@ -3778,7 +3767,7 @@
               </a:defRPr>
             </a:pPr>
             <a:r>
-              <a:t>Use radians for modeling and derivatives.</a:t>
+              <a:t>Do not move camera or change zoom after calibration.</a:t>
             </a:r>
           </a:p>
           <a:p>
@@ -3794,11 +3783,35 @@
               </a:defRPr>
             </a:pPr>
             <a:r>
-              <a:t>A drifting pivot creates false angle change.</a:t>
-            </a:r>
-          </a:p>
-        </p:txBody>
-      </p:sp>
+              <a:t>App saves time and bob coordinates.</a:t>
+            </a:r>
+          </a:p>
+        </p:txBody>
+      </p:sp>
+      <p:pic>
+        <p:nvPicPr>
+          <p:cNvPr id="6" name="Picture 5" descr="lab2-analyzer-calibration.jpg"/>
+          <p:cNvPicPr>
+            <a:picLocks noChangeAspect="1"/>
+          </p:cNvPicPr>
+          <p:nvPr/>
+        </p:nvPicPr>
+        <p:blipFill>
+          <a:blip r:embed="rId2"/>
+          <a:stretch>
+            <a:fillRect/>
+          </a:stretch>
+        </p:blipFill>
+        <p:spPr>
+          <a:xfrm>
+            <a:off x="6400800" y="1371600"/>
+            <a:ext cx="4754880" cy="4480560"/>
+          </a:xfrm>
+          <a:prstGeom prst="rect">
+            <a:avLst/>
+          </a:prstGeom>
+        </p:spPr>
+      </p:pic>
     </p:spTree>
   </p:cSld>
   <p:clrMapOvr>
@@ -3884,7 +3897,7 @@
               </a:defRPr>
             </a:pPr>
             <a:r>
-              <a:t>22-25 min</a:t>
+              <a:t>23-25 min</a:t>
             </a:r>
           </a:p>
         </p:txBody>
@@ -3920,69 +3933,57 @@
               </a:defRPr>
             </a:pPr>
             <a:r>
-              <a:t>Tracking workflow in MATLAB</a:t>
-            </a:r>
-          </a:p>
-        </p:txBody>
-      </p:sp>
-      <p:pic>
-        <p:nvPicPr>
-          <p:cNvPr id="5" name="Picture 4" descr="lab2-analyzer-load.jpg"/>
-          <p:cNvPicPr>
-            <a:picLocks noChangeAspect="1"/>
-          </p:cNvPicPr>
-          <p:nvPr/>
-        </p:nvPicPr>
-        <p:blipFill>
-          <a:blip r:embed="rId2"/>
-          <a:stretch>
-            <a:fillRect/>
-          </a:stretch>
-        </p:blipFill>
-        <p:spPr>
-          <a:xfrm>
-            <a:off x="457200" y="1371600"/>
-            <a:ext cx="3749039" cy="4389120"/>
-          </a:xfrm>
-          <a:prstGeom prst="rect">
-            <a:avLst/>
-          </a:prstGeom>
-        </p:spPr>
-      </p:pic>
-      <p:pic>
-        <p:nvPicPr>
-          <p:cNvPr id="6" name="Picture 5" descr="lab2-analyzer-tracking.jpg"/>
-          <p:cNvPicPr>
-            <a:picLocks noChangeAspect="1"/>
-          </p:cNvPicPr>
-          <p:nvPr/>
-        </p:nvPicPr>
-        <p:blipFill>
-          <a:blip r:embed="rId3"/>
-          <a:stretch>
-            <a:fillRect/>
-          </a:stretch>
-        </p:blipFill>
-        <p:spPr>
-          <a:xfrm>
-            <a:off x="4389120" y="1371600"/>
-            <a:ext cx="3749039" cy="4389120"/>
-          </a:xfrm>
-          <a:prstGeom prst="rect">
-            <a:avLst/>
-          </a:prstGeom>
-        </p:spPr>
-      </p:pic>
-      <p:sp>
-        <p:nvSpPr>
-          <p:cNvPr id="7" name="TextBox 6"/>
-          <p:cNvSpPr txBox="1"/>
-          <p:nvPr/>
-        </p:nvSpPr>
-        <p:spPr>
-          <a:xfrm>
-            <a:off x="8366760" y="1600200"/>
-            <a:ext cx="3383280" cy="3931920"/>
+              <a:t>From coordinates to a signed angle</a:t>
+            </a:r>
+          </a:p>
+        </p:txBody>
+      </p:sp>
+      <p:sp>
+        <p:nvSpPr>
+          <p:cNvPr id="5" name="TextBox 4"/>
+          <p:cNvSpPr txBox="1"/>
+          <p:nvPr/>
+        </p:nvSpPr>
+        <p:spPr>
+          <a:xfrm>
+            <a:off x="640080" y="1554480"/>
+            <a:ext cx="10972800" cy="640080"/>
+          </a:xfrm>
+          <a:prstGeom prst="rect">
+            <a:avLst/>
+          </a:prstGeom>
+          <a:noFill/>
+        </p:spPr>
+        <p:txBody>
+          <a:bodyPr wrap="square">
+            <a:spAutoFit/>
+          </a:bodyPr>
+          <a:lstStyle/>
+          <a:p>
+            <a:pPr algn="ctr">
+              <a:defRPr sz="3000" b="1">
+                <a:solidFill>
+                  <a:srgbClr val="881C1C"/>
+                </a:solidFill>
+                <a:latin typeface="Aptos"/>
+              </a:defRPr>
+            </a:pPr>
+            <a:r>
+              <a:t>theta(t) = atan2( xb - xp,  yb - yp )</a:t>
+            </a:r>
+          </a:p>
+        </p:txBody>
+      </p:sp>
+      <p:sp>
+        <p:nvSpPr>
+          <p:cNvPr id="6" name="TextBox 5"/>
+          <p:cNvSpPr txBox="1"/>
+          <p:nvPr/>
+        </p:nvSpPr>
+        <p:spPr>
+          <a:xfrm>
+            <a:off x="868680" y="2880360"/>
+            <a:ext cx="10058400" cy="2286000"/>
           </a:xfrm>
           <a:prstGeom prst="rect">
             <a:avLst/>
@@ -3999,15 +4000,15 @@
               <a:spcAft>
                 <a:spcPts val="1100"/>
               </a:spcAft>
-              <a:defRPr sz="1800">
-                <a:solidFill>
-                  <a:srgbClr val="161616"/>
-                </a:solidFill>
-                <a:latin typeface="Aptos"/>
-              </a:defRPr>
-            </a:pPr>
-            <a:r>
-              <a:t>Select Single pendulum.</a:t>
+              <a:defRPr sz="2100">
+                <a:solidFill>
+                  <a:srgbClr val="161616"/>
+                </a:solidFill>
+                <a:latin typeface="Aptos"/>
+              </a:defRPr>
+            </a:pPr>
+            <a:r>
+              <a:t>For image coordinates, x points right and y points down.</a:t>
             </a:r>
           </a:p>
           <a:p>
@@ -4015,15 +4016,15 @@
               <a:spcAft>
                 <a:spcPts val="1100"/>
               </a:spcAft>
-              <a:defRPr sz="1800">
-                <a:solidFill>
-                  <a:srgbClr val="161616"/>
-                </a:solidFill>
-                <a:latin typeface="Aptos"/>
-              </a:defRPr>
-            </a:pPr>
-            <a:r>
-              <a:t>Enter actual camera frame rate.</a:t>
+              <a:defRPr sz="2100">
+                <a:solidFill>
+                  <a:srgbClr val="161616"/>
+                </a:solidFill>
+                <a:latin typeface="Aptos"/>
+              </a:defRPr>
+            </a:pPr>
+            <a:r>
+              <a:t>The formula gives theta = 0 when the bob is directly below the pivot.</a:t>
             </a:r>
           </a:p>
           <a:p>
@@ -4031,15 +4032,15 @@
               <a:spcAft>
                 <a:spcPts val="1100"/>
               </a:spcAft>
-              <a:defRPr sz="1800">
-                <a:solidFill>
-                  <a:srgbClr val="161616"/>
-                </a:solidFill>
-                <a:latin typeface="Aptos"/>
-              </a:defRPr>
-            </a:pPr>
-            <a:r>
-              <a:t>Calibrate, select pivot and bob, then Quick Review.</a:t>
+              <a:defRPr sz="2100">
+                <a:solidFill>
+                  <a:srgbClr val="161616"/>
+                </a:solidFill>
+                <a:latin typeface="Aptos"/>
+              </a:defRPr>
+            </a:pPr>
+            <a:r>
+              <a:t>Verify zero and sign using one known frame before batch analysis.</a:t>
             </a:r>
           </a:p>
           <a:p>
@@ -4047,15 +4048,15 @@
               <a:spcAft>
                 <a:spcPts val="1100"/>
               </a:spcAft>
-              <a:defRPr sz="1800">
-                <a:solidFill>
-                  <a:srgbClr val="161616"/>
-                </a:solidFill>
-                <a:latin typeface="Aptos"/>
-              </a:defRPr>
-            </a:pPr>
-            <a:r>
-              <a:t>Run Analyze All Frames only after marker follows bob.</a:t>
+              <a:defRPr sz="2100">
+                <a:solidFill>
+                  <a:srgbClr val="161616"/>
+                </a:solidFill>
+                <a:latin typeface="Aptos"/>
+              </a:defRPr>
+            </a:pPr>
+            <a:r>
+              <a:t>Use radians for modeling and derivatives.</a:t>
             </a:r>
           </a:p>
         </p:txBody>
@@ -4145,7 +4146,7 @@
               </a:defRPr>
             </a:pPr>
             <a:r>
-              <a:t>25-27 min</a:t>
+              <a:t>25-28 min</a:t>
             </a:r>
           </a:p>
         </p:txBody>
@@ -4181,57 +4182,69 @@
               </a:defRPr>
             </a:pPr>
             <a:r>
-              <a:t>Why frame rate belongs in report</a:t>
-            </a:r>
-          </a:p>
-        </p:txBody>
-      </p:sp>
-      <p:sp>
-        <p:nvSpPr>
-          <p:cNvPr id="5" name="TextBox 4"/>
-          <p:cNvSpPr txBox="1"/>
-          <p:nvPr/>
-        </p:nvSpPr>
-        <p:spPr>
-          <a:xfrm>
-            <a:off x="685800" y="1554480"/>
-            <a:ext cx="10789920" cy="594360"/>
-          </a:xfrm>
-          <a:prstGeom prst="rect">
-            <a:avLst/>
-          </a:prstGeom>
-          <a:noFill/>
-        </p:spPr>
-        <p:txBody>
-          <a:bodyPr wrap="square">
-            <a:spAutoFit/>
-          </a:bodyPr>
-          <a:lstStyle/>
-          <a:p>
-            <a:pPr algn="ctr">
-              <a:defRPr sz="2700" b="1">
-                <a:solidFill>
-                  <a:srgbClr val="881C1C"/>
-                </a:solidFill>
-                <a:latin typeface="Aptos"/>
-              </a:defRPr>
-            </a:pPr>
-            <a:r>
-              <a:t>At 1000 frames/s: Nyquist frequency = 500 Hz</a:t>
-            </a:r>
-          </a:p>
-        </p:txBody>
-      </p:sp>
-      <p:sp>
-        <p:nvSpPr>
-          <p:cNvPr id="6" name="TextBox 5"/>
-          <p:cNvSpPr txBox="1"/>
-          <p:nvPr/>
-        </p:nvSpPr>
-        <p:spPr>
-          <a:xfrm>
-            <a:off x="868680" y="2788920"/>
-            <a:ext cx="10058400" cy="2103120"/>
+              <a:t>Tracking workflow in MATLAB</a:t>
+            </a:r>
+          </a:p>
+        </p:txBody>
+      </p:sp>
+      <p:pic>
+        <p:nvPicPr>
+          <p:cNvPr id="5" name="Picture 4" descr="lab2-analyzer-load.jpg"/>
+          <p:cNvPicPr>
+            <a:picLocks noChangeAspect="1"/>
+          </p:cNvPicPr>
+          <p:nvPr/>
+        </p:nvPicPr>
+        <p:blipFill>
+          <a:blip r:embed="rId2"/>
+          <a:stretch>
+            <a:fillRect/>
+          </a:stretch>
+        </p:blipFill>
+        <p:spPr>
+          <a:xfrm>
+            <a:off x="457200" y="1371600"/>
+            <a:ext cx="3749039" cy="4389120"/>
+          </a:xfrm>
+          <a:prstGeom prst="rect">
+            <a:avLst/>
+          </a:prstGeom>
+        </p:spPr>
+      </p:pic>
+      <p:pic>
+        <p:nvPicPr>
+          <p:cNvPr id="6" name="Picture 5" descr="lab2-analyzer-tracking.jpg"/>
+          <p:cNvPicPr>
+            <a:picLocks noChangeAspect="1"/>
+          </p:cNvPicPr>
+          <p:nvPr/>
+        </p:nvPicPr>
+        <p:blipFill>
+          <a:blip r:embed="rId3"/>
+          <a:stretch>
+            <a:fillRect/>
+          </a:stretch>
+        </p:blipFill>
+        <p:spPr>
+          <a:xfrm>
+            <a:off x="4389120" y="1371600"/>
+            <a:ext cx="3749039" cy="4389120"/>
+          </a:xfrm>
+          <a:prstGeom prst="rect">
+            <a:avLst/>
+          </a:prstGeom>
+        </p:spPr>
+      </p:pic>
+      <p:sp>
+        <p:nvSpPr>
+          <p:cNvPr id="7" name="TextBox 6"/>
+          <p:cNvSpPr txBox="1"/>
+          <p:nvPr/>
+        </p:nvSpPr>
+        <p:spPr>
+          <a:xfrm>
+            <a:off x="8366760" y="1600200"/>
+            <a:ext cx="3383280" cy="3931920"/>
           </a:xfrm>
           <a:prstGeom prst="rect">
             <a:avLst/>
@@ -4248,15 +4261,15 @@
               <a:spcAft>
                 <a:spcPts val="1100"/>
               </a:spcAft>
-              <a:defRPr sz="2100">
-                <a:solidFill>
-                  <a:srgbClr val="161616"/>
-                </a:solidFill>
-                <a:latin typeface="Aptos"/>
-              </a:defRPr>
-            </a:pPr>
-            <a:r>
-              <a:t>For L = 0.82 m, one small-angle period has about 1800 frames.</a:t>
+              <a:defRPr sz="1800">
+                <a:solidFill>
+                  <a:srgbClr val="161616"/>
+                </a:solidFill>
+                <a:latin typeface="Aptos"/>
+              </a:defRPr>
+            </a:pPr>
+            <a:r>
+              <a:t>Select Single pendulum.</a:t>
             </a:r>
           </a:p>
           <a:p>
@@ -4264,15 +4277,15 @@
               <a:spcAft>
                 <a:spcPts val="1100"/>
               </a:spcAft>
-              <a:defRPr sz="2100">
-                <a:solidFill>
-                  <a:srgbClr val="161616"/>
-                </a:solidFill>
-                <a:latin typeface="Aptos"/>
-              </a:defRPr>
-            </a:pPr>
-            <a:r>
-              <a:t>Dense frames support time histories and derivatives.</a:t>
+              <a:defRPr sz="1800">
+                <a:solidFill>
+                  <a:srgbClr val="161616"/>
+                </a:solidFill>
+                <a:latin typeface="Aptos"/>
+              </a:defRPr>
+            </a:pPr>
+            <a:r>
+              <a:t>Enter actual camera frame rate.</a:t>
             </a:r>
           </a:p>
           <a:p>
@@ -4280,15 +4293,31 @@
               <a:spcAft>
                 <a:spcPts val="1100"/>
               </a:spcAft>
-              <a:defRPr sz="2100">
-                <a:solidFill>
-                  <a:srgbClr val="161616"/>
-                </a:solidFill>
-                <a:latin typeface="Aptos"/>
-              </a:defRPr>
-            </a:pPr>
-            <a:r>
-              <a:t>Wrong frame rate gives wrong time, frequency, and angular velocity.</a:t>
+              <a:defRPr sz="1800">
+                <a:solidFill>
+                  <a:srgbClr val="161616"/>
+                </a:solidFill>
+                <a:latin typeface="Aptos"/>
+              </a:defRPr>
+            </a:pPr>
+            <a:r>
+              <a:t>Calibrate, select pivot and bob, then Quick Review.</a:t>
+            </a:r>
+          </a:p>
+          <a:p>
+            <a:pPr>
+              <a:spcAft>
+                <a:spcPts val="1100"/>
+              </a:spcAft>
+              <a:defRPr sz="1800">
+                <a:solidFill>
+                  <a:srgbClr val="161616"/>
+                </a:solidFill>
+                <a:latin typeface="Aptos"/>
+              </a:defRPr>
+            </a:pPr>
+            <a:r>
+              <a:t>Run Analyze All Frames only after marker follows bob.</a:t>
             </a:r>
           </a:p>
         </p:txBody>
@@ -4378,7 +4407,7 @@
               </a:defRPr>
             </a:pPr>
             <a:r>
-              <a:t>27-29 min</a:t>
+              <a:t>28-30 min</a:t>
             </a:r>
           </a:p>
         </p:txBody>
@@ -4414,7 +4443,7 @@
               </a:defRPr>
             </a:pPr>
             <a:r>
-              <a:t>Angular velocity and noise</a:t>
+              <a:t>Why frame rate belongs in report</a:t>
             </a:r>
           </a:p>
         </p:txBody>
@@ -4442,7 +4471,7 @@
           <a:lstStyle/>
           <a:p>
             <a:pPr algn="ctr">
-              <a:defRPr sz="3000" b="1">
+              <a:defRPr sz="2700" b="1">
                 <a:solidFill>
                   <a:srgbClr val="881C1C"/>
                 </a:solidFill>
@@ -4450,7 +4479,7 @@
               </a:defRPr>
             </a:pPr>
             <a:r>
-              <a:t>omega(t) = d theta(t) / dt</a:t>
+              <a:t>At 1000 frames/s: Nyquist frequency = 500 Hz</a:t>
             </a:r>
           </a:p>
         </p:txBody>
@@ -4463,8 +4492,8 @@
         </p:nvSpPr>
         <p:spPr>
           <a:xfrm>
-            <a:off x="868680" y="2834640"/>
-            <a:ext cx="10058400" cy="2286000"/>
+            <a:off x="868680" y="2788920"/>
+            <a:ext cx="10058400" cy="2103120"/>
           </a:xfrm>
           <a:prstGeom prst="rect">
             <a:avLst/>
@@ -4489,7 +4518,7 @@
               </a:defRPr>
             </a:pPr>
             <a:r>
-              <a:t>Differentiation magnifies frame-to-frame error.</a:t>
+              <a:t>For l = 0.82 m, one cycle contains roughly 1800 frames.</a:t>
             </a:r>
           </a:p>
           <a:p>
@@ -4505,7 +4534,7 @@
               </a:defRPr>
             </a:pPr>
             <a:r>
-              <a:t>Inspect theta(t) before interpreting omega(t).</a:t>
+              <a:t>The rate greatly exceeds the Nyquist minimum for the pendulum.</a:t>
             </a:r>
           </a:p>
           <a:p>
@@ -4521,23 +4550,7 @@
               </a:defRPr>
             </a:pPr>
             <a:r>
-              <a:t>State smoothing method and show it does not hide tracking problem.</a:t>
-            </a:r>
-          </a:p>
-          <a:p>
-            <a:pPr>
-              <a:spcAft>
-                <a:spcPts val="1100"/>
-              </a:spcAft>
-              <a:defRPr sz="2100">
-                <a:solidFill>
-                  <a:srgbClr val="161616"/>
-                </a:solidFill>
-                <a:latin typeface="Aptos"/>
-              </a:defRPr>
-            </a:pPr>
-            <a:r>
-              <a:t>Maximum speed occurs near bottom.</a:t>
+              <a:t>Wrong frame rate gives wrong time, frequency, and angular velocity.</a:t>
             </a:r>
           </a:p>
         </p:txBody>
@@ -4627,7 +4640,7 @@
               </a:defRPr>
             </a:pPr>
             <a:r>
-              <a:t>29-31 min</a:t>
+              <a:t>30-32 min</a:t>
             </a:r>
           </a:p>
         </p:txBody>
@@ -4663,7 +4676,7 @@
               </a:defRPr>
             </a:pPr>
             <a:r>
-              <a:t>Period from time history and spectrum</a:t>
+              <a:t>Angular velocity and noise</a:t>
             </a:r>
           </a:p>
         </p:txBody>
@@ -4676,8 +4689,44 @@
         </p:nvSpPr>
         <p:spPr>
           <a:xfrm>
-            <a:off x="640080" y="1508760"/>
-            <a:ext cx="5486400" cy="4389120"/>
+            <a:off x="685800" y="1554480"/>
+            <a:ext cx="10789920" cy="594360"/>
+          </a:xfrm>
+          <a:prstGeom prst="rect">
+            <a:avLst/>
+          </a:prstGeom>
+          <a:noFill/>
+        </p:spPr>
+        <p:txBody>
+          <a:bodyPr wrap="square">
+            <a:spAutoFit/>
+          </a:bodyPr>
+          <a:lstStyle/>
+          <a:p>
+            <a:pPr algn="ctr">
+              <a:defRPr sz="3000" b="1">
+                <a:solidFill>
+                  <a:srgbClr val="881C1C"/>
+                </a:solidFill>
+                <a:latin typeface="Aptos"/>
+              </a:defRPr>
+            </a:pPr>
+            <a:r>
+              <a:t>omega(t) = d theta(t) / dt</a:t>
+            </a:r>
+          </a:p>
+        </p:txBody>
+      </p:sp>
+      <p:sp>
+        <p:nvSpPr>
+          <p:cNvPr id="6" name="TextBox 5"/>
+          <p:cNvSpPr txBox="1"/>
+          <p:nvPr/>
+        </p:nvSpPr>
+        <p:spPr>
+          <a:xfrm>
+            <a:off x="868680" y="2834640"/>
+            <a:ext cx="10058400" cy="2286000"/>
           </a:xfrm>
           <a:prstGeom prst="rect">
             <a:avLst/>
@@ -4702,7 +4751,7 @@
               </a:defRPr>
             </a:pPr>
             <a:r>
-              <a:t>Time domain: measure time between same-direction peaks.</a:t>
+              <a:t>Differentiation magnifies frame-to-frame error.</a:t>
             </a:r>
           </a:p>
           <a:p>
@@ -4718,7 +4767,7 @@
               </a:defRPr>
             </a:pPr>
             <a:r>
-              <a:t>Frequency domain: remove mean, compute FFT, identify dominant peak.</a:t>
+              <a:t>Inspect theta(t) before interpreting omega(t).</a:t>
             </a:r>
           </a:p>
           <a:p>
@@ -4734,7 +4783,7 @@
               </a:defRPr>
             </a:pPr>
             <a:r>
-              <a:t>Bin spacing Delta f = 1/T_record.</a:t>
+              <a:t>State smoothing method and show it does not hide tracking problems.</a:t>
             </a:r>
           </a:p>
           <a:p>
@@ -4750,79 +4799,7 @@
               </a:defRPr>
             </a:pPr>
             <a:r>
-              <a:t>Time-domain period and spectral frequency should agree.</a:t>
-            </a:r>
-          </a:p>
-        </p:txBody>
-      </p:sp>
-      <p:sp>
-        <p:nvSpPr>
-          <p:cNvPr id="6" name="TextBox 5"/>
-          <p:cNvSpPr txBox="1"/>
-          <p:nvPr/>
-        </p:nvSpPr>
-        <p:spPr>
-          <a:xfrm>
-            <a:off x="6492240" y="2011680"/>
-            <a:ext cx="4663440" cy="731520"/>
-          </a:xfrm>
-          <a:prstGeom prst="rect">
-            <a:avLst/>
-          </a:prstGeom>
-          <a:noFill/>
-        </p:spPr>
-        <p:txBody>
-          <a:bodyPr wrap="square">
-            <a:spAutoFit/>
-          </a:bodyPr>
-          <a:lstStyle/>
-          <a:p>
-            <a:pPr algn="ctr">
-              <a:defRPr sz="3400" b="1">
-                <a:solidFill>
-                  <a:srgbClr val="881C1C"/>
-                </a:solidFill>
-                <a:latin typeface="Aptos"/>
-              </a:defRPr>
-            </a:pPr>
-            <a:r>
-              <a:t>f = 1/T</a:t>
-            </a:r>
-          </a:p>
-        </p:txBody>
-      </p:sp>
-      <p:sp>
-        <p:nvSpPr>
-          <p:cNvPr id="7" name="TextBox 6"/>
-          <p:cNvSpPr txBox="1"/>
-          <p:nvPr/>
-        </p:nvSpPr>
-        <p:spPr>
-          <a:xfrm>
-            <a:off x="6492240" y="3474720"/>
-            <a:ext cx="4663440" cy="731520"/>
-          </a:xfrm>
-          <a:prstGeom prst="rect">
-            <a:avLst/>
-          </a:prstGeom>
-          <a:noFill/>
-        </p:spPr>
-        <p:txBody>
-          <a:bodyPr wrap="square">
-            <a:spAutoFit/>
-          </a:bodyPr>
-          <a:lstStyle/>
-          <a:p>
-            <a:pPr algn="ctr">
-              <a:defRPr sz="2600" b="1">
-                <a:solidFill>
-                  <a:srgbClr val="161616"/>
-                </a:solidFill>
-                <a:latin typeface="Aptos"/>
-              </a:defRPr>
-            </a:pPr>
-            <a:r>
-              <a:t>Delta f = 1/T_record</a:t>
+              <a:t>Maximum speed occurs near the bottom.</a:t>
             </a:r>
           </a:p>
         </p:txBody>
@@ -4912,7 +4889,7 @@
               </a:defRPr>
             </a:pPr>
             <a:r>
-              <a:t>31-33 min</a:t>
+              <a:t>32-34 min</a:t>
             </a:r>
           </a:p>
         </p:txBody>
@@ -4948,7 +4925,7 @@
               </a:defRPr>
             </a:pPr>
             <a:r>
-              <a:t>Lab 2 trial matrix</a:t>
+              <a:t>Period from time history and spectrum</a:t>
             </a:r>
           </a:p>
         </p:txBody>
@@ -4961,8 +4938,8 @@
         </p:nvSpPr>
         <p:spPr>
           <a:xfrm>
-            <a:off x="685800" y="1508760"/>
-            <a:ext cx="10698480" cy="4480560"/>
+            <a:off x="640080" y="1508760"/>
+            <a:ext cx="5486400" cy="4389120"/>
           </a:xfrm>
           <a:prstGeom prst="rect">
             <a:avLst/>
@@ -4987,7 +4964,7 @@
               </a:defRPr>
             </a:pPr>
             <a:r>
-              <a:t>Trial A: theta0 below 10 degrees. Closest test of small-angle theory.</a:t>
+              <a:t>Time domain: measure several cycles between same-direction peaks.</a:t>
             </a:r>
           </a:p>
           <a:p>
@@ -5003,7 +4980,7 @@
               </a:defRPr>
             </a:pPr>
             <a:r>
-              <a:t>Trial B: theta0 from 10 to 90 degrees. Observe period change.</a:t>
+              <a:t>Frequency domain: remove mean, compute FFT, identify dominant peak.</a:t>
             </a:r>
           </a:p>
           <a:p>
@@ -5019,7 +4996,7 @@
               </a:defRPr>
             </a:pPr>
             <a:r>
-              <a:t>Trial C: theta0 from 90 to 180 degrees. Expect strong nonlinearity; keep bob in frame.</a:t>
+              <a:t>Bin spacing Delta f = 1/T_record.</a:t>
             </a:r>
           </a:p>
           <a:p>
@@ -5035,7 +5012,79 @@
               </a:defRPr>
             </a:pPr>
             <a:r>
-              <a:t>All releases start from rest. Record theta0 from protractor.</a:t>
+              <a:t>Time-domain period and spectral frequency should agree within resolution.</a:t>
+            </a:r>
+          </a:p>
+        </p:txBody>
+      </p:sp>
+      <p:sp>
+        <p:nvSpPr>
+          <p:cNvPr id="6" name="TextBox 5"/>
+          <p:cNvSpPr txBox="1"/>
+          <p:nvPr/>
+        </p:nvSpPr>
+        <p:spPr>
+          <a:xfrm>
+            <a:off x="6492240" y="2011680"/>
+            <a:ext cx="4663440" cy="731520"/>
+          </a:xfrm>
+          <a:prstGeom prst="rect">
+            <a:avLst/>
+          </a:prstGeom>
+          <a:noFill/>
+        </p:spPr>
+        <p:txBody>
+          <a:bodyPr wrap="square">
+            <a:spAutoFit/>
+          </a:bodyPr>
+          <a:lstStyle/>
+          <a:p>
+            <a:pPr algn="ctr">
+              <a:defRPr sz="2500" b="1">
+                <a:solidFill>
+                  <a:srgbClr val="881C1C"/>
+                </a:solidFill>
+                <a:latin typeface="Aptos"/>
+              </a:defRPr>
+            </a:pPr>
+            <a:r>
+              <a:t>f = number of cycles / elapsed time</a:t>
+            </a:r>
+          </a:p>
+        </p:txBody>
+      </p:sp>
+      <p:sp>
+        <p:nvSpPr>
+          <p:cNvPr id="7" name="TextBox 6"/>
+          <p:cNvSpPr txBox="1"/>
+          <p:nvPr/>
+        </p:nvSpPr>
+        <p:spPr>
+          <a:xfrm>
+            <a:off x="6492240" y="3474720"/>
+            <a:ext cx="4663440" cy="731520"/>
+          </a:xfrm>
+          <a:prstGeom prst="rect">
+            <a:avLst/>
+          </a:prstGeom>
+          <a:noFill/>
+        </p:spPr>
+        <p:txBody>
+          <a:bodyPr wrap="square">
+            <a:spAutoFit/>
+          </a:bodyPr>
+          <a:lstStyle/>
+          <a:p>
+            <a:pPr algn="ctr">
+              <a:defRPr sz="2600" b="1">
+                <a:solidFill>
+                  <a:srgbClr val="161616"/>
+                </a:solidFill>
+                <a:latin typeface="Aptos"/>
+              </a:defRPr>
+            </a:pPr>
+            <a:r>
+              <a:t>Delta f = 1/T_record</a:t>
             </a:r>
           </a:p>
         </p:txBody>
@@ -5125,7 +5174,7 @@
               </a:defRPr>
             </a:pPr>
             <a:r>
-              <a:t>33-35 min</a:t>
+              <a:t>34-36 min</a:t>
             </a:r>
           </a:p>
         </p:txBody>
@@ -5161,7 +5210,7 @@
               </a:defRPr>
             </a:pPr>
             <a:r>
-              <a:t>Data quality before accepting video</a:t>
+              <a:t>Lab 2 trial matrix</a:t>
             </a:r>
           </a:p>
         </p:txBody>
@@ -5200,7 +5249,7 @@
               </a:defRPr>
             </a:pPr>
             <a:r>
-              <a:t>Bob remains in frame.</a:t>
+              <a:t>Trial A: theta0 below 10 degrees. Closest test of small-angle theory.</a:t>
             </a:r>
           </a:p>
           <a:p>
@@ -5216,7 +5265,7 @@
               </a:defRPr>
             </a:pPr>
             <a:r>
-              <a:t>Bob edge and center are visible without glare.</a:t>
+              <a:t>Trial B: theta0 from 10 to 90 degrees. Observe period change.</a:t>
             </a:r>
           </a:p>
           <a:p>
@@ -5232,7 +5281,7 @@
               </a:defRPr>
             </a:pPr>
             <a:r>
-              <a:t>Pivot and calibration marks are visible.</a:t>
+              <a:t>Trial C: theta0 from 90 to 180 degrees. Expect strong nonlinearity; keep bob in frame.</a:t>
             </a:r>
           </a:p>
           <a:p>
@@ -5248,39 +5297,7 @@
               </a:defRPr>
             </a:pPr>
             <a:r>
-              <a:t>Release begins from rest.</a:t>
-            </a:r>
-          </a:p>
-          <a:p>
-            <a:pPr>
-              <a:spcAft>
-                <a:spcPts val="1100"/>
-              </a:spcAft>
-              <a:defRPr sz="2100">
-                <a:solidFill>
-                  <a:srgbClr val="161616"/>
-                </a:solidFill>
-                <a:latin typeface="Aptos"/>
-              </a:defRPr>
-            </a:pPr>
-            <a:r>
-              <a:t>Quick Review follows bob for nearly all frames.</a:t>
-            </a:r>
-          </a:p>
-          <a:p>
-            <a:pPr>
-              <a:spcAft>
-                <a:spcPts val="1100"/>
-              </a:spcAft>
-              <a:defRPr sz="2100">
-                <a:solidFill>
-                  <a:srgbClr val="161616"/>
-                </a:solidFill>
-                <a:latin typeface="Aptos"/>
-              </a:defRPr>
-            </a:pPr>
-            <a:r>
-              <a:t>Notes include file name, angle, frame rate, calibration distance.</a:t>
+              <a:t>All releases start from rest. Record theta0 from protractor.</a:t>
             </a:r>
           </a:p>
         </p:txBody>
@@ -5370,7 +5387,7 @@
               </a:defRPr>
             </a:pPr>
             <a:r>
-              <a:t>35-38 min</a:t>
+              <a:t>36-38 min</a:t>
             </a:r>
           </a:p>
         </p:txBody>
@@ -5406,7 +5423,7 @@
               </a:defRPr>
             </a:pPr>
             <a:r>
-              <a:t>Pre-Lab 2: what you submit</a:t>
+              <a:t>Data quality before accepting video</a:t>
             </a:r>
           </a:p>
         </p:txBody>
@@ -5445,7 +5462,7 @@
               </a:defRPr>
             </a:pPr>
             <a:r>
-              <a:t>One Word or PDF before laboratory section.</a:t>
+              <a:t>Bob remains in frame.</a:t>
             </a:r>
           </a:p>
           <a:p>
@@ -5461,7 +5478,7 @@
               </a:defRPr>
             </a:pPr>
             <a:r>
-              <a:t>Task 1: calculate omega_n, f_n, T0.</a:t>
+              <a:t>Bob edge and center are visible without glare.</a:t>
             </a:r>
           </a:p>
           <a:p>
@@ -5477,7 +5494,7 @@
               </a:defRPr>
             </a:pPr>
             <a:r>
-              <a:t>Task 2: predict behavior before simulation.</a:t>
+              <a:t>Pivot and calibration marks are visible.</a:t>
             </a:r>
           </a:p>
           <a:p>
@@ -5493,7 +5510,7 @@
               </a:defRPr>
             </a:pPr>
             <a:r>
-              <a:t>Task 3: estimate periods and explain finite-angle behavior.</a:t>
+              <a:t>Release begins from rest.</a:t>
             </a:r>
           </a:p>
           <a:p>
@@ -5509,7 +5526,23 @@
               </a:defRPr>
             </a:pPr>
             <a:r>
-              <a:t>Tasks 4-6: explain tracking, frame rate, and lab plan.</a:t>
+              <a:t>Quick Review follows bob for nearly all frames.</a:t>
+            </a:r>
+          </a:p>
+          <a:p>
+            <a:pPr>
+              <a:spcAft>
+                <a:spcPts val="1100"/>
+              </a:spcAft>
+              <a:defRPr sz="2100">
+                <a:solidFill>
+                  <a:srgbClr val="161616"/>
+                </a:solidFill>
+                <a:latin typeface="Aptos"/>
+              </a:defRPr>
+            </a:pPr>
+            <a:r>
+              <a:t>Notes include file name, angle, frame rate, and calibration distance.</a:t>
             </a:r>
           </a:p>
         </p:txBody>
@@ -5635,7 +5668,7 @@
               </a:defRPr>
             </a:pPr>
             <a:r>
-              <a:t>Evidence for combined Lab 2 and 3 report</a:t>
+              <a:t>Pre-Lab 2: what you submit</a:t>
             </a:r>
           </a:p>
         </p:txBody>
@@ -5674,7 +5707,7 @@
               </a:defRPr>
             </a:pPr>
             <a:r>
-              <a:t>Table: L, mass, theta0, predicted and measured frequency.</a:t>
+              <a:t>One Word or PDF before laboratory section.</a:t>
             </a:r>
           </a:p>
           <a:p>
@@ -5690,7 +5723,7 @@
               </a:defRPr>
             </a:pPr>
             <a:r>
-              <a:t>Plots: theta(t) and omega(t) with units.</a:t>
+              <a:t>Task 1: compare point-mass and compound-pendulum frequencies.</a:t>
             </a:r>
           </a:p>
           <a:p>
@@ -5706,7 +5739,7 @@
               </a:defRPr>
             </a:pPr>
             <a:r>
-              <a:t>Spectrum: meaningful range and stated bin spacing.</a:t>
+              <a:t>Task 2: predict behavior before running the supplied simulation.</a:t>
             </a:r>
           </a:p>
           <a:p>
@@ -5722,7 +5755,23 @@
               </a:defRPr>
             </a:pPr>
             <a:r>
-              <a:t>Discussion: distinguish finite-angle limitation from tracking error and damping.</a:t>
+              <a:t>Task 3: estimate periods and explain finite-angle behavior.</a:t>
+            </a:r>
+          </a:p>
+          <a:p>
+            <a:pPr>
+              <a:spcAft>
+                <a:spcPts val="1100"/>
+              </a:spcAft>
+              <a:defRPr sz="2100">
+                <a:solidFill>
+                  <a:srgbClr val="161616"/>
+                </a:solidFill>
+                <a:latin typeface="Aptos"/>
+              </a:defRPr>
+            </a:pPr>
+            <a:r>
+              <a:t>Tasks 4-6: explain coordinates, frame rate, and the laboratory plan.</a:t>
             </a:r>
           </a:p>
         </p:txBody>
@@ -6049,7 +6098,7 @@
               </a:defRPr>
             </a:pPr>
             <a:r>
-              <a:t>41-45 min</a:t>
+              <a:t>41-44 min</a:t>
             </a:r>
           </a:p>
         </p:txBody>
@@ -6085,7 +6134,7 @@
               </a:defRPr>
             </a:pPr>
             <a:r>
-              <a:t>In-class prediction</a:t>
+              <a:t>Evidence for combined Lab 2 and 3 report</a:t>
             </a:r>
           </a:p>
         </p:txBody>
@@ -6098,44 +6147,8 @@
         </p:nvSpPr>
         <p:spPr>
           <a:xfrm>
-            <a:off x="777240" y="1508760"/>
-            <a:ext cx="10698480" cy="548640"/>
-          </a:xfrm>
-          <a:prstGeom prst="rect">
-            <a:avLst/>
-          </a:prstGeom>
-          <a:noFill/>
-        </p:spPr>
-        <p:txBody>
-          <a:bodyPr wrap="square">
-            <a:spAutoFit/>
-          </a:bodyPr>
-          <a:lstStyle/>
-          <a:p>
-            <a:pPr algn="ctr">
-              <a:defRPr sz="2600" b="1">
-                <a:solidFill>
-                  <a:srgbClr val="881C1C"/>
-                </a:solidFill>
-                <a:latin typeface="Aptos"/>
-              </a:defRPr>
-            </a:pPr>
-            <a:r>
-              <a:t>For L = 0.82 m, which release has longest period?</a:t>
-            </a:r>
-          </a:p>
-        </p:txBody>
-      </p:sp>
-      <p:sp>
-        <p:nvSpPr>
-          <p:cNvPr id="6" name="TextBox 5"/>
-          <p:cNvSpPr txBox="1"/>
-          <p:nvPr/>
-        </p:nvSpPr>
-        <p:spPr>
-          <a:xfrm>
-            <a:off x="2011680" y="2788920"/>
-            <a:ext cx="8138160" cy="2103120"/>
+            <a:off x="685800" y="1508760"/>
+            <a:ext cx="10698480" cy="4480560"/>
           </a:xfrm>
           <a:prstGeom prst="rect">
             <a:avLst/>
@@ -6152,15 +6165,15 @@
               <a:spcAft>
                 <a:spcPts val="1100"/>
               </a:spcAft>
-              <a:defRPr sz="2400">
-                <a:solidFill>
-                  <a:srgbClr val="161616"/>
-                </a:solidFill>
-                <a:latin typeface="Aptos"/>
-              </a:defRPr>
-            </a:pPr>
-            <a:r>
-              <a:t>A. 8 degrees</a:t>
+              <a:defRPr sz="2100">
+                <a:solidFill>
+                  <a:srgbClr val="161616"/>
+                </a:solidFill>
+                <a:latin typeface="Aptos"/>
+              </a:defRPr>
+            </a:pPr>
+            <a:r>
+              <a:t>Schematic: pivot, l, M, m, theta, and positive direction.</a:t>
             </a:r>
           </a:p>
           <a:p>
@@ -6168,15 +6181,15 @@
               <a:spcAft>
                 <a:spcPts val="1100"/>
               </a:spcAft>
-              <a:defRPr sz="2400">
-                <a:solidFill>
-                  <a:srgbClr val="161616"/>
-                </a:solidFill>
-                <a:latin typeface="Aptos"/>
-              </a:defRPr>
-            </a:pPr>
-            <a:r>
-              <a:t>B. 35 degrees</a:t>
+              <a:defRPr sz="2100">
+                <a:solidFill>
+                  <a:srgbClr val="161616"/>
+                </a:solidFill>
+                <a:latin typeface="Aptos"/>
+              </a:defRPr>
+            </a:pPr>
+            <a:r>
+              <a:t>Table: measured parameters and analytical, nonlinear, time-domain, and FFT frequencies.</a:t>
             </a:r>
           </a:p>
           <a:p>
@@ -6184,15 +6197,15 @@
               <a:spcAft>
                 <a:spcPts val="1100"/>
               </a:spcAft>
-              <a:defRPr sz="2400">
-                <a:solidFill>
-                  <a:srgbClr val="161616"/>
-                </a:solidFill>
-                <a:latin typeface="Aptos"/>
-              </a:defRPr>
-            </a:pPr>
-            <a:r>
-              <a:t>C. 105 degrees</a:t>
+              <a:defRPr sz="2100">
+                <a:solidFill>
+                  <a:srgbClr val="161616"/>
+                </a:solidFill>
+                <a:latin typeface="Aptos"/>
+              </a:defRPr>
+            </a:pPr>
+            <a:r>
+              <a:t>Plots: theta(t), omega(t), and spectra with units.</a:t>
             </a:r>
           </a:p>
           <a:p>
@@ -6200,15 +6213,15 @@
               <a:spcAft>
                 <a:spcPts val="1100"/>
               </a:spcAft>
-              <a:defRPr sz="2400">
-                <a:solidFill>
-                  <a:srgbClr val="161616"/>
-                </a:solidFill>
-                <a:latin typeface="Aptos"/>
-              </a:defRPr>
-            </a:pPr>
-            <a:r>
-              <a:t>Explain using exact sine restoring torque.</a:t>
+              <a:defRPr sz="2100">
+                <a:solidFill>
+                  <a:srgbClr val="161616"/>
+                </a:solidFill>
+                <a:latin typeface="Aptos"/>
+              </a:defRPr>
+            </a:pPr>
+            <a:r>
+              <a:t>Discussion: separate model limitations from measurement errors.</a:t>
             </a:r>
           </a:p>
         </p:txBody>
@@ -6298,7 +6311,7 @@
               </a:defRPr>
             </a:pPr>
             <a:r>
-              <a:t>45-48 min</a:t>
+              <a:t>44-47 min</a:t>
             </a:r>
           </a:p>
         </p:txBody>
@@ -6334,7 +6347,7 @@
               </a:defRPr>
             </a:pPr>
             <a:r>
-              <a:t>Before leaving laboratory</a:t>
+              <a:t>In-class prediction</a:t>
             </a:r>
           </a:p>
         </p:txBody>
@@ -6347,8 +6360,44 @@
         </p:nvSpPr>
         <p:spPr>
           <a:xfrm>
-            <a:off x="685800" y="1508760"/>
-            <a:ext cx="10698480" cy="4480560"/>
+            <a:off x="777240" y="1508760"/>
+            <a:ext cx="10698480" cy="548640"/>
+          </a:xfrm>
+          <a:prstGeom prst="rect">
+            <a:avLst/>
+          </a:prstGeom>
+          <a:noFill/>
+        </p:spPr>
+        <p:txBody>
+          <a:bodyPr wrap="square">
+            <a:spAutoFit/>
+          </a:bodyPr>
+          <a:lstStyle/>
+          <a:p>
+            <a:pPr algn="ctr">
+              <a:defRPr sz="2600" b="1">
+                <a:solidFill>
+                  <a:srgbClr val="881C1C"/>
+                </a:solidFill>
+                <a:latin typeface="Aptos"/>
+              </a:defRPr>
+            </a:pPr>
+            <a:r>
+              <a:t>For the same apparatus, which release has the longest period?</a:t>
+            </a:r>
+          </a:p>
+        </p:txBody>
+      </p:sp>
+      <p:sp>
+        <p:nvSpPr>
+          <p:cNvPr id="6" name="TextBox 5"/>
+          <p:cNvSpPr txBox="1"/>
+          <p:nvPr/>
+        </p:nvSpPr>
+        <p:spPr>
+          <a:xfrm>
+            <a:off x="2011680" y="2788920"/>
+            <a:ext cx="8138160" cy="2103120"/>
           </a:xfrm>
           <a:prstGeom prst="rect">
             <a:avLst/>
@@ -6365,15 +6414,15 @@
               <a:spcAft>
                 <a:spcPts val="1100"/>
               </a:spcAft>
-              <a:defRPr sz="2100">
-                <a:solidFill>
-                  <a:srgbClr val="161616"/>
-                </a:solidFill>
-                <a:latin typeface="Aptos"/>
-              </a:defRPr>
-            </a:pPr>
-            <a:r>
-              <a:t>Save and back up every video and MAT output.</a:t>
+              <a:defRPr sz="2400">
+                <a:solidFill>
+                  <a:srgbClr val="161616"/>
+                </a:solidFill>
+                <a:latin typeface="Aptos"/>
+              </a:defRPr>
+            </a:pPr>
+            <a:r>
+              <a:t>A. 8 degrees</a:t>
             </a:r>
           </a:p>
           <a:p>
@@ -6381,15 +6430,15 @@
               <a:spcAft>
                 <a:spcPts val="1100"/>
               </a:spcAft>
-              <a:defRPr sz="2100">
-                <a:solidFill>
-                  <a:srgbClr val="161616"/>
-                </a:solidFill>
-                <a:latin typeface="Aptos"/>
-              </a:defRPr>
-            </a:pPr>
-            <a:r>
-              <a:t>Verify tracking for every trial.</a:t>
+              <a:defRPr sz="2400">
+                <a:solidFill>
+                  <a:srgbClr val="161616"/>
+                </a:solidFill>
+                <a:latin typeface="Aptos"/>
+              </a:defRPr>
+            </a:pPr>
+            <a:r>
+              <a:t>B. 35 degrees</a:t>
             </a:r>
           </a:p>
           <a:p>
@@ -6397,15 +6446,15 @@
               <a:spcAft>
                 <a:spcPts val="1100"/>
               </a:spcAft>
-              <a:defRPr sz="2100">
-                <a:solidFill>
-                  <a:srgbClr val="161616"/>
-                </a:solidFill>
-                <a:latin typeface="Aptos"/>
-              </a:defRPr>
-            </a:pPr>
-            <a:r>
-              <a:t>Record initial angle, frame rate, calibration distance, length, mass, and file names.</a:t>
+              <a:defRPr sz="2400">
+                <a:solidFill>
+                  <a:srgbClr val="161616"/>
+                </a:solidFill>
+                <a:latin typeface="Aptos"/>
+              </a:defRPr>
+            </a:pPr>
+            <a:r>
+              <a:t>C. 105 degrees</a:t>
             </a:r>
           </a:p>
           <a:p>
@@ -6413,31 +6462,15 @@
               <a:spcAft>
                 <a:spcPts val="1100"/>
               </a:spcAft>
-              <a:defRPr sz="2100">
-                <a:solidFill>
-                  <a:srgbClr val="161616"/>
-                </a:solidFill>
-                <a:latin typeface="Aptos"/>
-              </a:defRPr>
-            </a:pPr>
-            <a:r>
-              <a:t>Check one theta(t) plot and spectrum with GTA.</a:t>
-            </a:r>
-          </a:p>
-          <a:p>
-            <a:pPr>
-              <a:spcAft>
-                <a:spcPts val="1100"/>
-              </a:spcAft>
-              <a:defRPr sz="2100">
-                <a:solidFill>
-                  <a:srgbClr val="161616"/>
-                </a:solidFill>
-                <a:latin typeface="Aptos"/>
-              </a:defRPr>
-            </a:pPr>
-            <a:r>
-              <a:t>Keep raw data for combined report.</a:t>
+              <a:defRPr sz="2400">
+                <a:solidFill>
+                  <a:srgbClr val="161616"/>
+                </a:solidFill>
+                <a:latin typeface="Aptos"/>
+              </a:defRPr>
+            </a:pPr>
+            <a:r>
+              <a:t>Explain using the exact sine restoring torque.</a:t>
             </a:r>
           </a:p>
         </p:txBody>
@@ -6527,7 +6560,7 @@
               </a:defRPr>
             </a:pPr>
             <a:r>
-              <a:t>48-50 min</a:t>
+              <a:t>47-49 min</a:t>
             </a:r>
           </a:p>
         </p:txBody>
@@ -6563,7 +6596,7 @@
               </a:defRPr>
             </a:pPr>
             <a:r>
-              <a:t>Key ideas for Lab 2</a:t>
+              <a:t>Before leaving laboratory</a:t>
             </a:r>
           </a:p>
         </p:txBody>
@@ -6602,7 +6635,7 @@
               </a:defRPr>
             </a:pPr>
             <a:r>
-              <a:t>Camera images become positions; analysis converts positions to angle.</a:t>
+              <a:t>Save and back up every video and MAT output.</a:t>
             </a:r>
           </a:p>
           <a:p>
@@ -6618,7 +6651,7 @@
               </a:defRPr>
             </a:pPr>
             <a:r>
-              <a:t>Small-angle theory has a clear range of validity.</a:t>
+              <a:t>Verify tracking for every trial.</a:t>
             </a:r>
           </a:p>
           <a:p>
@@ -6634,7 +6667,7 @@
               </a:defRPr>
             </a:pPr>
             <a:r>
-              <a:t>Initial angle affects real pendulum period.</a:t>
+              <a:t>Record initial angle, frame rate, calibration distance, l, M, m, and file names.</a:t>
             </a:r>
           </a:p>
           <a:p>
@@ -6650,9 +6683,158 @@
               </a:defRPr>
             </a:pPr>
             <a:r>
-              <a:t>Frame rate and calibration are measurement settings.</a:t>
-            </a:r>
-          </a:p>
+              <a:t>Check one theta(t) plot and one spectrum with the GTA.</a:t>
+            </a:r>
+          </a:p>
+        </p:txBody>
+      </p:sp>
+    </p:spTree>
+  </p:cSld>
+  <p:clrMapOvr>
+    <a:masterClrMapping/>
+  </p:clrMapOvr>
+</p:sld>
+</file>
+
+<file path=ppt/slides/slide23.xml><?xml version="1.0" encoding="utf-8"?>
+<p:sld xmlns:a="http://schemas.openxmlformats.org/drawingml/2006/main" xmlns:p="http://schemas.openxmlformats.org/presentationml/2006/main" xmlns:r="http://schemas.openxmlformats.org/officeDocument/2006/relationships">
+  <p:cSld>
+    <p:spTree>
+      <p:nvGrpSpPr>
+        <p:cNvPr id="1" name=""/>
+        <p:cNvGrpSpPr/>
+        <p:nvPr/>
+      </p:nvGrpSpPr>
+      <p:grpSpPr/>
+      <p:sp>
+        <p:nvSpPr>
+          <p:cNvPr id="2" name="TextBox 1"/>
+          <p:cNvSpPr txBox="1"/>
+          <p:nvPr/>
+        </p:nvSpPr>
+        <p:spPr>
+          <a:xfrm>
+            <a:off x="256032" y="164592"/>
+            <a:ext cx="4114800" cy="274320"/>
+          </a:xfrm>
+          <a:prstGeom prst="rect">
+            <a:avLst/>
+          </a:prstGeom>
+          <a:noFill/>
+        </p:spPr>
+        <p:txBody>
+          <a:bodyPr wrap="square">
+            <a:spAutoFit/>
+          </a:bodyPr>
+          <a:lstStyle/>
+          <a:p>
+            <a:pPr>
+              <a:defRPr sz="1200" b="1">
+                <a:solidFill>
+                  <a:srgbClr val="881C1C"/>
+                </a:solidFill>
+                <a:latin typeface="Aptos"/>
+              </a:defRPr>
+            </a:pPr>
+            <a:r>
+              <a:t>MIE 402  |  ME LAB II</a:t>
+            </a:r>
+          </a:p>
+        </p:txBody>
+      </p:sp>
+      <p:sp>
+        <p:nvSpPr>
+          <p:cNvPr id="3" name="TextBox 2"/>
+          <p:cNvSpPr txBox="1"/>
+          <p:nvPr/>
+        </p:nvSpPr>
+        <p:spPr>
+          <a:xfrm>
+            <a:off x="8869680" y="164592"/>
+            <a:ext cx="2743200" cy="274320"/>
+          </a:xfrm>
+          <a:prstGeom prst="rect">
+            <a:avLst/>
+          </a:prstGeom>
+          <a:noFill/>
+        </p:spPr>
+        <p:txBody>
+          <a:bodyPr wrap="square">
+            <a:spAutoFit/>
+          </a:bodyPr>
+          <a:lstStyle/>
+          <a:p>
+            <a:pPr algn="r">
+              <a:defRPr sz="1200" b="0">
+                <a:solidFill>
+                  <a:srgbClr val="666666"/>
+                </a:solidFill>
+                <a:latin typeface="Aptos"/>
+              </a:defRPr>
+            </a:pPr>
+            <a:r>
+              <a:t>49-50 min</a:t>
+            </a:r>
+          </a:p>
+        </p:txBody>
+      </p:sp>
+      <p:sp>
+        <p:nvSpPr>
+          <p:cNvPr id="4" name="TextBox 3"/>
+          <p:cNvSpPr txBox="1"/>
+          <p:nvPr/>
+        </p:nvSpPr>
+        <p:spPr>
+          <a:xfrm>
+            <a:off x="256032" y="685800"/>
+            <a:ext cx="11338560" cy="594360"/>
+          </a:xfrm>
+          <a:prstGeom prst="rect">
+            <a:avLst/>
+          </a:prstGeom>
+          <a:noFill/>
+        </p:spPr>
+        <p:txBody>
+          <a:bodyPr wrap="square">
+            <a:spAutoFit/>
+          </a:bodyPr>
+          <a:lstStyle/>
+          <a:p>
+            <a:pPr>
+              <a:defRPr sz="2900" b="1">
+                <a:solidFill>
+                  <a:srgbClr val="161616"/>
+                </a:solidFill>
+                <a:latin typeface="Aptos"/>
+              </a:defRPr>
+            </a:pPr>
+            <a:r>
+              <a:t>Key ideas for Lab 2</a:t>
+            </a:r>
+          </a:p>
+        </p:txBody>
+      </p:sp>
+      <p:sp>
+        <p:nvSpPr>
+          <p:cNvPr id="5" name="TextBox 4"/>
+          <p:cNvSpPr txBox="1"/>
+          <p:nvPr/>
+        </p:nvSpPr>
+        <p:spPr>
+          <a:xfrm>
+            <a:off x="685800" y="1508760"/>
+            <a:ext cx="10698480" cy="4480560"/>
+          </a:xfrm>
+          <a:prstGeom prst="rect">
+            <a:avLst/>
+          </a:prstGeom>
+          <a:noFill/>
+        </p:spPr>
+        <p:txBody>
+          <a:bodyPr wrap="square">
+            <a:spAutoFit/>
+          </a:bodyPr>
+          <a:lstStyle/>
           <a:p>
             <a:pPr>
               <a:spcAft>
@@ -6666,7 +6848,55 @@
               </a:defRPr>
             </a:pPr>
             <a:r>
-              <a:t>Compare theory, time history, and spectrum.</a:t>
+              <a:t>The real apparatus is a compound pendulum because the bar has mass.</a:t>
+            </a:r>
+          </a:p>
+          <a:p>
+            <a:pPr>
+              <a:spcAft>
+                <a:spcPts val="1100"/>
+              </a:spcAft>
+              <a:defRPr sz="2100">
+                <a:solidFill>
+                  <a:srgbClr val="161616"/>
+                </a:solidFill>
+                <a:latin typeface="Aptos"/>
+              </a:defRPr>
+            </a:pPr>
+            <a:r>
+              <a:t>Initial angle changes the nonlinear period.</a:t>
+            </a:r>
+          </a:p>
+          <a:p>
+            <a:pPr>
+              <a:spcAft>
+                <a:spcPts val="1100"/>
+              </a:spcAft>
+              <a:defRPr sz="2100">
+                <a:solidFill>
+                  <a:srgbClr val="161616"/>
+                </a:solidFill>
+                <a:latin typeface="Aptos"/>
+              </a:defRPr>
+            </a:pPr>
+            <a:r>
+              <a:t>Camera coordinates require calibration, a fixed pivot, and a verified sign convention.</a:t>
+            </a:r>
+          </a:p>
+          <a:p>
+            <a:pPr>
+              <a:spcAft>
+                <a:spcPts val="1100"/>
+              </a:spcAft>
+              <a:defRPr sz="2100">
+                <a:solidFill>
+                  <a:srgbClr val="161616"/>
+                </a:solidFill>
+                <a:latin typeface="Aptos"/>
+              </a:defRPr>
+            </a:pPr>
+            <a:r>
+              <a:t>Compare analytical theory, nonlinear simulation, time history, and spectrum.</a:t>
             </a:r>
           </a:p>
         </p:txBody>
@@ -6831,7 +7061,7 @@
               </a:defRPr>
             </a:pPr>
             <a:r>
-              <a:t>m: bob mass</a:t>
+              <a:t>M: bob and attached hardware mass</a:t>
             </a:r>
           </a:p>
           <a:p>
@@ -6847,7 +7077,7 @@
               </a:defRPr>
             </a:pPr>
             <a:r>
-              <a:t>L: pivot-to-bob-center distance</a:t>
+              <a:t>m: uniform bar mass</a:t>
             </a:r>
           </a:p>
           <a:p>
@@ -6863,7 +7093,7 @@
               </a:defRPr>
             </a:pPr>
             <a:r>
-              <a:t>theta(t): angle from downward vertical</a:t>
+              <a:t>l: pivot-to-bob-center distance</a:t>
             </a:r>
           </a:p>
           <a:p>
@@ -6879,7 +7109,7 @@
               </a:defRPr>
             </a:pPr>
             <a:r>
-              <a:t>omega(t) = dtheta/dt: angular velocity</a:t>
+              <a:t>theta(t): angle from downward vertical</a:t>
             </a:r>
           </a:p>
           <a:p>
@@ -6895,7 +7125,7 @@
               </a:defRPr>
             </a:pPr>
             <a:r>
-              <a:t>Pivot remains fixed and every release begins with omega(0) = 0.</a:t>
+              <a:t>omega(t) = dtheta/dt; every release begins with omega(0) = 0.</a:t>
             </a:r>
           </a:p>
         </p:txBody>
@@ -7021,7 +7251,7 @@
               </a:defRPr>
             </a:pPr>
             <a:r>
-              <a:t>Restoring torque and nonlinear equation</a:t>
+              <a:t>Ideal point-mass pendulum</a:t>
             </a:r>
           </a:p>
         </p:txBody>
@@ -7057,7 +7287,7 @@
               </a:defRPr>
             </a:pPr>
             <a:r>
-              <a:t>I theta_double_dot = -m g L sin(theta)</a:t>
+              <a:t>M l^2 theta_double_dot = -M g l sin(theta)</a:t>
             </a:r>
           </a:p>
         </p:txBody>
@@ -7093,7 +7323,7 @@
               </a:defRPr>
             </a:pPr>
             <a:r>
-              <a:t>For a point mass: theta_double_dot + (g/L) sin(theta) = 0</a:t>
+              <a:t>theta_double_dot + (g/l) sin(theta) = 0</a:t>
             </a:r>
           </a:p>
         </p:txBody>
@@ -7164,7 +7394,7 @@
               </a:defRPr>
             </a:pPr>
             <a:r>
-              <a:t>Mass cancels in the ideal point-mass model.</a:t>
+              <a:t>M cancels only because this ideal model treats the bar as massless.</a:t>
             </a:r>
           </a:p>
         </p:txBody>
@@ -7254,7 +7484,7 @@
               </a:defRPr>
             </a:pPr>
             <a:r>
-              <a:t>8-10 min</a:t>
+              <a:t>8-11 min</a:t>
             </a:r>
           </a:p>
         </p:txBody>
@@ -7290,35 +7520,59 @@
               </a:defRPr>
             </a:pPr>
             <a:r>
-              <a:t>Small-angle model and prediction</a:t>
-            </a:r>
-          </a:p>
-        </p:txBody>
-      </p:sp>
-      <p:sp>
-        <p:nvSpPr>
-          <p:cNvPr id="5" name="TextBox 4"/>
-          <p:cNvSpPr txBox="1"/>
-          <p:nvPr/>
-        </p:nvSpPr>
-        <p:spPr>
-          <a:xfrm>
-            <a:off x="640080" y="1554480"/>
-            <a:ext cx="10972800" cy="640080"/>
-          </a:xfrm>
-          <a:prstGeom prst="rect">
-            <a:avLst/>
-          </a:prstGeom>
-          <a:noFill/>
-        </p:spPr>
-        <p:txBody>
-          <a:bodyPr wrap="square">
-            <a:spAutoFit/>
-          </a:bodyPr>
-          <a:lstStyle/>
-          <a:p>
-            <a:pPr algn="ctr">
-              <a:defRPr sz="3000" b="1">
+              <a:t>The bar mass changes the model</a:t>
+            </a:r>
+          </a:p>
+        </p:txBody>
+      </p:sp>
+      <p:pic>
+        <p:nvPicPr>
+          <p:cNvPr id="5" name="Picture 4" descr="lab2-compound-schematic.png"/>
+          <p:cNvPicPr>
+            <a:picLocks noChangeAspect="1"/>
+          </p:cNvPicPr>
+          <p:nvPr/>
+        </p:nvPicPr>
+        <p:blipFill>
+          <a:blip r:embed="rId2"/>
+          <a:stretch>
+            <a:fillRect/>
+          </a:stretch>
+        </p:blipFill>
+        <p:spPr>
+          <a:xfrm>
+            <a:off x="685800" y="1417320"/>
+            <a:ext cx="3108960" cy="4480560"/>
+          </a:xfrm>
+          <a:prstGeom prst="rect">
+            <a:avLst/>
+          </a:prstGeom>
+        </p:spPr>
+      </p:pic>
+      <p:sp>
+        <p:nvSpPr>
+          <p:cNvPr id="6" name="TextBox 5"/>
+          <p:cNvSpPr txBox="1"/>
+          <p:nvPr/>
+        </p:nvSpPr>
+        <p:spPr>
+          <a:xfrm>
+            <a:off x="4069080" y="1417320"/>
+            <a:ext cx="7406640" cy="502920"/>
+          </a:xfrm>
+          <a:prstGeom prst="rect">
+            <a:avLst/>
+          </a:prstGeom>
+          <a:noFill/>
+        </p:spPr>
+        <p:txBody>
+          <a:bodyPr wrap="square">
+            <a:spAutoFit/>
+          </a:bodyPr>
+          <a:lstStyle/>
+          <a:p>
+            <a:pPr>
+              <a:defRPr sz="2200" b="1">
                 <a:solidFill>
                   <a:srgbClr val="881C1C"/>
                 </a:solidFill>
@@ -7326,34 +7580,106 @@
               </a:defRPr>
             </a:pPr>
             <a:r>
-              <a:t>sin(theta) approximately theta, for theta in radians</a:t>
-            </a:r>
-          </a:p>
-        </p:txBody>
-      </p:sp>
-      <p:sp>
-        <p:nvSpPr>
-          <p:cNvPr id="6" name="TextBox 5"/>
-          <p:cNvSpPr txBox="1"/>
-          <p:nvPr/>
-        </p:nvSpPr>
-        <p:spPr>
-          <a:xfrm>
-            <a:off x="640080" y="2514600"/>
-            <a:ext cx="10972800" cy="640080"/>
-          </a:xfrm>
-          <a:prstGeom prst="rect">
-            <a:avLst/>
-          </a:prstGeom>
-          <a:noFill/>
-        </p:spPr>
-        <p:txBody>
-          <a:bodyPr wrap="square">
-            <a:spAutoFit/>
-          </a:bodyPr>
-          <a:lstStyle/>
-          <a:p>
-            <a:pPr algn="ctr">
+              <a:t>Moment of inertia about the pivot</a:t>
+            </a:r>
+          </a:p>
+        </p:txBody>
+      </p:sp>
+      <p:sp>
+        <p:nvSpPr>
+          <p:cNvPr id="7" name="TextBox 6"/>
+          <p:cNvSpPr txBox="1"/>
+          <p:nvPr/>
+        </p:nvSpPr>
+        <p:spPr>
+          <a:xfrm>
+            <a:off x="4069080" y="1965960"/>
+            <a:ext cx="7406640" cy="548640"/>
+          </a:xfrm>
+          <a:prstGeom prst="rect">
+            <a:avLst/>
+          </a:prstGeom>
+          <a:noFill/>
+        </p:spPr>
+        <p:txBody>
+          <a:bodyPr wrap="square">
+            <a:spAutoFit/>
+          </a:bodyPr>
+          <a:lstStyle/>
+          <a:p>
+            <a:pPr>
+              <a:defRPr sz="2800" b="1">
+                <a:solidFill>
+                  <a:srgbClr val="161616"/>
+                </a:solidFill>
+                <a:latin typeface="Aptos"/>
+              </a:defRPr>
+            </a:pPr>
+            <a:r>
+              <a:t>I = M l^2 + m l^2 / 3</a:t>
+            </a:r>
+          </a:p>
+        </p:txBody>
+      </p:sp>
+      <p:sp>
+        <p:nvSpPr>
+          <p:cNvPr id="8" name="TextBox 7"/>
+          <p:cNvSpPr txBox="1"/>
+          <p:nvPr/>
+        </p:nvSpPr>
+        <p:spPr>
+          <a:xfrm>
+            <a:off x="4069080" y="2788920"/>
+            <a:ext cx="7406640" cy="502920"/>
+          </a:xfrm>
+          <a:prstGeom prst="rect">
+            <a:avLst/>
+          </a:prstGeom>
+          <a:noFill/>
+        </p:spPr>
+        <p:txBody>
+          <a:bodyPr wrap="square">
+            <a:spAutoFit/>
+          </a:bodyPr>
+          <a:lstStyle/>
+          <a:p>
+            <a:pPr>
+              <a:defRPr sz="2200" b="1">
+                <a:solidFill>
+                  <a:srgbClr val="881C1C"/>
+                </a:solidFill>
+                <a:latin typeface="Aptos"/>
+              </a:defRPr>
+            </a:pPr>
+            <a:r>
+              <a:t>Gravity torque</a:t>
+            </a:r>
+          </a:p>
+        </p:txBody>
+      </p:sp>
+      <p:sp>
+        <p:nvSpPr>
+          <p:cNvPr id="9" name="TextBox 8"/>
+          <p:cNvSpPr txBox="1"/>
+          <p:nvPr/>
+        </p:nvSpPr>
+        <p:spPr>
+          <a:xfrm>
+            <a:off x="4069080" y="3337560"/>
+            <a:ext cx="7406640" cy="685800"/>
+          </a:xfrm>
+          <a:prstGeom prst="rect">
+            <a:avLst/>
+          </a:prstGeom>
+          <a:noFill/>
+        </p:spPr>
+        <p:txBody>
+          <a:bodyPr wrap="square">
+            <a:spAutoFit/>
+          </a:bodyPr>
+          <a:lstStyle/>
+          <a:p>
+            <a:pPr>
               <a:defRPr sz="2500" b="1">
                 <a:solidFill>
                   <a:srgbClr val="161616"/>
@@ -7362,78 +7688,43 @@
               </a:defRPr>
             </a:pPr>
             <a:r>
-              <a:t>omega_n = sqrt(g/L)     f_n = omega_n/(2 pi)     T0 = 2 pi sqrt(L/g)</a:t>
-            </a:r>
-          </a:p>
-        </p:txBody>
-      </p:sp>
-      <p:sp>
-        <p:nvSpPr>
-          <p:cNvPr id="7" name="TextBox 6"/>
-          <p:cNvSpPr txBox="1"/>
-          <p:nvPr/>
-        </p:nvSpPr>
-        <p:spPr>
-          <a:xfrm>
-            <a:off x="914400" y="3794760"/>
-            <a:ext cx="10058400" cy="1554480"/>
-          </a:xfrm>
-          <a:prstGeom prst="rect">
-            <a:avLst/>
-          </a:prstGeom>
-          <a:noFill/>
-        </p:spPr>
-        <p:txBody>
-          <a:bodyPr wrap="square">
-            <a:spAutoFit/>
-          </a:bodyPr>
-          <a:lstStyle/>
-          <a:p>
-            <a:pPr>
-              <a:spcAft>
-                <a:spcPts val="1100"/>
-              </a:spcAft>
-              <a:defRPr sz="2000">
-                <a:solidFill>
-                  <a:srgbClr val="161616"/>
-                </a:solidFill>
-                <a:latin typeface="Aptos"/>
-              </a:defRPr>
-            </a:pPr>
-            <a:r>
-              <a:t>Linear model predicts a sinusoidal angle history.</a:t>
-            </a:r>
-          </a:p>
-          <a:p>
-            <a:pPr>
-              <a:spcAft>
-                <a:spcPts val="1100"/>
-              </a:spcAft>
-              <a:defRPr sz="2000">
-                <a:solidFill>
-                  <a:srgbClr val="161616"/>
-                </a:solidFill>
-                <a:latin typeface="Aptos"/>
-              </a:defRPr>
-            </a:pPr>
-            <a:r>
-              <a:t>Longer L lowers natural frequency.</a:t>
-            </a:r>
-          </a:p>
-          <a:p>
-            <a:pPr>
-              <a:spcAft>
-                <a:spcPts val="1100"/>
-              </a:spcAft>
-              <a:defRPr sz="2000">
-                <a:solidFill>
-                  <a:srgbClr val="161616"/>
-                </a:solidFill>
-                <a:latin typeface="Aptos"/>
-              </a:defRPr>
-            </a:pPr>
-            <a:r>
-              <a:t>Use model mainly near equilibrium.</a:t>
+              <a:t>tau_g = -(M g l + m g l / 2) sin(theta)</a:t>
+            </a:r>
+          </a:p>
+        </p:txBody>
+      </p:sp>
+      <p:sp>
+        <p:nvSpPr>
+          <p:cNvPr id="10" name="TextBox 9"/>
+          <p:cNvSpPr txBox="1"/>
+          <p:nvPr/>
+        </p:nvSpPr>
+        <p:spPr>
+          <a:xfrm>
+            <a:off x="4069080" y="4572000"/>
+            <a:ext cx="7406640" cy="1005840"/>
+          </a:xfrm>
+          <a:prstGeom prst="rect">
+            <a:avLst/>
+          </a:prstGeom>
+          <a:noFill/>
+        </p:spPr>
+        <p:txBody>
+          <a:bodyPr wrap="square">
+            <a:spAutoFit/>
+          </a:bodyPr>
+          <a:lstStyle/>
+          <a:p>
+            <a:pPr>
+              <a:defRPr sz="2000" b="0">
+                <a:solidFill>
+                  <a:srgbClr val="161616"/>
+                </a:solidFill>
+                <a:latin typeface="Aptos"/>
+              </a:defRPr>
+            </a:pPr>
+            <a:r>
+              <a:t>The bob acts at l. The uniform bar acts through its center of mass at l/2.</a:t>
             </a:r>
           </a:p>
         </p:txBody>
@@ -7523,7 +7814,7 @@
               </a:defRPr>
             </a:pPr>
             <a:r>
-              <a:t>10-12 min</a:t>
+              <a:t>11-13 min</a:t>
             </a:r>
           </a:p>
         </p:txBody>
@@ -7559,7 +7850,7 @@
               </a:defRPr>
             </a:pPr>
             <a:r>
-              <a:t>Why large initial angle changes period</a:t>
+              <a:t>Compound-pendulum equation</a:t>
             </a:r>
           </a:p>
         </p:txBody>
@@ -7572,8 +7863,80 @@
         </p:nvSpPr>
         <p:spPr>
           <a:xfrm>
-            <a:off x="685800" y="1508760"/>
-            <a:ext cx="5394960" cy="4480560"/>
+            <a:off x="411480" y="1508760"/>
+            <a:ext cx="11338560" cy="685800"/>
+          </a:xfrm>
+          <a:prstGeom prst="rect">
+            <a:avLst/>
+          </a:prstGeom>
+          <a:noFill/>
+        </p:spPr>
+        <p:txBody>
+          <a:bodyPr wrap="square">
+            <a:spAutoFit/>
+          </a:bodyPr>
+          <a:lstStyle/>
+          <a:p>
+            <a:pPr algn="ctr">
+              <a:defRPr sz="2300" b="1">
+                <a:solidFill>
+                  <a:srgbClr val="881C1C"/>
+                </a:solidFill>
+                <a:latin typeface="Aptos"/>
+              </a:defRPr>
+            </a:pPr>
+            <a:r>
+              <a:t>(M l^2 + m l^2/3) theta_double_dot + (M g l + m g l/2) sin(theta) = 0</a:t>
+            </a:r>
+          </a:p>
+        </p:txBody>
+      </p:sp>
+      <p:sp>
+        <p:nvSpPr>
+          <p:cNvPr id="6" name="TextBox 5"/>
+          <p:cNvSpPr txBox="1"/>
+          <p:nvPr/>
+        </p:nvSpPr>
+        <p:spPr>
+          <a:xfrm>
+            <a:off x="640080" y="2606040"/>
+            <a:ext cx="10972800" cy="685800"/>
+          </a:xfrm>
+          <a:prstGeom prst="rect">
+            <a:avLst/>
+          </a:prstGeom>
+          <a:noFill/>
+        </p:spPr>
+        <p:txBody>
+          <a:bodyPr wrap="square">
+            <a:spAutoFit/>
+          </a:bodyPr>
+          <a:lstStyle/>
+          <a:p>
+            <a:pPr algn="ctr">
+              <a:defRPr sz="2500" b="1">
+                <a:solidFill>
+                  <a:srgbClr val="161616"/>
+                </a:solidFill>
+                <a:latin typeface="Aptos"/>
+              </a:defRPr>
+            </a:pPr>
+            <a:r>
+              <a:t>Small angle: omega_n^2 = g(M + m/2) / [l(M + m/3)]</a:t>
+            </a:r>
+          </a:p>
+        </p:txBody>
+      </p:sp>
+      <p:sp>
+        <p:nvSpPr>
+          <p:cNvPr id="7" name="TextBox 6"/>
+          <p:cNvSpPr txBox="1"/>
+          <p:nvPr/>
+        </p:nvSpPr>
+        <p:spPr>
+          <a:xfrm>
+            <a:off x="960120" y="3794760"/>
+            <a:ext cx="10058400" cy="1645920"/>
           </a:xfrm>
           <a:prstGeom prst="rect">
             <a:avLst/>
@@ -7590,15 +7953,15 @@
               <a:spcAft>
                 <a:spcPts val="1100"/>
               </a:spcAft>
-              <a:defRPr sz="2100">
-                <a:solidFill>
-                  <a:srgbClr val="161616"/>
-                </a:solidFill>
-                <a:latin typeface="Aptos"/>
-              </a:defRPr>
-            </a:pPr>
-            <a:r>
-              <a:t>At large angle, sin(theta) differs from theta.</a:t>
+              <a:defRPr sz="2000">
+                <a:solidFill>
+                  <a:srgbClr val="161616"/>
+                </a:solidFill>
+                <a:latin typeface="Aptos"/>
+              </a:defRPr>
+            </a:pPr>
+            <a:r>
+              <a:t>Measure M, m, and l for the apparatus.</a:t>
             </a:r>
           </a:p>
           <a:p>
@@ -7606,15 +7969,15 @@
               <a:spcAft>
                 <a:spcPts val="1100"/>
               </a:spcAft>
-              <a:defRPr sz="2100">
-                <a:solidFill>
-                  <a:srgbClr val="161616"/>
-                </a:solidFill>
-                <a:latin typeface="Aptos"/>
-              </a:defRPr>
-            </a:pPr>
-            <a:r>
-              <a:t>Exact restoring torque is weaker than linear model predicts at the same angle.</a:t>
+              <a:defRPr sz="2000">
+                <a:solidFill>
+                  <a:srgbClr val="161616"/>
+                </a:solidFill>
+                <a:latin typeface="Aptos"/>
+              </a:defRPr>
+            </a:pPr>
+            <a:r>
+              <a:t>sqrt(g/l) applies only when bar mass is negligible.</a:t>
             </a:r>
           </a:p>
           <a:p>
@@ -7622,59 +7985,19 @@
               <a:spcAft>
                 <a:spcPts val="1100"/>
               </a:spcAft>
-              <a:defRPr sz="2100">
-                <a:solidFill>
-                  <a:srgbClr val="161616"/>
-                </a:solidFill>
-                <a:latin typeface="Aptos"/>
-              </a:defRPr>
-            </a:pPr>
-            <a:r>
-              <a:t>Finite-angle pendulum takes longer to complete a cycle.</a:t>
-            </a:r>
-          </a:p>
-          <a:p>
-            <a:pPr>
-              <a:spcAft>
-                <a:spcPts val="1100"/>
-              </a:spcAft>
-              <a:defRPr sz="2100">
-                <a:solidFill>
-                  <a:srgbClr val="161616"/>
-                </a:solidFill>
-                <a:latin typeface="Aptos"/>
-              </a:defRPr>
-            </a:pPr>
-            <a:r>
-              <a:t>Three Lab 2 releases reveal this change.</a:t>
-            </a:r>
-          </a:p>
-        </p:txBody>
-      </p:sp>
-      <p:pic>
-        <p:nvPicPr>
-          <p:cNvPr id="6" name="Picture 5" descr="lab2-pendulum-photo.jpg"/>
-          <p:cNvPicPr>
-            <a:picLocks noChangeAspect="1"/>
-          </p:cNvPicPr>
-          <p:nvPr/>
-        </p:nvPicPr>
-        <p:blipFill>
-          <a:blip r:embed="rId2"/>
-          <a:stretch>
-            <a:fillRect/>
-          </a:stretch>
-        </p:blipFill>
-        <p:spPr>
-          <a:xfrm>
-            <a:off x="6400800" y="1371600"/>
-            <a:ext cx="4754880" cy="4480560"/>
-          </a:xfrm>
-          <a:prstGeom prst="rect">
-            <a:avLst/>
-          </a:prstGeom>
-        </p:spPr>
-      </p:pic>
+              <a:defRPr sz="2000">
+                <a:solidFill>
+                  <a:srgbClr val="161616"/>
+                </a:solidFill>
+                <a:latin typeface="Aptos"/>
+              </a:defRPr>
+            </a:pPr>
+            <a:r>
+              <a:t>Mass distribution changes inertia and gravity torque by different amounts.</a:t>
+            </a:r>
+          </a:p>
+        </p:txBody>
+      </p:sp>
     </p:spTree>
   </p:cSld>
   <p:clrMapOvr>
@@ -7760,7 +8083,7 @@
               </a:defRPr>
             </a:pPr>
             <a:r>
-              <a:t>12-14 min</a:t>
+              <a:t>13-15 min</a:t>
             </a:r>
           </a:p>
         </p:txBody>
@@ -7796,7 +8119,7 @@
               </a:defRPr>
             </a:pPr>
             <a:r>
-              <a:t>Energy during a swing</a:t>
+              <a:t>Why large initial angle changes period</a:t>
             </a:r>
           </a:p>
         </p:txBody>
@@ -7809,44 +8132,8 @@
         </p:nvSpPr>
         <p:spPr>
           <a:xfrm>
-            <a:off x="640080" y="1600200"/>
-            <a:ext cx="10972800" cy="640080"/>
-          </a:xfrm>
-          <a:prstGeom prst="rect">
-            <a:avLst/>
-          </a:prstGeom>
-          <a:noFill/>
-        </p:spPr>
-        <p:txBody>
-          <a:bodyPr wrap="square">
-            <a:spAutoFit/>
-          </a:bodyPr>
-          <a:lstStyle/>
-          <a:p>
-            <a:pPr algn="ctr">
-              <a:defRPr sz="2700" b="1">
-                <a:solidFill>
-                  <a:srgbClr val="881C1C"/>
-                </a:solidFill>
-                <a:latin typeface="Aptos"/>
-              </a:defRPr>
-            </a:pPr>
-            <a:r>
-              <a:t>E = 1/2 m L^2 omega^2 + m g L (1 - cos(theta))</a:t>
-            </a:r>
-          </a:p>
-        </p:txBody>
-      </p:sp>
-      <p:sp>
-        <p:nvSpPr>
-          <p:cNvPr id="6" name="TextBox 5"/>
-          <p:cNvSpPr txBox="1"/>
-          <p:nvPr/>
-        </p:nvSpPr>
-        <p:spPr>
-          <a:xfrm>
-            <a:off x="914400" y="2971800"/>
-            <a:ext cx="10058400" cy="1828800"/>
+            <a:off x="685800" y="1508760"/>
+            <a:ext cx="5394960" cy="4480560"/>
           </a:xfrm>
           <a:prstGeom prst="rect">
             <a:avLst/>
@@ -7871,7 +8158,7 @@
               </a:defRPr>
             </a:pPr>
             <a:r>
-              <a:t>At release theta is largest and omega = 0.</a:t>
+              <a:t>At large angle, sin(theta) differs from theta.</a:t>
             </a:r>
           </a:p>
           <a:p>
@@ -7887,7 +8174,7 @@
               </a:defRPr>
             </a:pPr>
             <a:r>
-              <a:t>Near bottom theta = 0 and speed is largest.</a:t>
+              <a:t>Exact restoring torque is weaker than the linear model predicts at the same angle.</a:t>
             </a:r>
           </a:p>
           <a:p>
@@ -7903,11 +8190,51 @@
               </a:defRPr>
             </a:pPr>
             <a:r>
-              <a:t>Real data decays slowly due to air drag and pivot friction.</a:t>
-            </a:r>
-          </a:p>
-        </p:txBody>
-      </p:sp>
+              <a:t>Finite-angle motion takes longer to complete a cycle.</a:t>
+            </a:r>
+          </a:p>
+          <a:p>
+            <a:pPr>
+              <a:spcAft>
+                <a:spcPts val="1100"/>
+              </a:spcAft>
+              <a:defRPr sz="2100">
+                <a:solidFill>
+                  <a:srgbClr val="161616"/>
+                </a:solidFill>
+                <a:latin typeface="Aptos"/>
+              </a:defRPr>
+            </a:pPr>
+            <a:r>
+              <a:t>Use the nonlinear equation from Pre-Lab 2 for all three releases.</a:t>
+            </a:r>
+          </a:p>
+        </p:txBody>
+      </p:sp>
+      <p:pic>
+        <p:nvPicPr>
+          <p:cNvPr id="6" name="Picture 5" descr="lab2-pendulum-photo.jpg"/>
+          <p:cNvPicPr>
+            <a:picLocks noChangeAspect="1"/>
+          </p:cNvPicPr>
+          <p:nvPr/>
+        </p:nvPicPr>
+        <p:blipFill>
+          <a:blip r:embed="rId2"/>
+          <a:stretch>
+            <a:fillRect/>
+          </a:stretch>
+        </p:blipFill>
+        <p:spPr>
+          <a:xfrm>
+            <a:off x="6400800" y="1371600"/>
+            <a:ext cx="4754880" cy="4480560"/>
+          </a:xfrm>
+          <a:prstGeom prst="rect">
+            <a:avLst/>
+          </a:prstGeom>
+        </p:spPr>
+      </p:pic>
     </p:spTree>
   </p:cSld>
   <p:clrMapOvr>
@@ -7993,7 +8320,7 @@
               </a:defRPr>
             </a:pPr>
             <a:r>
-              <a:t>14-16 min</a:t>
+              <a:t>15-17 min</a:t>
             </a:r>
           </a:p>
         </p:txBody>
@@ -8029,7 +8356,7 @@
               </a:defRPr>
             </a:pPr>
             <a:r>
-              <a:t>What the camera actually measures</a:t>
+              <a:t>Energy during a swing</a:t>
             </a:r>
           </a:p>
         </p:txBody>
@@ -8042,8 +8369,44 @@
         </p:nvSpPr>
         <p:spPr>
           <a:xfrm>
-            <a:off x="685800" y="1508760"/>
-            <a:ext cx="5394960" cy="4480560"/>
+            <a:off x="411480" y="1508760"/>
+            <a:ext cx="11338560" cy="777240"/>
+          </a:xfrm>
+          <a:prstGeom prst="rect">
+            <a:avLst/>
+          </a:prstGeom>
+          <a:noFill/>
+        </p:spPr>
+        <p:txBody>
+          <a:bodyPr wrap="square">
+            <a:spAutoFit/>
+          </a:bodyPr>
+          <a:lstStyle/>
+          <a:p>
+            <a:pPr algn="ctr">
+              <a:defRPr sz="2200" b="1">
+                <a:solidFill>
+                  <a:srgbClr val="881C1C"/>
+                </a:solidFill>
+                <a:latin typeface="Aptos"/>
+              </a:defRPr>
+            </a:pPr>
+            <a:r>
+              <a:t>E = 1/2 (M l^2 + m l^2/3) omega^2 + (M g l + m g l/2)(1 - cos(theta))</a:t>
+            </a:r>
+          </a:p>
+        </p:txBody>
+      </p:sp>
+      <p:sp>
+        <p:nvSpPr>
+          <p:cNvPr id="6" name="TextBox 5"/>
+          <p:cNvSpPr txBox="1"/>
+          <p:nvPr/>
+        </p:nvSpPr>
+        <p:spPr>
+          <a:xfrm>
+            <a:off x="914400" y="2971800"/>
+            <a:ext cx="10058400" cy="1828800"/>
           </a:xfrm>
           <a:prstGeom prst="rect">
             <a:avLst/>
@@ -8068,7 +8431,7 @@
               </a:defRPr>
             </a:pPr>
             <a:r>
-              <a:t>Camera stores frames, not angle directly.</a:t>
+              <a:t>At release theta is largest and omega = 0.</a:t>
             </a:r>
           </a:p>
           <a:p>
@@ -8084,7 +8447,7 @@
               </a:defRPr>
             </a:pPr>
             <a:r>
-              <a:t>Every frame contains pivot and bob positions.</a:t>
+              <a:t>Near the bottom theta = 0 and speed is largest.</a:t>
             </a:r>
           </a:p>
           <a:p>
@@ -8100,51 +8463,11 @@
               </a:defRPr>
             </a:pPr>
             <a:r>
-              <a:t>Useful record needs full motion in frame, sharp contrast, and visible bob center.</a:t>
-            </a:r>
-          </a:p>
-          <a:p>
-            <a:pPr>
-              <a:spcAft>
-                <a:spcPts val="1100"/>
-              </a:spcAft>
-              <a:defRPr sz="2100">
-                <a:solidFill>
-                  <a:srgbClr val="161616"/>
-                </a:solidFill>
-                <a:latin typeface="Aptos"/>
-              </a:defRPr>
-            </a:pPr>
-            <a:r>
-              <a:t>Frame rate becomes time spacing of measurement.</a:t>
-            </a:r>
-          </a:p>
-        </p:txBody>
-      </p:sp>
-      <p:pic>
-        <p:nvPicPr>
-          <p:cNvPr id="6" name="Picture 5" descr="lab2-camera-main-screen.jpg"/>
-          <p:cNvPicPr>
-            <a:picLocks noChangeAspect="1"/>
-          </p:cNvPicPr>
-          <p:nvPr/>
-        </p:nvPicPr>
-        <p:blipFill>
-          <a:blip r:embed="rId2"/>
-          <a:stretch>
-            <a:fillRect/>
-          </a:stretch>
-        </p:blipFill>
-        <p:spPr>
-          <a:xfrm>
-            <a:off x="6400800" y="1371600"/>
-            <a:ext cx="4754880" cy="4480560"/>
-          </a:xfrm>
-          <a:prstGeom prst="rect">
-            <a:avLst/>
-          </a:prstGeom>
-        </p:spPr>
-      </p:pic>
+              <a:t>Air drag and pivot friction cause measured amplitude and energy to decrease.</a:t>
+            </a:r>
+          </a:p>
+        </p:txBody>
+      </p:sp>
     </p:spTree>
   </p:cSld>
   <p:clrMapOvr>
@@ -8230,7 +8553,7 @@
               </a:defRPr>
             </a:pPr>
             <a:r>
-              <a:t>16-18 min</a:t>
+              <a:t>17-19 min</a:t>
             </a:r>
           </a:p>
         </p:txBody>
@@ -8266,14 +8589,101 @@
               </a:defRPr>
             </a:pPr>
             <a:r>
-              <a:t>Camera settings and useful video</a:t>
+              <a:t>What the camera actually measures</a:t>
+            </a:r>
+          </a:p>
+        </p:txBody>
+      </p:sp>
+      <p:sp>
+        <p:nvSpPr>
+          <p:cNvPr id="5" name="TextBox 4"/>
+          <p:cNvSpPr txBox="1"/>
+          <p:nvPr/>
+        </p:nvSpPr>
+        <p:spPr>
+          <a:xfrm>
+            <a:off x="685800" y="1508760"/>
+            <a:ext cx="5394960" cy="4480560"/>
+          </a:xfrm>
+          <a:prstGeom prst="rect">
+            <a:avLst/>
+          </a:prstGeom>
+          <a:noFill/>
+        </p:spPr>
+        <p:txBody>
+          <a:bodyPr wrap="square">
+            <a:spAutoFit/>
+          </a:bodyPr>
+          <a:lstStyle/>
+          <a:p>
+            <a:pPr>
+              <a:spcAft>
+                <a:spcPts val="1100"/>
+              </a:spcAft>
+              <a:defRPr sz="2100">
+                <a:solidFill>
+                  <a:srgbClr val="161616"/>
+                </a:solidFill>
+                <a:latin typeface="Aptos"/>
+              </a:defRPr>
+            </a:pPr>
+            <a:r>
+              <a:t>Camera stores frames, not angle directly.</a:t>
+            </a:r>
+          </a:p>
+          <a:p>
+            <a:pPr>
+              <a:spcAft>
+                <a:spcPts val="1100"/>
+              </a:spcAft>
+              <a:defRPr sz="2100">
+                <a:solidFill>
+                  <a:srgbClr val="161616"/>
+                </a:solidFill>
+                <a:latin typeface="Aptos"/>
+              </a:defRPr>
+            </a:pPr>
+            <a:r>
+              <a:t>Every frame contains pivot and bob positions.</a:t>
+            </a:r>
+          </a:p>
+          <a:p>
+            <a:pPr>
+              <a:spcAft>
+                <a:spcPts val="1100"/>
+              </a:spcAft>
+              <a:defRPr sz="2100">
+                <a:solidFill>
+                  <a:srgbClr val="161616"/>
+                </a:solidFill>
+                <a:latin typeface="Aptos"/>
+              </a:defRPr>
+            </a:pPr>
+            <a:r>
+              <a:t>Useful record needs full motion in frame, sharp contrast, and visible bob center.</a:t>
+            </a:r>
+          </a:p>
+          <a:p>
+            <a:pPr>
+              <a:spcAft>
+                <a:spcPts val="1100"/>
+              </a:spcAft>
+              <a:defRPr sz="2100">
+                <a:solidFill>
+                  <a:srgbClr val="161616"/>
+                </a:solidFill>
+                <a:latin typeface="Aptos"/>
+              </a:defRPr>
+            </a:pPr>
+            <a:r>
+              <a:t>Frame rate becomes time spacing of measurement.</a:t>
             </a:r>
           </a:p>
         </p:txBody>
       </p:sp>
       <p:pic>
         <p:nvPicPr>
-          <p:cNvPr id="5" name="Picture 4" descr="lab2-camera-record-settings.jpg"/>
+          <p:cNvPr id="6" name="Picture 5" descr="lab2-camera-main-screen.jpg"/>
           <p:cNvPicPr>
             <a:picLocks noChangeAspect="1"/>
           </p:cNvPicPr>
@@ -8287,125 +8697,14 @@
         </p:blipFill>
         <p:spPr>
           <a:xfrm>
-            <a:off x="594360" y="1463040"/>
-            <a:ext cx="4114800" cy="3063240"/>
+            <a:off x="6400800" y="1371600"/>
+            <a:ext cx="4754880" cy="4480560"/>
           </a:xfrm>
           <a:prstGeom prst="rect">
             <a:avLst/>
           </a:prstGeom>
         </p:spPr>
       </p:pic>
-      <p:pic>
-        <p:nvPicPr>
-          <p:cNvPr id="6" name="Picture 5" descr="lab2-camera-trigger-delay.jpg"/>
-          <p:cNvPicPr>
-            <a:picLocks noChangeAspect="1"/>
-          </p:cNvPicPr>
-          <p:nvPr/>
-        </p:nvPicPr>
-        <p:blipFill>
-          <a:blip r:embed="rId3"/>
-          <a:stretch>
-            <a:fillRect/>
-          </a:stretch>
-        </p:blipFill>
-        <p:spPr>
-          <a:xfrm>
-            <a:off x="4892040" y="1463040"/>
-            <a:ext cx="4114800" cy="3063240"/>
-          </a:xfrm>
-          <a:prstGeom prst="rect">
-            <a:avLst/>
-          </a:prstGeom>
-        </p:spPr>
-      </p:pic>
-      <p:sp>
-        <p:nvSpPr>
-          <p:cNvPr id="7" name="TextBox 6"/>
-          <p:cNvSpPr txBox="1"/>
-          <p:nvPr/>
-        </p:nvSpPr>
-        <p:spPr>
-          <a:xfrm>
-            <a:off x="777240" y="4800600"/>
-            <a:ext cx="10515600" cy="1051560"/>
-          </a:xfrm>
-          <a:prstGeom prst="rect">
-            <a:avLst/>
-          </a:prstGeom>
-          <a:noFill/>
-        </p:spPr>
-        <p:txBody>
-          <a:bodyPr wrap="square">
-            <a:spAutoFit/>
-          </a:bodyPr>
-          <a:lstStyle/>
-          <a:p>
-            <a:pPr>
-              <a:spcAft>
-                <a:spcPts val="1100"/>
-              </a:spcAft>
-              <a:defRPr sz="1700">
-                <a:solidFill>
-                  <a:srgbClr val="161616"/>
-                </a:solidFill>
-                <a:latin typeface="Aptos"/>
-              </a:defRPr>
-            </a:pPr>
-            <a:r>
-              <a:t>Record actual frame rate.</a:t>
-            </a:r>
-          </a:p>
-          <a:p>
-            <a:pPr>
-              <a:spcAft>
-                <a:spcPts val="1100"/>
-              </a:spcAft>
-              <a:defRPr sz="1700">
-                <a:solidFill>
-                  <a:srgbClr val="161616"/>
-                </a:solidFill>
-                <a:latin typeface="Aptos"/>
-              </a:defRPr>
-            </a:pPr>
-            <a:r>
-              <a:t>Use trigger delay that includes release and cycles.</a:t>
-            </a:r>
-          </a:p>
-          <a:p>
-            <a:pPr>
-              <a:spcAft>
-                <a:spcPts val="1100"/>
-              </a:spcAft>
-              <a:defRPr sz="1700">
-                <a:solidFill>
-                  <a:srgbClr val="161616"/>
-                </a:solidFill>
-                <a:latin typeface="Aptos"/>
-              </a:defRPr>
-            </a:pPr>
-            <a:r>
-              <a:t>Test framing before experiment.</a:t>
-            </a:r>
-          </a:p>
-          <a:p>
-            <a:pPr>
-              <a:spcAft>
-                <a:spcPts val="1100"/>
-              </a:spcAft>
-              <a:defRPr sz="1700">
-                <a:solidFill>
-                  <a:srgbClr val="161616"/>
-                </a:solidFill>
-                <a:latin typeface="Aptos"/>
-              </a:defRPr>
-            </a:pPr>
-            <a:r>
-              <a:t>Smooth video does not prove accurate tracking.</a:t>
-            </a:r>
-          </a:p>
-        </p:txBody>
-      </p:sp>
     </p:spTree>
   </p:cSld>
   <p:clrMapOvr>

</xml_diff>

<commit_message>
Typeset Lab 2 equations professionally
</commit_message>
<xml_diff>
--- a/site/docs/MIE402_Lecture03_Single_Pendulum_PreLab2_Fall2026.pptx
+++ b/site/docs/MIE402_Lecture03_Single_Pendulum_PreLab2_Fall2026.pptx
@@ -3938,42 +3938,30 @@
           </a:p>
         </p:txBody>
       </p:sp>
-      <p:sp>
-        <p:nvSpPr>
-          <p:cNvPr id="5" name="TextBox 4"/>
-          <p:cNvSpPr txBox="1"/>
-          <p:nvPr/>
-        </p:nvSpPr>
-        <p:spPr>
-          <a:xfrm>
-            <a:off x="640080" y="1554480"/>
-            <a:ext cx="10972800" cy="640080"/>
-          </a:xfrm>
-          <a:prstGeom prst="rect">
-            <a:avLst/>
-          </a:prstGeom>
-          <a:noFill/>
-        </p:spPr>
-        <p:txBody>
-          <a:bodyPr wrap="square">
-            <a:spAutoFit/>
-          </a:bodyPr>
-          <a:lstStyle/>
-          <a:p>
-            <a:pPr algn="ctr">
-              <a:defRPr sz="3000" b="1">
-                <a:solidFill>
-                  <a:srgbClr val="881C1C"/>
-                </a:solidFill>
-                <a:latin typeface="Aptos"/>
-              </a:defRPr>
-            </a:pPr>
-            <a:r>
-              <a:t>theta(t) = atan2( xb - xp,  yb - yp )</a:t>
-            </a:r>
-          </a:p>
-        </p:txBody>
-      </p:sp>
+      <p:pic>
+        <p:nvPicPr>
+          <p:cNvPr id="5" name="Picture 4" descr="angle-black.png"/>
+          <p:cNvPicPr>
+            <a:picLocks noChangeAspect="1"/>
+          </p:cNvPicPr>
+          <p:nvPr/>
+        </p:nvPicPr>
+        <p:blipFill>
+          <a:blip r:embed="rId2"/>
+          <a:stretch>
+            <a:fillRect/>
+          </a:stretch>
+        </p:blipFill>
+        <p:spPr>
+          <a:xfrm>
+            <a:off x="2834640" y="1481328"/>
+            <a:ext cx="6583680" cy="777240"/>
+          </a:xfrm>
+          <a:prstGeom prst="rect">
+            <a:avLst/>
+          </a:prstGeom>
+        </p:spPr>
+      </p:pic>
       <p:sp>
         <p:nvSpPr>
           <p:cNvPr id="6" name="TextBox 5"/>
@@ -4448,42 +4436,30 @@
           </a:p>
         </p:txBody>
       </p:sp>
-      <p:sp>
-        <p:nvSpPr>
-          <p:cNvPr id="5" name="TextBox 4"/>
-          <p:cNvSpPr txBox="1"/>
-          <p:nvPr/>
-        </p:nvSpPr>
-        <p:spPr>
-          <a:xfrm>
-            <a:off x="685800" y="1554480"/>
-            <a:ext cx="10789920" cy="594360"/>
-          </a:xfrm>
-          <a:prstGeom prst="rect">
-            <a:avLst/>
-          </a:prstGeom>
-          <a:noFill/>
-        </p:spPr>
-        <p:txBody>
-          <a:bodyPr wrap="square">
-            <a:spAutoFit/>
-          </a:bodyPr>
-          <a:lstStyle/>
-          <a:p>
-            <a:pPr algn="ctr">
-              <a:defRPr sz="2700" b="1">
-                <a:solidFill>
-                  <a:srgbClr val="881C1C"/>
-                </a:solidFill>
-                <a:latin typeface="Aptos"/>
-              </a:defRPr>
-            </a:pPr>
-            <a:r>
-              <a:t>At 1000 frames/s: Nyquist frequency = 500 Hz</a:t>
-            </a:r>
-          </a:p>
-        </p:txBody>
-      </p:sp>
+      <p:pic>
+        <p:nvPicPr>
+          <p:cNvPr id="5" name="Picture 4" descr="nyquist-black.png"/>
+          <p:cNvPicPr>
+            <a:picLocks noChangeAspect="1"/>
+          </p:cNvPicPr>
+          <p:nvPr/>
+        </p:nvPicPr>
+        <p:blipFill>
+          <a:blip r:embed="rId2"/>
+          <a:stretch>
+            <a:fillRect/>
+          </a:stretch>
+        </p:blipFill>
+        <p:spPr>
+          <a:xfrm>
+            <a:off x="2331720" y="1481328"/>
+            <a:ext cx="7498079" cy="731520"/>
+          </a:xfrm>
+          <a:prstGeom prst="rect">
+            <a:avLst/>
+          </a:prstGeom>
+        </p:spPr>
+      </p:pic>
       <p:sp>
         <p:nvSpPr>
           <p:cNvPr id="6" name="TextBox 5"/>
@@ -4681,42 +4657,30 @@
           </a:p>
         </p:txBody>
       </p:sp>
-      <p:sp>
-        <p:nvSpPr>
-          <p:cNvPr id="5" name="TextBox 4"/>
-          <p:cNvSpPr txBox="1"/>
-          <p:nvPr/>
-        </p:nvSpPr>
-        <p:spPr>
-          <a:xfrm>
-            <a:off x="685800" y="1554480"/>
-            <a:ext cx="10789920" cy="594360"/>
-          </a:xfrm>
-          <a:prstGeom prst="rect">
-            <a:avLst/>
-          </a:prstGeom>
-          <a:noFill/>
-        </p:spPr>
-        <p:txBody>
-          <a:bodyPr wrap="square">
-            <a:spAutoFit/>
-          </a:bodyPr>
-          <a:lstStyle/>
-          <a:p>
-            <a:pPr algn="ctr">
-              <a:defRPr sz="3000" b="1">
-                <a:solidFill>
-                  <a:srgbClr val="881C1C"/>
-                </a:solidFill>
-                <a:latin typeface="Aptos"/>
-              </a:defRPr>
-            </a:pPr>
-            <a:r>
-              <a:t>omega(t) = d theta(t) / dt</a:t>
-            </a:r>
-          </a:p>
-        </p:txBody>
-      </p:sp>
+      <p:pic>
+        <p:nvPicPr>
+          <p:cNvPr id="5" name="Picture 4" descr="omega-black.png"/>
+          <p:cNvPicPr>
+            <a:picLocks noChangeAspect="1"/>
+          </p:cNvPicPr>
+          <p:nvPr/>
+        </p:nvPicPr>
+        <p:blipFill>
+          <a:blip r:embed="rId2"/>
+          <a:stretch>
+            <a:fillRect/>
+          </a:stretch>
+        </p:blipFill>
+        <p:spPr>
+          <a:xfrm>
+            <a:off x="3154680" y="1481328"/>
+            <a:ext cx="5852160" cy="749808"/>
+          </a:xfrm>
+          <a:prstGeom prst="rect">
+            <a:avLst/>
+          </a:prstGeom>
+        </p:spPr>
+      </p:pic>
       <p:sp>
         <p:nvSpPr>
           <p:cNvPr id="6" name="TextBox 5"/>
@@ -4996,7 +4960,7 @@
               </a:defRPr>
             </a:pPr>
             <a:r>
-              <a:t>Bin spacing Delta f = 1/T_record.</a:t>
+              <a:t>Report record duration Tᵣ and frequency-bin spacing.</a:t>
             </a:r>
           </a:p>
           <a:p>
@@ -5017,78 +4981,54 @@
           </a:p>
         </p:txBody>
       </p:sp>
-      <p:sp>
-        <p:nvSpPr>
-          <p:cNvPr id="6" name="TextBox 5"/>
-          <p:cNvSpPr txBox="1"/>
-          <p:nvPr/>
-        </p:nvSpPr>
-        <p:spPr>
-          <a:xfrm>
-            <a:off x="6492240" y="2011680"/>
-            <a:ext cx="4663440" cy="731520"/>
-          </a:xfrm>
-          <a:prstGeom prst="rect">
-            <a:avLst/>
-          </a:prstGeom>
-          <a:noFill/>
-        </p:spPr>
-        <p:txBody>
-          <a:bodyPr wrap="square">
-            <a:spAutoFit/>
-          </a:bodyPr>
-          <a:lstStyle/>
-          <a:p>
-            <a:pPr algn="ctr">
-              <a:defRPr sz="2500" b="1">
-                <a:solidFill>
-                  <a:srgbClr val="881C1C"/>
-                </a:solidFill>
-                <a:latin typeface="Aptos"/>
-              </a:defRPr>
-            </a:pPr>
-            <a:r>
-              <a:t>f = number of cycles / elapsed time</a:t>
-            </a:r>
-          </a:p>
-        </p:txBody>
-      </p:sp>
-      <p:sp>
-        <p:nvSpPr>
-          <p:cNvPr id="7" name="TextBox 6"/>
-          <p:cNvSpPr txBox="1"/>
-          <p:nvPr/>
-        </p:nvSpPr>
-        <p:spPr>
-          <a:xfrm>
-            <a:off x="6492240" y="3474720"/>
-            <a:ext cx="4663440" cy="731520"/>
-          </a:xfrm>
-          <a:prstGeom prst="rect">
-            <a:avLst/>
-          </a:prstGeom>
-          <a:noFill/>
-        </p:spPr>
-        <p:txBody>
-          <a:bodyPr wrap="square">
-            <a:spAutoFit/>
-          </a:bodyPr>
-          <a:lstStyle/>
-          <a:p>
-            <a:pPr algn="ctr">
-              <a:defRPr sz="2600" b="1">
-                <a:solidFill>
-                  <a:srgbClr val="161616"/>
-                </a:solidFill>
-                <a:latin typeface="Aptos"/>
-              </a:defRPr>
-            </a:pPr>
-            <a:r>
-              <a:t>Delta f = 1/T_record</a:t>
-            </a:r>
-          </a:p>
-        </p:txBody>
-      </p:sp>
+      <p:pic>
+        <p:nvPicPr>
+          <p:cNvPr id="6" name="Picture 5" descr="period-black.png"/>
+          <p:cNvPicPr>
+            <a:picLocks noChangeAspect="1"/>
+          </p:cNvPicPr>
+          <p:nvPr/>
+        </p:nvPicPr>
+        <p:blipFill>
+          <a:blip r:embed="rId2"/>
+          <a:stretch>
+            <a:fillRect/>
+          </a:stretch>
+        </p:blipFill>
+        <p:spPr>
+          <a:xfrm>
+            <a:off x="6583680" y="1828800"/>
+            <a:ext cx="4297680" cy="685800"/>
+          </a:xfrm>
+          <a:prstGeom prst="rect">
+            <a:avLst/>
+          </a:prstGeom>
+        </p:spPr>
+      </p:pic>
+      <p:pic>
+        <p:nvPicPr>
+          <p:cNvPr id="7" name="Picture 6" descr="resolution-black.png"/>
+          <p:cNvPicPr>
+            <a:picLocks noChangeAspect="1"/>
+          </p:cNvPicPr>
+          <p:nvPr/>
+        </p:nvPicPr>
+        <p:blipFill>
+          <a:blip r:embed="rId3"/>
+          <a:stretch>
+            <a:fillRect/>
+          </a:stretch>
+        </p:blipFill>
+        <p:spPr>
+          <a:xfrm>
+            <a:off x="6629400" y="3337560"/>
+            <a:ext cx="4206240" cy="658368"/>
+          </a:xfrm>
+          <a:prstGeom prst="rect">
+            <a:avLst/>
+          </a:prstGeom>
+        </p:spPr>
+      </p:pic>
     </p:spTree>
   </p:cSld>
   <p:clrMapOvr>
@@ -7256,78 +7196,54 @@
           </a:p>
         </p:txBody>
       </p:sp>
-      <p:sp>
-        <p:nvSpPr>
-          <p:cNvPr id="5" name="TextBox 4"/>
-          <p:cNvSpPr txBox="1"/>
-          <p:nvPr/>
-        </p:nvSpPr>
-        <p:spPr>
-          <a:xfrm>
-            <a:off x="640080" y="1554480"/>
-            <a:ext cx="10972800" cy="640080"/>
-          </a:xfrm>
-          <a:prstGeom prst="rect">
-            <a:avLst/>
-          </a:prstGeom>
-          <a:noFill/>
-        </p:spPr>
-        <p:txBody>
-          <a:bodyPr wrap="square">
-            <a:spAutoFit/>
-          </a:bodyPr>
-          <a:lstStyle/>
-          <a:p>
-            <a:pPr algn="ctr">
-              <a:defRPr sz="3000" b="1">
-                <a:solidFill>
-                  <a:srgbClr val="881C1C"/>
-                </a:solidFill>
-                <a:latin typeface="Aptos"/>
-              </a:defRPr>
-            </a:pPr>
-            <a:r>
-              <a:t>M l^2 theta_double_dot = -M g l sin(theta)</a:t>
-            </a:r>
-          </a:p>
-        </p:txBody>
-      </p:sp>
-      <p:sp>
-        <p:nvSpPr>
-          <p:cNvPr id="6" name="TextBox 5"/>
-          <p:cNvSpPr txBox="1"/>
-          <p:nvPr/>
-        </p:nvSpPr>
-        <p:spPr>
-          <a:xfrm>
-            <a:off x="640080" y="2468880"/>
-            <a:ext cx="10972800" cy="640080"/>
-          </a:xfrm>
-          <a:prstGeom prst="rect">
-            <a:avLst/>
-          </a:prstGeom>
-          <a:noFill/>
-        </p:spPr>
-        <p:txBody>
-          <a:bodyPr wrap="square">
-            <a:spAutoFit/>
-          </a:bodyPr>
-          <a:lstStyle/>
-          <a:p>
-            <a:pPr algn="ctr">
-              <a:defRPr sz="2600" b="1">
-                <a:solidFill>
-                  <a:srgbClr val="161616"/>
-                </a:solidFill>
-                <a:latin typeface="Aptos"/>
-              </a:defRPr>
-            </a:pPr>
-            <a:r>
-              <a:t>theta_double_dot + (g/l) sin(theta) = 0</a:t>
-            </a:r>
-          </a:p>
-        </p:txBody>
-      </p:sp>
+      <p:pic>
+        <p:nvPicPr>
+          <p:cNvPr id="5" name="Picture 4" descr="point_torque-black.png"/>
+          <p:cNvPicPr>
+            <a:picLocks noChangeAspect="1"/>
+          </p:cNvPicPr>
+          <p:nvPr/>
+        </p:nvPicPr>
+        <p:blipFill>
+          <a:blip r:embed="rId2"/>
+          <a:stretch>
+            <a:fillRect/>
+          </a:stretch>
+        </p:blipFill>
+        <p:spPr>
+          <a:xfrm>
+            <a:off x="2880360" y="1481328"/>
+            <a:ext cx="6400800" cy="658368"/>
+          </a:xfrm>
+          <a:prstGeom prst="rect">
+            <a:avLst/>
+          </a:prstGeom>
+        </p:spPr>
+      </p:pic>
+      <p:pic>
+        <p:nvPicPr>
+          <p:cNvPr id="6" name="Picture 5" descr="point_eom-black.png"/>
+          <p:cNvPicPr>
+            <a:picLocks noChangeAspect="1"/>
+          </p:cNvPicPr>
+          <p:nvPr/>
+        </p:nvPicPr>
+        <p:blipFill>
+          <a:blip r:embed="rId3"/>
+          <a:stretch>
+            <a:fillRect/>
+          </a:stretch>
+        </p:blipFill>
+        <p:spPr>
+          <a:xfrm>
+            <a:off x="3566160" y="2395728"/>
+            <a:ext cx="5029200" cy="713232"/>
+          </a:xfrm>
+          <a:prstGeom prst="rect">
+            <a:avLst/>
+          </a:prstGeom>
+        </p:spPr>
+      </p:pic>
       <p:sp>
         <p:nvSpPr>
           <p:cNvPr id="7" name="TextBox 6"/>
@@ -7585,42 +7501,30 @@
           </a:p>
         </p:txBody>
       </p:sp>
-      <p:sp>
-        <p:nvSpPr>
-          <p:cNvPr id="7" name="TextBox 6"/>
-          <p:cNvSpPr txBox="1"/>
-          <p:nvPr/>
-        </p:nvSpPr>
-        <p:spPr>
-          <a:xfrm>
-            <a:off x="4069080" y="1965960"/>
-            <a:ext cx="7406640" cy="548640"/>
-          </a:xfrm>
-          <a:prstGeom prst="rect">
-            <a:avLst/>
-          </a:prstGeom>
-          <a:noFill/>
-        </p:spPr>
-        <p:txBody>
-          <a:bodyPr wrap="square">
-            <a:spAutoFit/>
-          </a:bodyPr>
-          <a:lstStyle/>
-          <a:p>
-            <a:pPr>
-              <a:defRPr sz="2800" b="1">
-                <a:solidFill>
-                  <a:srgbClr val="161616"/>
-                </a:solidFill>
-                <a:latin typeface="Aptos"/>
-              </a:defRPr>
-            </a:pPr>
-            <a:r>
-              <a:t>I = M l^2 + m l^2 / 3</a:t>
-            </a:r>
-          </a:p>
-        </p:txBody>
-      </p:sp>
+      <p:pic>
+        <p:nvPicPr>
+          <p:cNvPr id="7" name="Picture 6" descr="inertia-black.png"/>
+          <p:cNvPicPr>
+            <a:picLocks noChangeAspect="1"/>
+          </p:cNvPicPr>
+          <p:nvPr/>
+        </p:nvPicPr>
+        <p:blipFill>
+          <a:blip r:embed="rId3"/>
+          <a:stretch>
+            <a:fillRect/>
+          </a:stretch>
+        </p:blipFill>
+        <p:spPr>
+          <a:xfrm>
+            <a:off x="4572000" y="1938528"/>
+            <a:ext cx="5029200" cy="621792"/>
+          </a:xfrm>
+          <a:prstGeom prst="rect">
+            <a:avLst/>
+          </a:prstGeom>
+        </p:spPr>
+      </p:pic>
       <p:sp>
         <p:nvSpPr>
           <p:cNvPr id="8" name="TextBox 7"/>
@@ -7657,42 +7561,30 @@
           </a:p>
         </p:txBody>
       </p:sp>
-      <p:sp>
-        <p:nvSpPr>
-          <p:cNvPr id="9" name="TextBox 8"/>
-          <p:cNvSpPr txBox="1"/>
-          <p:nvPr/>
-        </p:nvSpPr>
-        <p:spPr>
-          <a:xfrm>
-            <a:off x="4069080" y="3337560"/>
-            <a:ext cx="7406640" cy="685800"/>
-          </a:xfrm>
-          <a:prstGeom prst="rect">
-            <a:avLst/>
-          </a:prstGeom>
-          <a:noFill/>
-        </p:spPr>
-        <p:txBody>
-          <a:bodyPr wrap="square">
-            <a:spAutoFit/>
-          </a:bodyPr>
-          <a:lstStyle/>
-          <a:p>
-            <a:pPr>
-              <a:defRPr sz="2500" b="1">
-                <a:solidFill>
-                  <a:srgbClr val="161616"/>
-                </a:solidFill>
-                <a:latin typeface="Aptos"/>
-              </a:defRPr>
-            </a:pPr>
-            <a:r>
-              <a:t>tau_g = -(M g l + m g l / 2) sin(theta)</a:t>
-            </a:r>
-          </a:p>
-        </p:txBody>
-      </p:sp>
+      <p:pic>
+        <p:nvPicPr>
+          <p:cNvPr id="9" name="Picture 8" descr="gravity_torque-black.png"/>
+          <p:cNvPicPr>
+            <a:picLocks noChangeAspect="1"/>
+          </p:cNvPicPr>
+          <p:nvPr/>
+        </p:nvPicPr>
+        <p:blipFill>
+          <a:blip r:embed="rId4"/>
+          <a:stretch>
+            <a:fillRect/>
+          </a:stretch>
+        </p:blipFill>
+        <p:spPr>
+          <a:xfrm>
+            <a:off x="4315968" y="3310128"/>
+            <a:ext cx="5852160" cy="731520"/>
+          </a:xfrm>
+          <a:prstGeom prst="rect">
+            <a:avLst/>
+          </a:prstGeom>
+        </p:spPr>
+      </p:pic>
       <p:sp>
         <p:nvSpPr>
           <p:cNvPr id="10" name="TextBox 9"/>
@@ -7855,16 +7747,40 @@
           </a:p>
         </p:txBody>
       </p:sp>
-      <p:sp>
-        <p:nvSpPr>
-          <p:cNvPr id="5" name="TextBox 4"/>
-          <p:cNvSpPr txBox="1"/>
-          <p:nvPr/>
-        </p:nvSpPr>
-        <p:spPr>
-          <a:xfrm>
-            <a:off x="411480" y="1508760"/>
-            <a:ext cx="11338560" cy="685800"/>
+      <p:pic>
+        <p:nvPicPr>
+          <p:cNvPr id="5" name="Picture 4" descr="compound_eom-black.png"/>
+          <p:cNvPicPr>
+            <a:picLocks noChangeAspect="1"/>
+          </p:cNvPicPr>
+          <p:nvPr/>
+        </p:nvPicPr>
+        <p:blipFill>
+          <a:blip r:embed="rId2"/>
+          <a:stretch>
+            <a:fillRect/>
+          </a:stretch>
+        </p:blipFill>
+        <p:spPr>
+          <a:xfrm>
+            <a:off x="1005840" y="1481328"/>
+            <a:ext cx="10149840" cy="731520"/>
+          </a:xfrm>
+          <a:prstGeom prst="rect">
+            <a:avLst/>
+          </a:prstGeom>
+        </p:spPr>
+      </p:pic>
+      <p:sp>
+        <p:nvSpPr>
+          <p:cNvPr id="6" name="TextBox 5"/>
+          <p:cNvSpPr txBox="1"/>
+          <p:nvPr/>
+        </p:nvSpPr>
+        <p:spPr>
+          <a:xfrm>
+            <a:off x="640080" y="2514600"/>
+            <a:ext cx="10972800" cy="411480"/>
           </a:xfrm>
           <a:prstGeom prst="rect">
             <a:avLst/>
@@ -7878,7 +7794,7 @@
           <a:lstStyle/>
           <a:p>
             <a:pPr algn="ctr">
-              <a:defRPr sz="2300" b="1">
+              <a:defRPr sz="2200" b="1">
                 <a:solidFill>
                   <a:srgbClr val="881C1C"/>
                 </a:solidFill>
@@ -7886,57 +7802,69 @@
               </a:defRPr>
             </a:pPr>
             <a:r>
-              <a:t>(M l^2 + m l^2/3) theta_double_dot + (M g l + m g l/2) sin(theta) = 0</a:t>
-            </a:r>
-          </a:p>
-        </p:txBody>
-      </p:sp>
-      <p:sp>
-        <p:nvSpPr>
-          <p:cNvPr id="6" name="TextBox 5"/>
-          <p:cNvSpPr txBox="1"/>
-          <p:nvPr/>
-        </p:nvSpPr>
-        <p:spPr>
-          <a:xfrm>
-            <a:off x="640080" y="2606040"/>
-            <a:ext cx="10972800" cy="685800"/>
-          </a:xfrm>
-          <a:prstGeom prst="rect">
-            <a:avLst/>
-          </a:prstGeom>
-          <a:noFill/>
-        </p:spPr>
-        <p:txBody>
-          <a:bodyPr wrap="square">
-            <a:spAutoFit/>
-          </a:bodyPr>
-          <a:lstStyle/>
-          <a:p>
-            <a:pPr algn="ctr">
-              <a:defRPr sz="2500" b="1">
-                <a:solidFill>
-                  <a:srgbClr val="161616"/>
-                </a:solidFill>
-                <a:latin typeface="Aptos"/>
-              </a:defRPr>
-            </a:pPr>
-            <a:r>
-              <a:t>Small angle: omega_n^2 = g(M + m/2) / [l(M + m/3)]</a:t>
-            </a:r>
-          </a:p>
-        </p:txBody>
-      </p:sp>
-      <p:sp>
-        <p:nvSpPr>
-          <p:cNvPr id="7" name="TextBox 6"/>
-          <p:cNvSpPr txBox="1"/>
-          <p:nvPr/>
-        </p:nvSpPr>
-        <p:spPr>
-          <a:xfrm>
-            <a:off x="960120" y="3794760"/>
-            <a:ext cx="10058400" cy="1645920"/>
+              <a:t>Small-angle approximation</a:t>
+            </a:r>
+          </a:p>
+        </p:txBody>
+      </p:sp>
+      <p:pic>
+        <p:nvPicPr>
+          <p:cNvPr id="7" name="Picture 6" descr="small_angle-black.png"/>
+          <p:cNvPicPr>
+            <a:picLocks noChangeAspect="1"/>
+          </p:cNvPicPr>
+          <p:nvPr/>
+        </p:nvPicPr>
+        <p:blipFill>
+          <a:blip r:embed="rId3"/>
+          <a:stretch>
+            <a:fillRect/>
+          </a:stretch>
+        </p:blipFill>
+        <p:spPr>
+          <a:xfrm>
+            <a:off x="2148840" y="2971800"/>
+            <a:ext cx="7909560" cy="731520"/>
+          </a:xfrm>
+          <a:prstGeom prst="rect">
+            <a:avLst/>
+          </a:prstGeom>
+        </p:spPr>
+      </p:pic>
+      <p:pic>
+        <p:nvPicPr>
+          <p:cNvPr id="8" name="Picture 7" descr="frequency_period-black.png"/>
+          <p:cNvPicPr>
+            <a:picLocks noChangeAspect="1"/>
+          </p:cNvPicPr>
+          <p:nvPr/>
+        </p:nvPicPr>
+        <p:blipFill>
+          <a:blip r:embed="rId4"/>
+          <a:stretch>
+            <a:fillRect/>
+          </a:stretch>
+        </p:blipFill>
+        <p:spPr>
+          <a:xfrm>
+            <a:off x="3886200" y="3886200"/>
+            <a:ext cx="4389120" cy="640080"/>
+          </a:xfrm>
+          <a:prstGeom prst="rect">
+            <a:avLst/>
+          </a:prstGeom>
+        </p:spPr>
+      </p:pic>
+      <p:sp>
+        <p:nvSpPr>
+          <p:cNvPr id="9" name="TextBox 8"/>
+          <p:cNvSpPr txBox="1"/>
+          <p:nvPr/>
+        </p:nvSpPr>
+        <p:spPr>
+          <a:xfrm>
+            <a:off x="960120" y="4709160"/>
+            <a:ext cx="10058400" cy="1325880"/>
           </a:xfrm>
           <a:prstGeom prst="rect">
             <a:avLst/>
@@ -7953,7 +7881,7 @@
               <a:spcAft>
                 <a:spcPts val="1100"/>
               </a:spcAft>
-              <a:defRPr sz="2000">
+              <a:defRPr sz="1800">
                 <a:solidFill>
                   <a:srgbClr val="161616"/>
                 </a:solidFill>
@@ -7969,15 +7897,15 @@
               <a:spcAft>
                 <a:spcPts val="1100"/>
               </a:spcAft>
-              <a:defRPr sz="2000">
-                <a:solidFill>
-                  <a:srgbClr val="161616"/>
-                </a:solidFill>
-                <a:latin typeface="Aptos"/>
-              </a:defRPr>
-            </a:pPr>
-            <a:r>
-              <a:t>sqrt(g/l) applies only when bar mass is negligible.</a:t>
+              <a:defRPr sz="1800">
+                <a:solidFill>
+                  <a:srgbClr val="161616"/>
+                </a:solidFill>
+                <a:latin typeface="Aptos"/>
+              </a:defRPr>
+            </a:pPr>
+            <a:r>
+              <a:t>The point-mass formula applies only when bar mass is negligible.</a:t>
             </a:r>
           </a:p>
           <a:p>
@@ -7985,7 +7913,7 @@
               <a:spcAft>
                 <a:spcPts val="1100"/>
               </a:spcAft>
-              <a:defRPr sz="2000">
+              <a:defRPr sz="1800">
                 <a:solidFill>
                   <a:srgbClr val="161616"/>
                 </a:solidFill>
@@ -8361,42 +8289,30 @@
           </a:p>
         </p:txBody>
       </p:sp>
-      <p:sp>
-        <p:nvSpPr>
-          <p:cNvPr id="5" name="TextBox 4"/>
-          <p:cNvSpPr txBox="1"/>
-          <p:nvPr/>
-        </p:nvSpPr>
-        <p:spPr>
-          <a:xfrm>
-            <a:off x="411480" y="1508760"/>
-            <a:ext cx="11338560" cy="777240"/>
-          </a:xfrm>
-          <a:prstGeom prst="rect">
-            <a:avLst/>
-          </a:prstGeom>
-          <a:noFill/>
-        </p:spPr>
-        <p:txBody>
-          <a:bodyPr wrap="square">
-            <a:spAutoFit/>
-          </a:bodyPr>
-          <a:lstStyle/>
-          <a:p>
-            <a:pPr algn="ctr">
-              <a:defRPr sz="2200" b="1">
-                <a:solidFill>
-                  <a:srgbClr val="881C1C"/>
-                </a:solidFill>
-                <a:latin typeface="Aptos"/>
-              </a:defRPr>
-            </a:pPr>
-            <a:r>
-              <a:t>E = 1/2 (M l^2 + m l^2/3) omega^2 + (M g l + m g l/2)(1 - cos(theta))</a:t>
-            </a:r>
-          </a:p>
-        </p:txBody>
-      </p:sp>
+      <p:pic>
+        <p:nvPicPr>
+          <p:cNvPr id="5" name="Picture 4" descr="energy-black.png"/>
+          <p:cNvPicPr>
+            <a:picLocks noChangeAspect="1"/>
+          </p:cNvPicPr>
+          <p:nvPr/>
+        </p:nvPicPr>
+        <p:blipFill>
+          <a:blip r:embed="rId2"/>
+          <a:stretch>
+            <a:fillRect/>
+          </a:stretch>
+        </p:blipFill>
+        <p:spPr>
+          <a:xfrm>
+            <a:off x="1005840" y="1481328"/>
+            <a:ext cx="10149840" cy="822960"/>
+          </a:xfrm>
+          <a:prstGeom prst="rect">
+            <a:avLst/>
+          </a:prstGeom>
+        </p:spPr>
+      </p:pic>
       <p:sp>
         <p:nvSpPr>
           <p:cNvPr id="6" name="TextBox 5"/>

</xml_diff>

<commit_message>
Fix Lab 2 mathematical subscripts
</commit_message>
<xml_diff>
--- a/site/docs/MIE402_Lecture03_Single_Pendulum_PreLab2_Fall2026.pptx
+++ b/site/docs/MIE402_Lecture03_Single_Pendulum_PreLab2_Fall2026.pptx
@@ -2,35 +2,35 @@
 <file path=ppt/presentation.xml><?xml version="1.0" encoding="utf-8"?>
 <p:presentation xmlns:p="http://schemas.openxmlformats.org/presentationml/2006/main">
   <p:sldMasterIdLst>
-    <p:sldMasterId xmlns:r="http://schemas.openxmlformats.org/officeDocument/2006/relationships" id="2147483648" r:id="R705d1e78f7c54323"/>
+    <p:sldMasterId xmlns:r="http://schemas.openxmlformats.org/officeDocument/2006/relationships" id="2147483648" r:id="R32d718e7365144c1"/>
   </p:sldMasterIdLst>
   <p:notesMasterIdLst>
-    <p:notesMasterId xmlns:r="http://schemas.openxmlformats.org/officeDocument/2006/relationships" r:id="Re80ee75307c04353"/>
+    <p:notesMasterId xmlns:r="http://schemas.openxmlformats.org/officeDocument/2006/relationships" r:id="Rfe8c08c44ff54536"/>
   </p:notesMasterIdLst>
   <p:sldIdLst>
-    <p:sldId xmlns:r="http://schemas.openxmlformats.org/officeDocument/2006/relationships" id="256" r:id="R459b9d9510b54ce7"/>
-    <p:sldId xmlns:r="http://schemas.openxmlformats.org/officeDocument/2006/relationships" id="257" r:id="R19e0787bf168422f"/>
-    <p:sldId xmlns:r="http://schemas.openxmlformats.org/officeDocument/2006/relationships" id="258" r:id="Re5a7a4d2a64d4625"/>
-    <p:sldId xmlns:r="http://schemas.openxmlformats.org/officeDocument/2006/relationships" id="259" r:id="R11deb5d7fdb54284"/>
-    <p:sldId xmlns:r="http://schemas.openxmlformats.org/officeDocument/2006/relationships" id="260" r:id="R578b181e5bc54aae"/>
-    <p:sldId xmlns:r="http://schemas.openxmlformats.org/officeDocument/2006/relationships" id="261" r:id="Rd3bf704b48864ca5"/>
-    <p:sldId xmlns:r="http://schemas.openxmlformats.org/officeDocument/2006/relationships" id="262" r:id="Re8661538eb3a40c8"/>
-    <p:sldId xmlns:r="http://schemas.openxmlformats.org/officeDocument/2006/relationships" id="263" r:id="Re71f00c7d19a49a7"/>
-    <p:sldId xmlns:r="http://schemas.openxmlformats.org/officeDocument/2006/relationships" id="264" r:id="R2c84f487cae64f1b"/>
-    <p:sldId xmlns:r="http://schemas.openxmlformats.org/officeDocument/2006/relationships" id="265" r:id="R8cbd32886f254e4b"/>
-    <p:sldId xmlns:r="http://schemas.openxmlformats.org/officeDocument/2006/relationships" id="266" r:id="Rbdeea36648554619"/>
-    <p:sldId xmlns:r="http://schemas.openxmlformats.org/officeDocument/2006/relationships" id="267" r:id="R9840732acfca4068"/>
-    <p:sldId xmlns:r="http://schemas.openxmlformats.org/officeDocument/2006/relationships" id="268" r:id="R11db3aba3ab14acc"/>
-    <p:sldId xmlns:r="http://schemas.openxmlformats.org/officeDocument/2006/relationships" id="269" r:id="R250f72380aaa4471"/>
-    <p:sldId xmlns:r="http://schemas.openxmlformats.org/officeDocument/2006/relationships" id="270" r:id="R32f69cad735b41f3"/>
-    <p:sldId xmlns:r="http://schemas.openxmlformats.org/officeDocument/2006/relationships" id="271" r:id="R74147a3b5d744b4a"/>
-    <p:sldId xmlns:r="http://schemas.openxmlformats.org/officeDocument/2006/relationships" id="272" r:id="Rbeee116eb043464c"/>
-    <p:sldId xmlns:r="http://schemas.openxmlformats.org/officeDocument/2006/relationships" id="273" r:id="Rd1eab79a2d984cc5"/>
-    <p:sldId xmlns:r="http://schemas.openxmlformats.org/officeDocument/2006/relationships" id="274" r:id="R569f9b730bec4178"/>
-    <p:sldId xmlns:r="http://schemas.openxmlformats.org/officeDocument/2006/relationships" id="275" r:id="Rc520d36a20a4435a"/>
-    <p:sldId xmlns:r="http://schemas.openxmlformats.org/officeDocument/2006/relationships" id="276" r:id="Ree8ca7cdf8524821"/>
-    <p:sldId xmlns:r="http://schemas.openxmlformats.org/officeDocument/2006/relationships" id="277" r:id="Re6352200d902410a"/>
-    <p:sldId xmlns:r="http://schemas.openxmlformats.org/officeDocument/2006/relationships" id="278" r:id="Rb21ae92e512947fc"/>
+    <p:sldId xmlns:r="http://schemas.openxmlformats.org/officeDocument/2006/relationships" id="256" r:id="R075847576449453e"/>
+    <p:sldId xmlns:r="http://schemas.openxmlformats.org/officeDocument/2006/relationships" id="257" r:id="Rfe6bbad9fa51420a"/>
+    <p:sldId xmlns:r="http://schemas.openxmlformats.org/officeDocument/2006/relationships" id="258" r:id="R5160e48033034ce2"/>
+    <p:sldId xmlns:r="http://schemas.openxmlformats.org/officeDocument/2006/relationships" id="259" r:id="Rdd6fad00e02d4644"/>
+    <p:sldId xmlns:r="http://schemas.openxmlformats.org/officeDocument/2006/relationships" id="260" r:id="R2f43aed275964f9c"/>
+    <p:sldId xmlns:r="http://schemas.openxmlformats.org/officeDocument/2006/relationships" id="261" r:id="Re6409a0e18284693"/>
+    <p:sldId xmlns:r="http://schemas.openxmlformats.org/officeDocument/2006/relationships" id="262" r:id="R8b1202da63c84e8a"/>
+    <p:sldId xmlns:r="http://schemas.openxmlformats.org/officeDocument/2006/relationships" id="263" r:id="R4c7e43418db0403d"/>
+    <p:sldId xmlns:r="http://schemas.openxmlformats.org/officeDocument/2006/relationships" id="264" r:id="R7f5e4a3861c240ed"/>
+    <p:sldId xmlns:r="http://schemas.openxmlformats.org/officeDocument/2006/relationships" id="265" r:id="R0eb4c56f60964f1a"/>
+    <p:sldId xmlns:r="http://schemas.openxmlformats.org/officeDocument/2006/relationships" id="266" r:id="Rc9c51067e5fc4434"/>
+    <p:sldId xmlns:r="http://schemas.openxmlformats.org/officeDocument/2006/relationships" id="267" r:id="R89a3e4c9e6ba4663"/>
+    <p:sldId xmlns:r="http://schemas.openxmlformats.org/officeDocument/2006/relationships" id="268" r:id="R96e9d7aecc064467"/>
+    <p:sldId xmlns:r="http://schemas.openxmlformats.org/officeDocument/2006/relationships" id="269" r:id="Re10b022b88c14d78"/>
+    <p:sldId xmlns:r="http://schemas.openxmlformats.org/officeDocument/2006/relationships" id="270" r:id="Rdf93e799a2564a9c"/>
+    <p:sldId xmlns:r="http://schemas.openxmlformats.org/officeDocument/2006/relationships" id="271" r:id="Rf61920805d0c44ac"/>
+    <p:sldId xmlns:r="http://schemas.openxmlformats.org/officeDocument/2006/relationships" id="272" r:id="R39bd5142da1343b5"/>
+    <p:sldId xmlns:r="http://schemas.openxmlformats.org/officeDocument/2006/relationships" id="273" r:id="R4c9332caf3fb45c2"/>
+    <p:sldId xmlns:r="http://schemas.openxmlformats.org/officeDocument/2006/relationships" id="274" r:id="R3b9a8c00bb9c4cee"/>
+    <p:sldId xmlns:r="http://schemas.openxmlformats.org/officeDocument/2006/relationships" id="275" r:id="Rcfa4bae7c81045eb"/>
+    <p:sldId xmlns:r="http://schemas.openxmlformats.org/officeDocument/2006/relationships" id="276" r:id="Rfccd0b24add142ae"/>
+    <p:sldId xmlns:r="http://schemas.openxmlformats.org/officeDocument/2006/relationships" id="277" r:id="Ra96693f47a614dea"/>
+    <p:sldId xmlns:r="http://schemas.openxmlformats.org/officeDocument/2006/relationships" id="278" r:id="R80eff10132a54375"/>
   </p:sldIdLst>
   <p:sldSz cx="12191695" cy="6858000"/>
   <p:notesSz cx="6858000" cy="9144000"/>
@@ -4990,17 +4990,17 @@
   </p:cSld>
   <p:clrMap bg1="lt1" tx1="dk1" bg2="lt2" tx2="dk2" accent1="accent1" accent2="accent2" accent3="accent3" accent4="accent4" accent5="accent5" accent6="accent6" hlink="hlink" folHlink="folHlink"/>
   <p:sldLayoutIdLst>
-    <p:sldLayoutId xmlns:r="http://schemas.openxmlformats.org/officeDocument/2006/relationships" id="2147483649" r:id="R6100ae115826421e"/>
-    <p:sldLayoutId xmlns:r="http://schemas.openxmlformats.org/officeDocument/2006/relationships" id="2147483650" r:id="Rfa67fd666351408a"/>
-    <p:sldLayoutId xmlns:r="http://schemas.openxmlformats.org/officeDocument/2006/relationships" id="2147483651" r:id="Rfcdd60e3f7e640c6"/>
-    <p:sldLayoutId xmlns:r="http://schemas.openxmlformats.org/officeDocument/2006/relationships" id="2147483652" r:id="R453915a515fd4632"/>
-    <p:sldLayoutId xmlns:r="http://schemas.openxmlformats.org/officeDocument/2006/relationships" id="2147483653" r:id="Rde44d2c478834a63"/>
-    <p:sldLayoutId xmlns:r="http://schemas.openxmlformats.org/officeDocument/2006/relationships" id="2147483654" r:id="Rdfff4e857ff8463f"/>
-    <p:sldLayoutId xmlns:r="http://schemas.openxmlformats.org/officeDocument/2006/relationships" id="2147483655" r:id="R27c8602646934c85"/>
-    <p:sldLayoutId xmlns:r="http://schemas.openxmlformats.org/officeDocument/2006/relationships" id="2147483656" r:id="R655320bc730744d7"/>
-    <p:sldLayoutId xmlns:r="http://schemas.openxmlformats.org/officeDocument/2006/relationships" id="2147483657" r:id="R44fc308142b64f84"/>
-    <p:sldLayoutId xmlns:r="http://schemas.openxmlformats.org/officeDocument/2006/relationships" id="2147483658" r:id="R54f1f58cd09c4686"/>
-    <p:sldLayoutId xmlns:r="http://schemas.openxmlformats.org/officeDocument/2006/relationships" id="2147483659" r:id="Rc5bc924c43d74637"/>
+    <p:sldLayoutId xmlns:r="http://schemas.openxmlformats.org/officeDocument/2006/relationships" id="2147483649" r:id="R561899b9b7a64c79"/>
+    <p:sldLayoutId xmlns:r="http://schemas.openxmlformats.org/officeDocument/2006/relationships" id="2147483650" r:id="R5ee860e3975f4169"/>
+    <p:sldLayoutId xmlns:r="http://schemas.openxmlformats.org/officeDocument/2006/relationships" id="2147483651" r:id="R8af448a1681e4547"/>
+    <p:sldLayoutId xmlns:r="http://schemas.openxmlformats.org/officeDocument/2006/relationships" id="2147483652" r:id="R61b4aa9e809a4fec"/>
+    <p:sldLayoutId xmlns:r="http://schemas.openxmlformats.org/officeDocument/2006/relationships" id="2147483653" r:id="Re0229243e6004ee9"/>
+    <p:sldLayoutId xmlns:r="http://schemas.openxmlformats.org/officeDocument/2006/relationships" id="2147483654" r:id="Rbeac01b3002e4ac5"/>
+    <p:sldLayoutId xmlns:r="http://schemas.openxmlformats.org/officeDocument/2006/relationships" id="2147483655" r:id="Rd129fdb6da384943"/>
+    <p:sldLayoutId xmlns:r="http://schemas.openxmlformats.org/officeDocument/2006/relationships" id="2147483656" r:id="R057d1b1183134c93"/>
+    <p:sldLayoutId xmlns:r="http://schemas.openxmlformats.org/officeDocument/2006/relationships" id="2147483657" r:id="R2040e22ebaa842d2"/>
+    <p:sldLayoutId xmlns:r="http://schemas.openxmlformats.org/officeDocument/2006/relationships" id="2147483658" r:id="Ra0848537bc9d49ed"/>
+    <p:sldLayoutId xmlns:r="http://schemas.openxmlformats.org/officeDocument/2006/relationships" id="2147483659" r:id="R5c023467dec941de"/>
   </p:sldLayoutIdLst>
   <p:txStyles>
     <p:titleStyle>
@@ -5785,7 +5785,7 @@
           <p:nvPr/>
         </p:nvPicPr>
         <p:blipFill>
-          <a:blip xmlns:r="http://schemas.openxmlformats.org/officeDocument/2006/relationships" xmlns:a="http://schemas.openxmlformats.org/drawingml/2006/main" r:embed="R3c0795da5bc14dd5"/>
+          <a:blip xmlns:r="http://schemas.openxmlformats.org/officeDocument/2006/relationships" xmlns:a="http://schemas.openxmlformats.org/drawingml/2006/main" r:embed="R395dd43927cd4e36"/>
           <a:stretch xmlns:a="http://schemas.openxmlformats.org/drawingml/2006/main">
             <a:fillRect l="0" t="0" r="0" b="0"/>
           </a:stretch>
@@ -5972,7 +5972,7 @@
           <p:nvPr/>
         </p:nvPicPr>
         <p:blipFill>
-          <a:blip xmlns:r="http://schemas.openxmlformats.org/officeDocument/2006/relationships" xmlns:a="http://schemas.openxmlformats.org/drawingml/2006/main" r:embed="R327130831cfa471a"/>
+          <a:blip xmlns:r="http://schemas.openxmlformats.org/officeDocument/2006/relationships" xmlns:a="http://schemas.openxmlformats.org/drawingml/2006/main" r:embed="R4c4feb5d7a334c4a"/>
           <a:stretch xmlns:a="http://schemas.openxmlformats.org/drawingml/2006/main">
             <a:fillRect l="0" t="0" r="0" b="0"/>
           </a:stretch>
@@ -5996,7 +5996,7 @@
           <p:nvPr/>
         </p:nvPicPr>
         <p:blipFill>
-          <a:blip xmlns:r="http://schemas.openxmlformats.org/officeDocument/2006/relationships" xmlns:a="http://schemas.openxmlformats.org/drawingml/2006/main" r:embed="Rc6097b7c99a5488a"/>
+          <a:blip xmlns:r="http://schemas.openxmlformats.org/officeDocument/2006/relationships" xmlns:a="http://schemas.openxmlformats.org/drawingml/2006/main" r:embed="Rcefb38400b774397"/>
           <a:stretch xmlns:a="http://schemas.openxmlformats.org/drawingml/2006/main">
             <a:fillRect l="0" t="0" r="0" b="0"/>
           </a:stretch>
@@ -6397,7 +6397,7 @@
           <p:nvPr/>
         </p:nvPicPr>
         <p:blipFill>
-          <a:blip xmlns:r="http://schemas.openxmlformats.org/officeDocument/2006/relationships" xmlns:a="http://schemas.openxmlformats.org/drawingml/2006/main" r:embed="R7bb76632fdb34889"/>
+          <a:blip xmlns:r="http://schemas.openxmlformats.org/officeDocument/2006/relationships" xmlns:a="http://schemas.openxmlformats.org/drawingml/2006/main" r:embed="R89cb9043138b4c03"/>
           <a:stretch xmlns:a="http://schemas.openxmlformats.org/drawingml/2006/main">
             <a:fillRect l="0" t="0" r="0" b="0"/>
           </a:stretch>
@@ -6584,7 +6584,7 @@
           <p:nvPr/>
         </p:nvPicPr>
         <p:blipFill>
-          <a:blip xmlns:r="http://schemas.openxmlformats.org/officeDocument/2006/relationships" xmlns:a="http://schemas.openxmlformats.org/drawingml/2006/main" r:embed="Rec6e4b6e993e494d"/>
+          <a:blip xmlns:r="http://schemas.openxmlformats.org/officeDocument/2006/relationships" xmlns:a="http://schemas.openxmlformats.org/drawingml/2006/main" r:embed="Rf602d4d4b0674e3a"/>
           <a:stretch xmlns:a="http://schemas.openxmlformats.org/drawingml/2006/main">
             <a:fillRect l="0" t="0" r="0" b="0"/>
           </a:stretch>
@@ -6878,7 +6878,7 @@
           <p:nvPr/>
         </p:nvPicPr>
         <p:blipFill>
-          <a:blip xmlns:r="http://schemas.openxmlformats.org/officeDocument/2006/relationships" xmlns:a="http://schemas.openxmlformats.org/drawingml/2006/main" r:embed="Re270618635ec4f77"/>
+          <a:blip xmlns:r="http://schemas.openxmlformats.org/officeDocument/2006/relationships" xmlns:a="http://schemas.openxmlformats.org/drawingml/2006/main" r:embed="Rab8bf088c64849a1"/>
           <a:stretch xmlns:a="http://schemas.openxmlformats.org/drawingml/2006/main">
             <a:fillRect l="0" t="0" r="0" b="0"/>
           </a:stretch>
@@ -6902,7 +6902,7 @@
           <p:nvPr/>
         </p:nvPicPr>
         <p:blipFill>
-          <a:blip xmlns:r="http://schemas.openxmlformats.org/officeDocument/2006/relationships" xmlns:a="http://schemas.openxmlformats.org/drawingml/2006/main" r:embed="R3273f10aa3e048b6"/>
+          <a:blip xmlns:r="http://schemas.openxmlformats.org/officeDocument/2006/relationships" xmlns:a="http://schemas.openxmlformats.org/drawingml/2006/main" r:embed="Rd331f85696fa4763"/>
           <a:stretch xmlns:a="http://schemas.openxmlformats.org/drawingml/2006/main">
             <a:fillRect l="0" t="0" r="0" b="0"/>
           </a:stretch>
@@ -7196,7 +7196,7 @@
           <p:nvPr/>
         </p:nvPicPr>
         <p:blipFill>
-          <a:blip xmlns:r="http://schemas.openxmlformats.org/officeDocument/2006/relationships" xmlns:a="http://schemas.openxmlformats.org/drawingml/2006/main" r:embed="R10e84a884bee4311"/>
+          <a:blip xmlns:r="http://schemas.openxmlformats.org/officeDocument/2006/relationships" xmlns:a="http://schemas.openxmlformats.org/drawingml/2006/main" r:embed="R4b2045c0dd18448c"/>
           <a:stretch xmlns:a="http://schemas.openxmlformats.org/drawingml/2006/main">
             <a:fillRect l="0" t="0" r="0" b="0"/>
           </a:stretch>
@@ -7471,7 +7471,7 @@
           <p:nvPr/>
         </p:nvPicPr>
         <p:blipFill>
-          <a:blip xmlns:r="http://schemas.openxmlformats.org/officeDocument/2006/relationships" xmlns:a="http://schemas.openxmlformats.org/drawingml/2006/main" r:embed="Rb2c1ce3c778744f8"/>
+          <a:blip xmlns:r="http://schemas.openxmlformats.org/officeDocument/2006/relationships" xmlns:a="http://schemas.openxmlformats.org/drawingml/2006/main" r:embed="R1d1743e7c3594cab"/>
           <a:stretch xmlns:a="http://schemas.openxmlformats.org/drawingml/2006/main">
             <a:fillRect l="0" t="0" r="0" b="0"/>
           </a:stretch>
@@ -7872,7 +7872,7 @@
           <p:nvPr/>
         </p:nvPicPr>
         <p:blipFill>
-          <a:blip xmlns:r="http://schemas.openxmlformats.org/officeDocument/2006/relationships" xmlns:a="http://schemas.openxmlformats.org/drawingml/2006/main" r:embed="R01bfc0f98b7a4d07"/>
+          <a:blip xmlns:r="http://schemas.openxmlformats.org/officeDocument/2006/relationships" xmlns:a="http://schemas.openxmlformats.org/drawingml/2006/main" r:embed="Ra7d9f27a75c94800"/>
           <a:stretch xmlns:a="http://schemas.openxmlformats.org/drawingml/2006/main">
             <a:fillRect l="0" t="0" r="0" b="0"/>
           </a:stretch>
@@ -7896,7 +7896,7 @@
           <p:nvPr/>
         </p:nvPicPr>
         <p:blipFill>
-          <a:blip xmlns:r="http://schemas.openxmlformats.org/officeDocument/2006/relationships" xmlns:a="http://schemas.openxmlformats.org/drawingml/2006/main" r:embed="Rd9771c8d99df460a"/>
+          <a:blip xmlns:r="http://schemas.openxmlformats.org/officeDocument/2006/relationships" xmlns:a="http://schemas.openxmlformats.org/drawingml/2006/main" r:embed="R5a0268b2203c4a7c"/>
           <a:stretch xmlns:a="http://schemas.openxmlformats.org/drawingml/2006/main">
             <a:fillRect l="0" t="0" r="0" b="0"/>
           </a:stretch>
@@ -9057,7 +9057,7 @@
           <p:nvPr/>
         </p:nvPicPr>
         <p:blipFill>
-          <a:blip xmlns:r="http://schemas.openxmlformats.org/officeDocument/2006/relationships" xmlns:a="http://schemas.openxmlformats.org/drawingml/2006/main" r:embed="R282a6f1b35514520"/>
+          <a:blip xmlns:r="http://schemas.openxmlformats.org/officeDocument/2006/relationships" xmlns:a="http://schemas.openxmlformats.org/drawingml/2006/main" r:embed="R4fbbe05f7d1d4fb2"/>
           <a:stretch xmlns:a="http://schemas.openxmlformats.org/drawingml/2006/main">
             <a:fillRect l="0" t="0" r="0" b="0"/>
           </a:stretch>
@@ -10388,7 +10388,7 @@
           <p:nvPr/>
         </p:nvPicPr>
         <p:blipFill>
-          <a:blip xmlns:r="http://schemas.openxmlformats.org/officeDocument/2006/relationships" xmlns:a="http://schemas.openxmlformats.org/drawingml/2006/main" r:embed="R6070dc78ae8840c5"/>
+          <a:blip xmlns:r="http://schemas.openxmlformats.org/officeDocument/2006/relationships" xmlns:a="http://schemas.openxmlformats.org/drawingml/2006/main" r:embed="R8cd9ddf76cc148ff"/>
           <a:stretch xmlns:a="http://schemas.openxmlformats.org/drawingml/2006/main"/>
         </p:blipFill>
         <p:spPr>
@@ -10581,7 +10581,7 @@
           <p:nvPr/>
         </p:nvPicPr>
         <p:blipFill>
-          <a:blip xmlns:r="http://schemas.openxmlformats.org/officeDocument/2006/relationships" xmlns:a="http://schemas.openxmlformats.org/drawingml/2006/main" r:embed="R75cac146836b4a66"/>
+          <a:blip xmlns:r="http://schemas.openxmlformats.org/officeDocument/2006/relationships" xmlns:a="http://schemas.openxmlformats.org/drawingml/2006/main" r:embed="Rf206b403efe647f1"/>
           <a:stretch xmlns:a="http://schemas.openxmlformats.org/drawingml/2006/main">
             <a:fillRect l="0" t="0" r="0" b="0"/>
           </a:stretch>
@@ -10605,7 +10605,7 @@
           <p:nvPr/>
         </p:nvPicPr>
         <p:blipFill>
-          <a:blip xmlns:r="http://schemas.openxmlformats.org/officeDocument/2006/relationships" xmlns:a="http://schemas.openxmlformats.org/drawingml/2006/main" r:embed="R1caf5bb1c1f04b25"/>
+          <a:blip xmlns:r="http://schemas.openxmlformats.org/officeDocument/2006/relationships" xmlns:a="http://schemas.openxmlformats.org/drawingml/2006/main" r:embed="Ra2058615793946cd"/>
           <a:stretch xmlns:a="http://schemas.openxmlformats.org/drawingml/2006/main">
             <a:fillRect l="0" t="0" r="0" b="0"/>
           </a:stretch>
@@ -10858,7 +10858,7 @@
           <p:nvPr/>
         </p:nvPicPr>
         <p:blipFill>
-          <a:blip xmlns:r="http://schemas.openxmlformats.org/officeDocument/2006/relationships" xmlns:a="http://schemas.openxmlformats.org/drawingml/2006/main" r:embed="R4f860b8924014fc5"/>
+          <a:blip xmlns:r="http://schemas.openxmlformats.org/officeDocument/2006/relationships" xmlns:a="http://schemas.openxmlformats.org/drawingml/2006/main" r:embed="Recf0ca4670e443f1"/>
           <a:stretch xmlns:a="http://schemas.openxmlformats.org/drawingml/2006/main">
             <a:fillRect l="0" t="0" r="0" b="0"/>
           </a:stretch>
@@ -10929,7 +10929,7 @@
           <p:nvPr/>
         </p:nvPicPr>
         <p:blipFill>
-          <a:blip xmlns:r="http://schemas.openxmlformats.org/officeDocument/2006/relationships" xmlns:a="http://schemas.openxmlformats.org/drawingml/2006/main" r:embed="R1dc76c9cca0446b5"/>
+          <a:blip xmlns:r="http://schemas.openxmlformats.org/officeDocument/2006/relationships" xmlns:a="http://schemas.openxmlformats.org/drawingml/2006/main" r:embed="Rb4e8cfaf3d7c41b5"/>
           <a:stretch xmlns:a="http://schemas.openxmlformats.org/drawingml/2006/main">
             <a:fillRect l="0" t="0" r="0" b="0"/>
           </a:stretch>
@@ -11000,7 +11000,7 @@
           <p:nvPr/>
         </p:nvPicPr>
         <p:blipFill>
-          <a:blip xmlns:r="http://schemas.openxmlformats.org/officeDocument/2006/relationships" xmlns:a="http://schemas.openxmlformats.org/drawingml/2006/main" r:embed="R48ca4ce637834b3c"/>
+          <a:blip xmlns:r="http://schemas.openxmlformats.org/officeDocument/2006/relationships" xmlns:a="http://schemas.openxmlformats.org/drawingml/2006/main" r:embed="R573a7489fd954872"/>
           <a:stretch xmlns:a="http://schemas.openxmlformats.org/drawingml/2006/main">
             <a:fillRect l="0" t="0" r="0" b="0"/>
           </a:stretch>
@@ -11250,7 +11250,7 @@
           <p:nvPr/>
         </p:nvPicPr>
         <p:blipFill>
-          <a:blip xmlns:r="http://schemas.openxmlformats.org/officeDocument/2006/relationships" xmlns:a="http://schemas.openxmlformats.org/drawingml/2006/main" r:embed="R659ba146cdbf4553"/>
+          <a:blip xmlns:r="http://schemas.openxmlformats.org/officeDocument/2006/relationships" xmlns:a="http://schemas.openxmlformats.org/drawingml/2006/main" r:embed="R628f2c221bf54d19"/>
           <a:stretch xmlns:a="http://schemas.openxmlformats.org/drawingml/2006/main">
             <a:fillRect l="0" t="0" r="0" b="0"/>
           </a:stretch>
@@ -11321,7 +11321,7 @@
           <p:nvPr/>
         </p:nvPicPr>
         <p:blipFill>
-          <a:blip xmlns:r="http://schemas.openxmlformats.org/officeDocument/2006/relationships" xmlns:a="http://schemas.openxmlformats.org/drawingml/2006/main" r:embed="R3bb678f6d5584b7f"/>
+          <a:blip xmlns:r="http://schemas.openxmlformats.org/officeDocument/2006/relationships" xmlns:a="http://schemas.openxmlformats.org/drawingml/2006/main" r:embed="Rdd2cf628c51043e9"/>
           <a:stretch xmlns:a="http://schemas.openxmlformats.org/drawingml/2006/main">
             <a:fillRect l="0" t="0" r="0" b="0"/>
           </a:stretch>
@@ -11345,7 +11345,7 @@
           <p:nvPr/>
         </p:nvPicPr>
         <p:blipFill>
-          <a:blip xmlns:r="http://schemas.openxmlformats.org/officeDocument/2006/relationships" xmlns:a="http://schemas.openxmlformats.org/drawingml/2006/main" r:embed="Rdf2846521baa4227"/>
+          <a:blip xmlns:r="http://schemas.openxmlformats.org/officeDocument/2006/relationships" xmlns:a="http://schemas.openxmlformats.org/drawingml/2006/main" r:embed="R9a2ea9f2eb7e4164"/>
           <a:stretch xmlns:a="http://schemas.openxmlformats.org/drawingml/2006/main">
             <a:fillRect l="0" t="0" r="0" b="0"/>
           </a:stretch>
@@ -11648,7 +11648,7 @@
           <p:nvPr/>
         </p:nvPicPr>
         <p:blipFill>
-          <a:blip xmlns:r="http://schemas.openxmlformats.org/officeDocument/2006/relationships" xmlns:a="http://schemas.openxmlformats.org/drawingml/2006/main" r:embed="R0a730a4d96b7460d"/>
+          <a:blip xmlns:r="http://schemas.openxmlformats.org/officeDocument/2006/relationships" xmlns:a="http://schemas.openxmlformats.org/drawingml/2006/main" r:embed="Rcad2cba67ce24178"/>
           <a:stretch xmlns:a="http://schemas.openxmlformats.org/drawingml/2006/main">
             <a:fillRect l="0" t="0" r="0" b="0"/>
           </a:stretch>
@@ -11835,7 +11835,7 @@
           <p:nvPr/>
         </p:nvPicPr>
         <p:blipFill>
-          <a:blip xmlns:r="http://schemas.openxmlformats.org/officeDocument/2006/relationships" xmlns:a="http://schemas.openxmlformats.org/drawingml/2006/main" r:embed="R97f2dbdd9ec14c45"/>
+          <a:blip xmlns:r="http://schemas.openxmlformats.org/officeDocument/2006/relationships" xmlns:a="http://schemas.openxmlformats.org/drawingml/2006/main" r:embed="R5f4b6cc8713147b3"/>
           <a:stretch xmlns:a="http://schemas.openxmlformats.org/drawingml/2006/main">
             <a:fillRect l="0" t="0" r="0" b="0"/>
           </a:stretch>
@@ -12187,7 +12187,7 @@
           <p:nvPr/>
         </p:nvPicPr>
         <p:blipFill>
-          <a:blip xmlns:r="http://schemas.openxmlformats.org/officeDocument/2006/relationships" xmlns:a="http://schemas.openxmlformats.org/drawingml/2006/main" r:embed="R30644e783e6044dc"/>
+          <a:blip xmlns:r="http://schemas.openxmlformats.org/officeDocument/2006/relationships" xmlns:a="http://schemas.openxmlformats.org/drawingml/2006/main" r:embed="R979a9cb9fc9744e3"/>
           <a:stretch xmlns:a="http://schemas.openxmlformats.org/drawingml/2006/main">
             <a:fillRect l="0" t="0" r="0" b="0"/>
           </a:stretch>

</xml_diff>

<commit_message>
Explain FFT in Lab 2 lecture
</commit_message>
<xml_diff>
--- a/site/docs/MIE402_Lecture03_Single_Pendulum_PreLab2_Fall2026.pptx
+++ b/site/docs/MIE402_Lecture03_Single_Pendulum_PreLab2_Fall2026.pptx
@@ -28,6 +28,9 @@
     <p:sldId id="276" r:id="rId27"/>
     <p:sldId id="277" r:id="rId28"/>
     <p:sldId id="278" r:id="rId29"/>
+    <p:sldId id="279" r:id="rId30"/>
+    <p:sldId id="280" r:id="rId31"/>
+    <p:sldId id="281" r:id="rId32"/>
   </p:sldIdLst>
   <p:sldSz cx="12191695" cy="6858000" type="screen4x3"/>
   <p:notesSz cx="6858000" cy="9144000"/>
@@ -4853,7 +4856,7 @@
               </a:defRPr>
             </a:pPr>
             <a:r>
-              <a:t>32-34 min</a:t>
+              <a:t>32-33 min</a:t>
             </a:r>
           </a:p>
         </p:txBody>
@@ -4889,7 +4892,7 @@
               </a:defRPr>
             </a:pPr>
             <a:r>
-              <a:t>Period from time history and spectrum</a:t>
+              <a:t>Period from time history</a:t>
             </a:r>
           </a:p>
         </p:txBody>
@@ -4928,7 +4931,7 @@
               </a:defRPr>
             </a:pPr>
             <a:r>
-              <a:t>Time domain: measure several cycles between same-direction peaks.</a:t>
+              <a:t>Measure several cycles between same-direction peaks in theta(t).</a:t>
             </a:r>
           </a:p>
           <a:p>
@@ -4944,7 +4947,7 @@
               </a:defRPr>
             </a:pPr>
             <a:r>
-              <a:t>Frequency domain: remove mean, compute FFT, identify dominant peak.</a:t>
+              <a:t>Use T = (tₖ₊ₙ − tₖ)/N, then f = 1/T.</a:t>
             </a:r>
           </a:p>
           <a:p>
@@ -4960,7 +4963,7 @@
               </a:defRPr>
             </a:pPr>
             <a:r>
-              <a:t>Report record duration Tᵣ and frequency-bin spacing.</a:t>
+              <a:t>This is the direct physical measurement: “how long does one swing take?”</a:t>
             </a:r>
           </a:p>
           <a:p>
@@ -4976,7 +4979,7 @@
               </a:defRPr>
             </a:pPr>
             <a:r>
-              <a:t>Time-domain period and spectral frequency should agree within resolution.</a:t>
+              <a:t>Use the FFT as an independent frequency-based check.</a:t>
             </a:r>
           </a:p>
         </p:txBody>
@@ -4999,30 +5002,6 @@
           <a:xfrm>
             <a:off x="6583680" y="1828800"/>
             <a:ext cx="4297680" cy="685800"/>
-          </a:xfrm>
-          <a:prstGeom prst="rect">
-            <a:avLst/>
-          </a:prstGeom>
-        </p:spPr>
-      </p:pic>
-      <p:pic>
-        <p:nvPicPr>
-          <p:cNvPr id="7" name="Picture 6" descr="resolution-black.png"/>
-          <p:cNvPicPr>
-            <a:picLocks noChangeAspect="1"/>
-          </p:cNvPicPr>
-          <p:nvPr/>
-        </p:nvPicPr>
-        <p:blipFill>
-          <a:blip r:embed="rId3"/>
-          <a:stretch>
-            <a:fillRect/>
-          </a:stretch>
-        </p:blipFill>
-        <p:spPr>
-          <a:xfrm>
-            <a:off x="6629400" y="3337560"/>
-            <a:ext cx="4206240" cy="658368"/>
           </a:xfrm>
           <a:prstGeom prst="rect">
             <a:avLst/>
@@ -5114,7 +5093,7 @@
               </a:defRPr>
             </a:pPr>
             <a:r>
-              <a:t>34-36 min</a:t>
+              <a:t>33-35 min</a:t>
             </a:r>
           </a:p>
         </p:txBody>
@@ -5150,21 +5129,45 @@
               </a:defRPr>
             </a:pPr>
             <a:r>
-              <a:t>Lab 2 trial matrix</a:t>
-            </a:r>
-          </a:p>
-        </p:txBody>
-      </p:sp>
-      <p:sp>
-        <p:nvSpPr>
-          <p:cNvPr id="5" name="TextBox 4"/>
-          <p:cNvSpPr txBox="1"/>
-          <p:nvPr/>
-        </p:nvSpPr>
-        <p:spPr>
-          <a:xfrm>
-            <a:off x="685800" y="1508760"/>
-            <a:ext cx="10698480" cy="4480560"/>
+              <a:t>What the FFT means physically</a:t>
+            </a:r>
+          </a:p>
+        </p:txBody>
+      </p:sp>
+      <p:pic>
+        <p:nvPicPr>
+          <p:cNvPr id="5" name="Picture 4" descr="fft_physical.png"/>
+          <p:cNvPicPr>
+            <a:picLocks noChangeAspect="1"/>
+          </p:cNvPicPr>
+          <p:nvPr/>
+        </p:nvPicPr>
+        <p:blipFill>
+          <a:blip r:embed="rId2"/>
+          <a:stretch>
+            <a:fillRect/>
+          </a:stretch>
+        </p:blipFill>
+        <p:spPr>
+          <a:xfrm>
+            <a:off x="502920" y="1325880"/>
+            <a:ext cx="11201400" cy="4480560"/>
+          </a:xfrm>
+          <a:prstGeom prst="rect">
+            <a:avLst/>
+          </a:prstGeom>
+        </p:spPr>
+      </p:pic>
+      <p:sp>
+        <p:nvSpPr>
+          <p:cNvPr id="6" name="TextBox 5"/>
+          <p:cNvSpPr txBox="1"/>
+          <p:nvPr/>
+        </p:nvSpPr>
+        <p:spPr>
+          <a:xfrm>
+            <a:off x="731520" y="5806440"/>
+            <a:ext cx="10698480" cy="566928"/>
           </a:xfrm>
           <a:prstGeom prst="rect">
             <a:avLst/>
@@ -5181,15 +5184,15 @@
               <a:spcAft>
                 <a:spcPts val="1100"/>
               </a:spcAft>
-              <a:defRPr sz="2100">
-                <a:solidFill>
-                  <a:srgbClr val="161616"/>
-                </a:solidFill>
-                <a:latin typeface="Aptos"/>
-              </a:defRPr>
-            </a:pPr>
-            <a:r>
-              <a:t>Trial A: theta0 below 10 degrees. Closest test of small-angle theory.</a:t>
+              <a:defRPr sz="1500">
+                <a:solidFill>
+                  <a:srgbClr val="161616"/>
+                </a:solidFill>
+                <a:latin typeface="Aptos"/>
+              </a:defRPr>
+            </a:pPr>
+            <a:r>
+              <a:t>The FFT asks: how strongly does the measured theta(t) contain a sinusoid at each candidate frequency?</a:t>
             </a:r>
           </a:p>
           <a:p>
@@ -5197,15 +5200,15 @@
               <a:spcAft>
                 <a:spcPts val="1100"/>
               </a:spcAft>
-              <a:defRPr sz="2100">
-                <a:solidFill>
-                  <a:srgbClr val="161616"/>
-                </a:solidFill>
-                <a:latin typeface="Aptos"/>
-              </a:defRPr>
-            </a:pPr>
-            <a:r>
-              <a:t>Trial B: theta0 from 10 to 90 degrees. Observe period change.</a:t>
+              <a:defRPr sz="1500">
+                <a:solidFill>
+                  <a:srgbClr val="161616"/>
+                </a:solidFill>
+                <a:latin typeface="Aptos"/>
+              </a:defRPr>
+            </a:pPr>
+            <a:r>
+              <a:t>A tall peak near the pendulum frequency means that oscillation is the dominant repeating motion.</a:t>
             </a:r>
           </a:p>
           <a:p>
@@ -5213,31 +5216,15 @@
               <a:spcAft>
                 <a:spcPts val="1100"/>
               </a:spcAft>
-              <a:defRPr sz="2100">
-                <a:solidFill>
-                  <a:srgbClr val="161616"/>
-                </a:solidFill>
-                <a:latin typeface="Aptos"/>
-              </a:defRPr>
-            </a:pPr>
-            <a:r>
-              <a:t>Trial C: theta0 above 90 degrees only when approved by the GTA and the full swing stays in frame.</a:t>
-            </a:r>
-          </a:p>
-          <a:p>
-            <a:pPr>
-              <a:spcAft>
-                <a:spcPts val="1100"/>
-              </a:spcAft>
-              <a:defRPr sz="2100">
-                <a:solidFill>
-                  <a:srgbClr val="161616"/>
-                </a:solidFill>
-                <a:latin typeface="Aptos"/>
-              </a:defRPr>
-            </a:pPr>
-            <a:r>
-              <a:t>All releases start from rest. Record theta0 from protractor; do not push the bob.</a:t>
+              <a:defRPr sz="1500">
+                <a:solidFill>
+                  <a:srgbClr val="161616"/>
+                </a:solidFill>
+                <a:latin typeface="Aptos"/>
+              </a:defRPr>
+            </a:pPr>
+            <a:r>
+              <a:t>The FFT does not create a new physical tone; it reorganizes the same recorded motion by frequency.</a:t>
             </a:r>
           </a:p>
         </p:txBody>
@@ -5327,7 +5314,7 @@
               </a:defRPr>
             </a:pPr>
             <a:r>
-              <a:t>36-38 min</a:t>
+              <a:t>35-37 min</a:t>
             </a:r>
           </a:p>
         </p:txBody>
@@ -5363,21 +5350,69 @@
               </a:defRPr>
             </a:pPr>
             <a:r>
-              <a:t>Data quality before accepting video</a:t>
-            </a:r>
-          </a:p>
-        </p:txBody>
-      </p:sp>
-      <p:sp>
-        <p:nvSpPr>
-          <p:cNvPr id="5" name="TextBox 4"/>
-          <p:cNvSpPr txBox="1"/>
-          <p:nvPr/>
-        </p:nvSpPr>
-        <p:spPr>
-          <a:xfrm>
-            <a:off x="685800" y="1508760"/>
-            <a:ext cx="10698480" cy="4480560"/>
+              <a:t>FFT algorithm: same DFT, fewer repeated calculations</a:t>
+            </a:r>
+          </a:p>
+        </p:txBody>
+      </p:sp>
+      <p:pic>
+        <p:nvPicPr>
+          <p:cNvPr id="5" name="Picture 4" descr="fft_dft-black.png"/>
+          <p:cNvPicPr>
+            <a:picLocks noChangeAspect="1"/>
+          </p:cNvPicPr>
+          <p:nvPr/>
+        </p:nvPicPr>
+        <p:blipFill>
+          <a:blip r:embed="rId2"/>
+          <a:stretch>
+            <a:fillRect/>
+          </a:stretch>
+        </p:blipFill>
+        <p:spPr>
+          <a:xfrm>
+            <a:off x="2852928" y="1234440"/>
+            <a:ext cx="6492240" cy="640080"/>
+          </a:xfrm>
+          <a:prstGeom prst="rect">
+            <a:avLst/>
+          </a:prstGeom>
+        </p:spPr>
+      </p:pic>
+      <p:pic>
+        <p:nvPicPr>
+          <p:cNvPr id="6" name="Picture 5" descr="fft_algorithm.png"/>
+          <p:cNvPicPr>
+            <a:picLocks noChangeAspect="1"/>
+          </p:cNvPicPr>
+          <p:nvPr/>
+        </p:nvPicPr>
+        <p:blipFill>
+          <a:blip r:embed="rId3"/>
+          <a:stretch>
+            <a:fillRect/>
+          </a:stretch>
+        </p:blipFill>
+        <p:spPr>
+          <a:xfrm>
+            <a:off x="502920" y="1874519"/>
+            <a:ext cx="11201400" cy="3429000"/>
+          </a:xfrm>
+          <a:prstGeom prst="rect">
+            <a:avLst/>
+          </a:prstGeom>
+        </p:spPr>
+      </p:pic>
+      <p:sp>
+        <p:nvSpPr>
+          <p:cNvPr id="7" name="TextBox 6"/>
+          <p:cNvSpPr txBox="1"/>
+          <p:nvPr/>
+        </p:nvSpPr>
+        <p:spPr>
+          <a:xfrm>
+            <a:off x="731520" y="5422392"/>
+            <a:ext cx="10698480" cy="658368"/>
           </a:xfrm>
           <a:prstGeom prst="rect">
             <a:avLst/>
@@ -5394,15 +5429,15 @@
               <a:spcAft>
                 <a:spcPts val="1100"/>
               </a:spcAft>
-              <a:defRPr sz="2100">
-                <a:solidFill>
-                  <a:srgbClr val="161616"/>
-                </a:solidFill>
-                <a:latin typeface="Aptos"/>
-              </a:defRPr>
-            </a:pPr>
-            <a:r>
-              <a:t>Bob remains in frame.</a:t>
+              <a:defRPr sz="1400">
+                <a:solidFill>
+                  <a:srgbClr val="161616"/>
+                </a:solidFill>
+                <a:latin typeface="Aptos"/>
+              </a:defRPr>
+            </a:pPr>
+            <a:r>
+              <a:t>The DFT compares the record with complex sinusoids. The FFT is an efficient algorithm for computing that same DFT.</a:t>
             </a:r>
           </a:p>
           <a:p>
@@ -5410,15 +5445,15 @@
               <a:spcAft>
                 <a:spcPts val="1100"/>
               </a:spcAft>
-              <a:defRPr sz="2100">
-                <a:solidFill>
-                  <a:srgbClr val="161616"/>
-                </a:solidFill>
-                <a:latin typeface="Aptos"/>
-              </a:defRPr>
-            </a:pPr>
-            <a:r>
-              <a:t>Bob edge and center are visible without glare.</a:t>
+              <a:defRPr sz="1400">
+                <a:solidFill>
+                  <a:srgbClr val="161616"/>
+                </a:solidFill>
+                <a:latin typeface="Aptos"/>
+              </a:defRPr>
+            </a:pPr>
+            <a:r>
+              <a:t>It splits the samples into even and odd groups, solves smaller transforms, then combines them.</a:t>
             </a:r>
           </a:p>
           <a:p>
@@ -5426,63 +5461,15 @@
               <a:spcAft>
                 <a:spcPts val="1100"/>
               </a:spcAft>
-              <a:defRPr sz="2100">
-                <a:solidFill>
-                  <a:srgbClr val="161616"/>
-                </a:solidFill>
-                <a:latin typeface="Aptos"/>
-              </a:defRPr>
-            </a:pPr>
-            <a:r>
-              <a:t>Pivot and calibration marks are visible.</a:t>
-            </a:r>
-          </a:p>
-          <a:p>
-            <a:pPr>
-              <a:spcAft>
-                <a:spcPts val="1100"/>
-              </a:spcAft>
-              <a:defRPr sz="2100">
-                <a:solidFill>
-                  <a:srgbClr val="161616"/>
-                </a:solidFill>
-                <a:latin typeface="Aptos"/>
-              </a:defRPr>
-            </a:pPr>
-            <a:r>
-              <a:t>Release begins from rest.</a:t>
-            </a:r>
-          </a:p>
-          <a:p>
-            <a:pPr>
-              <a:spcAft>
-                <a:spcPts val="1100"/>
-              </a:spcAft>
-              <a:defRPr sz="2100">
-                <a:solidFill>
-                  <a:srgbClr val="161616"/>
-                </a:solidFill>
-                <a:latin typeface="Aptos"/>
-              </a:defRPr>
-            </a:pPr>
-            <a:r>
-              <a:t>Quick Review follows bob for nearly all frames.</a:t>
-            </a:r>
-          </a:p>
-          <a:p>
-            <a:pPr>
-              <a:spcAft>
-                <a:spcPts val="1100"/>
-              </a:spcAft>
-              <a:defRPr sz="2100">
-                <a:solidFill>
-                  <a:srgbClr val="161616"/>
-                </a:solidFill>
-                <a:latin typeface="Aptos"/>
-              </a:defRPr>
-            </a:pPr>
-            <a:r>
-              <a:t>Notes include file name, angle, frame rate, and calibration distance.</a:t>
+              <a:defRPr sz="1400">
+                <a:solidFill>
+                  <a:srgbClr val="161616"/>
+                </a:solidFill>
+                <a:latin typeface="Aptos"/>
+              </a:defRPr>
+            </a:pPr>
+            <a:r>
+              <a:t>For Lab 2, MATLAB performs this calculation. You must understand the input, the frequency axis, and the physical meaning of the peak.</a:t>
             </a:r>
           </a:p>
         </p:txBody>
@@ -5572,7 +5559,7 @@
               </a:defRPr>
             </a:pPr>
             <a:r>
-              <a:t>38-41 min</a:t>
+              <a:t>37-39 min</a:t>
             </a:r>
           </a:p>
         </p:txBody>
@@ -5608,21 +5595,69 @@
               </a:defRPr>
             </a:pPr>
             <a:r>
-              <a:t>Pre-Lab 2: what you submit</a:t>
-            </a:r>
-          </a:p>
-        </p:txBody>
-      </p:sp>
-      <p:sp>
-        <p:nvSpPr>
-          <p:cNvPr id="5" name="TextBox 4"/>
-          <p:cNvSpPr txBox="1"/>
-          <p:nvPr/>
-        </p:nvSpPr>
-        <p:spPr>
-          <a:xfrm>
-            <a:off x="685800" y="1508760"/>
-            <a:ext cx="10698480" cy="4480560"/>
+              <a:t>Using FFT results in Lab 2</a:t>
+            </a:r>
+          </a:p>
+        </p:txBody>
+      </p:sp>
+      <p:pic>
+        <p:nvPicPr>
+          <p:cNvPr id="5" name="Picture 4" descr="fft_bins-black.png"/>
+          <p:cNvPicPr>
+            <a:picLocks noChangeAspect="1"/>
+          </p:cNvPicPr>
+          <p:nvPr/>
+        </p:nvPicPr>
+        <p:blipFill>
+          <a:blip r:embed="rId2"/>
+          <a:stretch>
+            <a:fillRect/>
+          </a:stretch>
+        </p:blipFill>
+        <p:spPr>
+          <a:xfrm>
+            <a:off x="3611880" y="1417320"/>
+            <a:ext cx="5029200" cy="658368"/>
+          </a:xfrm>
+          <a:prstGeom prst="rect">
+            <a:avLst/>
+          </a:prstGeom>
+        </p:spPr>
+      </p:pic>
+      <p:pic>
+        <p:nvPicPr>
+          <p:cNvPr id="6" name="Picture 5" descr="resolution-black.png"/>
+          <p:cNvPicPr>
+            <a:picLocks noChangeAspect="1"/>
+          </p:cNvPicPr>
+          <p:nvPr/>
+        </p:nvPicPr>
+        <p:blipFill>
+          <a:blip r:embed="rId3"/>
+          <a:stretch>
+            <a:fillRect/>
+          </a:stretch>
+        </p:blipFill>
+        <p:spPr>
+          <a:xfrm>
+            <a:off x="4251960" y="2331720"/>
+            <a:ext cx="3657600" cy="594360"/>
+          </a:xfrm>
+          <a:prstGeom prst="rect">
+            <a:avLst/>
+          </a:prstGeom>
+        </p:spPr>
+      </p:pic>
+      <p:sp>
+        <p:nvSpPr>
+          <p:cNvPr id="7" name="TextBox 6"/>
+          <p:cNvSpPr txBox="1"/>
+          <p:nvPr/>
+        </p:nvSpPr>
+        <p:spPr>
+          <a:xfrm>
+            <a:off x="685800" y="3337560"/>
+            <a:ext cx="10789920" cy="2194560"/>
           </a:xfrm>
           <a:prstGeom prst="rect">
             <a:avLst/>
@@ -5639,15 +5674,15 @@
               <a:spcAft>
                 <a:spcPts val="1100"/>
               </a:spcAft>
-              <a:defRPr sz="2100">
-                <a:solidFill>
-                  <a:srgbClr val="161616"/>
-                </a:solidFill>
-                <a:latin typeface="Aptos"/>
-              </a:defRPr>
-            </a:pPr>
-            <a:r>
-              <a:t>One Word or PDF before laboratory section.</a:t>
+              <a:defRPr sz="1800">
+                <a:solidFill>
+                  <a:srgbClr val="161616"/>
+                </a:solidFill>
+                <a:latin typeface="Aptos"/>
+              </a:defRPr>
+            </a:pPr>
+            <a:r>
+              <a:t>Start with the usable theta(t) segment. Remove its mean before the FFT.</a:t>
             </a:r>
           </a:p>
           <a:p>
@@ -5655,15 +5690,15 @@
               <a:spcAft>
                 <a:spcPts val="1100"/>
               </a:spcAft>
-              <a:defRPr sz="2100">
-                <a:solidFill>
-                  <a:srgbClr val="161616"/>
-                </a:solidFill>
-                <a:latin typeface="Aptos"/>
-              </a:defRPr>
-            </a:pPr>
-            <a:r>
-              <a:t>Use the supplied notebook: run the provided cells, keep requested figures, and write your own answers. No programming is assigned.</a:t>
+              <a:defRPr sz="1800">
+                <a:solidFill>
+                  <a:srgbClr val="161616"/>
+                </a:solidFill>
+                <a:latin typeface="Aptos"/>
+              </a:defRPr>
+            </a:pPr>
+            <a:r>
+              <a:t>Nₛ samples at frame rate fₛ give record duration Tᵣ = Nₛ/fₛ and bin spacing Delta f = 1/Tᵣ.</a:t>
             </a:r>
           </a:p>
           <a:p>
@@ -5671,15 +5706,15 @@
               <a:spcAft>
                 <a:spcPts val="1100"/>
               </a:spcAft>
-              <a:defRPr sz="2100">
-                <a:solidFill>
-                  <a:srgbClr val="161616"/>
-                </a:solidFill>
-                <a:latin typeface="Aptos"/>
-              </a:defRPr>
-            </a:pPr>
-            <a:r>
-              <a:t>Task 1: compare point-mass and compound-pendulum frequencies.</a:t>
+              <a:defRPr sz="1800">
+                <a:solidFill>
+                  <a:srgbClr val="161616"/>
+                </a:solidFill>
+                <a:latin typeface="Aptos"/>
+              </a:defRPr>
+            </a:pPr>
+            <a:r>
+              <a:t>Read f_peak from the largest physically meaningful peak, then use T_FFT = 1/f_peak.</a:t>
             </a:r>
           </a:p>
           <a:p>
@@ -5687,31 +5722,15 @@
               <a:spcAft>
                 <a:spcPts val="1100"/>
               </a:spcAft>
-              <a:defRPr sz="2100">
-                <a:solidFill>
-                  <a:srgbClr val="161616"/>
-                </a:solidFill>
-                <a:latin typeface="Aptos"/>
-              </a:defRPr>
-            </a:pPr>
-            <a:r>
-              <a:t>Task 2: predict behavior before running the supplied simulation.</a:t>
-            </a:r>
-          </a:p>
-          <a:p>
-            <a:pPr>
-              <a:spcAft>
-                <a:spcPts val="1100"/>
-              </a:spcAft>
-              <a:defRPr sz="2100">
-                <a:solidFill>
-                  <a:srgbClr val="161616"/>
-                </a:solidFill>
-                <a:latin typeface="Aptos"/>
-              </a:defRPr>
-            </a:pPr>
-            <a:r>
-              <a:t>Tasks 3-6: explain finite-angle behavior, coordinates, frame rate, and the laboratory plan.</a:t>
+              <a:defRPr sz="1800">
+                <a:solidFill>
+                  <a:srgbClr val="161616"/>
+                </a:solidFill>
+                <a:latin typeface="Aptos"/>
+              </a:defRPr>
+            </a:pPr>
+            <a:r>
+              <a:t>A longer usable record narrows the bins. Zero-padding can make a smoother plot but does not improve the true resolution.</a:t>
             </a:r>
           </a:p>
         </p:txBody>
@@ -6038,7 +6057,7 @@
               </a:defRPr>
             </a:pPr>
             <a:r>
-              <a:t>41-44 min</a:t>
+              <a:t>39-41 min</a:t>
             </a:r>
           </a:p>
         </p:txBody>
@@ -6074,7 +6093,7 @@
               </a:defRPr>
             </a:pPr>
             <a:r>
-              <a:t>Evidence for combined Lab 2 and 3 report</a:t>
+              <a:t>Lab 2 trial matrix</a:t>
             </a:r>
           </a:p>
         </p:txBody>
@@ -6113,7 +6132,7 @@
               </a:defRPr>
             </a:pPr>
             <a:r>
-              <a:t>Schematic: pivot, l, M, m, theta, and positive direction.</a:t>
+              <a:t>Trial A: theta0 below 10 degrees. Closest test of small-angle theory.</a:t>
             </a:r>
           </a:p>
           <a:p>
@@ -6129,7 +6148,7 @@
               </a:defRPr>
             </a:pPr>
             <a:r>
-              <a:t>Table: measured parameters and analytical, nonlinear, time-domain, and FFT frequencies.</a:t>
+              <a:t>Trial B: theta0 from 10 to 90 degrees. Observe period change.</a:t>
             </a:r>
           </a:p>
           <a:p>
@@ -6145,7 +6164,7 @@
               </a:defRPr>
             </a:pPr>
             <a:r>
-              <a:t>Plots: theta(t), omega(t), and spectra with units.</a:t>
+              <a:t>Trial C: theta0 above 90 degrees only when approved by the GTA and the full swing stays in frame.</a:t>
             </a:r>
           </a:p>
           <a:p>
@@ -6161,7 +6180,7 @@
               </a:defRPr>
             </a:pPr>
             <a:r>
-              <a:t>Discussion: separate model limitations from measurement errors.</a:t>
+              <a:t>All releases start from rest. Record theta0 from protractor; do not push the bob.</a:t>
             </a:r>
           </a:p>
         </p:txBody>
@@ -6251,7 +6270,7 @@
               </a:defRPr>
             </a:pPr>
             <a:r>
-              <a:t>44-47 min</a:t>
+              <a:t>41-43 min</a:t>
             </a:r>
           </a:p>
         </p:txBody>
@@ -6287,7 +6306,7 @@
               </a:defRPr>
             </a:pPr>
             <a:r>
-              <a:t>In-class prediction</a:t>
+              <a:t>Data quality before accepting video</a:t>
             </a:r>
           </a:p>
         </p:txBody>
@@ -6300,44 +6319,8 @@
         </p:nvSpPr>
         <p:spPr>
           <a:xfrm>
-            <a:off x="777240" y="1508760"/>
-            <a:ext cx="10698480" cy="548640"/>
-          </a:xfrm>
-          <a:prstGeom prst="rect">
-            <a:avLst/>
-          </a:prstGeom>
-          <a:noFill/>
-        </p:spPr>
-        <p:txBody>
-          <a:bodyPr wrap="square">
-            <a:spAutoFit/>
-          </a:bodyPr>
-          <a:lstStyle/>
-          <a:p>
-            <a:pPr algn="ctr">
-              <a:defRPr sz="2600" b="1">
-                <a:solidFill>
-                  <a:srgbClr val="881C1C"/>
-                </a:solidFill>
-                <a:latin typeface="Aptos"/>
-              </a:defRPr>
-            </a:pPr>
-            <a:r>
-              <a:t>For the same apparatus, which release has the longest period?</a:t>
-            </a:r>
-          </a:p>
-        </p:txBody>
-      </p:sp>
-      <p:sp>
-        <p:nvSpPr>
-          <p:cNvPr id="6" name="TextBox 5"/>
-          <p:cNvSpPr txBox="1"/>
-          <p:nvPr/>
-        </p:nvSpPr>
-        <p:spPr>
-          <a:xfrm>
-            <a:off x="2011680" y="2788920"/>
-            <a:ext cx="8138160" cy="2103120"/>
+            <a:off x="685800" y="1508760"/>
+            <a:ext cx="10698480" cy="4480560"/>
           </a:xfrm>
           <a:prstGeom prst="rect">
             <a:avLst/>
@@ -6354,15 +6337,15 @@
               <a:spcAft>
                 <a:spcPts val="1100"/>
               </a:spcAft>
-              <a:defRPr sz="2400">
-                <a:solidFill>
-                  <a:srgbClr val="161616"/>
-                </a:solidFill>
-                <a:latin typeface="Aptos"/>
-              </a:defRPr>
-            </a:pPr>
-            <a:r>
-              <a:t>A. 8 degrees</a:t>
+              <a:defRPr sz="2100">
+                <a:solidFill>
+                  <a:srgbClr val="161616"/>
+                </a:solidFill>
+                <a:latin typeface="Aptos"/>
+              </a:defRPr>
+            </a:pPr>
+            <a:r>
+              <a:t>Bob remains in frame.</a:t>
             </a:r>
           </a:p>
           <a:p>
@@ -6370,15 +6353,15 @@
               <a:spcAft>
                 <a:spcPts val="1100"/>
               </a:spcAft>
-              <a:defRPr sz="2400">
-                <a:solidFill>
-                  <a:srgbClr val="161616"/>
-                </a:solidFill>
-                <a:latin typeface="Aptos"/>
-              </a:defRPr>
-            </a:pPr>
-            <a:r>
-              <a:t>B. 35 degrees</a:t>
+              <a:defRPr sz="2100">
+                <a:solidFill>
+                  <a:srgbClr val="161616"/>
+                </a:solidFill>
+                <a:latin typeface="Aptos"/>
+              </a:defRPr>
+            </a:pPr>
+            <a:r>
+              <a:t>Bob edge and center are visible without glare.</a:t>
             </a:r>
           </a:p>
           <a:p>
@@ -6386,15 +6369,15 @@
               <a:spcAft>
                 <a:spcPts val="1100"/>
               </a:spcAft>
-              <a:defRPr sz="2400">
-                <a:solidFill>
-                  <a:srgbClr val="161616"/>
-                </a:solidFill>
-                <a:latin typeface="Aptos"/>
-              </a:defRPr>
-            </a:pPr>
-            <a:r>
-              <a:t>C. 105 degrees</a:t>
+              <a:defRPr sz="2100">
+                <a:solidFill>
+                  <a:srgbClr val="161616"/>
+                </a:solidFill>
+                <a:latin typeface="Aptos"/>
+              </a:defRPr>
+            </a:pPr>
+            <a:r>
+              <a:t>Pivot and calibration marks are visible.</a:t>
             </a:r>
           </a:p>
           <a:p>
@@ -6402,15 +6385,47 @@
               <a:spcAft>
                 <a:spcPts val="1100"/>
               </a:spcAft>
-              <a:defRPr sz="2400">
-                <a:solidFill>
-                  <a:srgbClr val="161616"/>
-                </a:solidFill>
-                <a:latin typeface="Aptos"/>
-              </a:defRPr>
-            </a:pPr>
-            <a:r>
-              <a:t>Explain using the exact sine restoring torque.</a:t>
+              <a:defRPr sz="2100">
+                <a:solidFill>
+                  <a:srgbClr val="161616"/>
+                </a:solidFill>
+                <a:latin typeface="Aptos"/>
+              </a:defRPr>
+            </a:pPr>
+            <a:r>
+              <a:t>Release begins from rest.</a:t>
+            </a:r>
+          </a:p>
+          <a:p>
+            <a:pPr>
+              <a:spcAft>
+                <a:spcPts val="1100"/>
+              </a:spcAft>
+              <a:defRPr sz="2100">
+                <a:solidFill>
+                  <a:srgbClr val="161616"/>
+                </a:solidFill>
+                <a:latin typeface="Aptos"/>
+              </a:defRPr>
+            </a:pPr>
+            <a:r>
+              <a:t>Quick Review follows bob for nearly all frames.</a:t>
+            </a:r>
+          </a:p>
+          <a:p>
+            <a:pPr>
+              <a:spcAft>
+                <a:spcPts val="1100"/>
+              </a:spcAft>
+              <a:defRPr sz="2100">
+                <a:solidFill>
+                  <a:srgbClr val="161616"/>
+                </a:solidFill>
+                <a:latin typeface="Aptos"/>
+              </a:defRPr>
+            </a:pPr>
+            <a:r>
+              <a:t>Notes include file name, angle, frame rate, and calibration distance.</a:t>
             </a:r>
           </a:p>
         </p:txBody>
@@ -6500,7 +6515,7 @@
               </a:defRPr>
             </a:pPr>
             <a:r>
-              <a:t>47-49 min</a:t>
+              <a:t>43-45 min</a:t>
             </a:r>
           </a:p>
         </p:txBody>
@@ -6536,7 +6551,7 @@
               </a:defRPr>
             </a:pPr>
             <a:r>
-              <a:t>Before leaving laboratory</a:t>
+              <a:t>Pre-Lab 2: what you submit</a:t>
             </a:r>
           </a:p>
         </p:txBody>
@@ -6575,7 +6590,7 @@
               </a:defRPr>
             </a:pPr>
             <a:r>
-              <a:t>Save and back up every video and MAT output.</a:t>
+              <a:t>One Word or PDF before laboratory section.</a:t>
             </a:r>
           </a:p>
           <a:p>
@@ -6591,7 +6606,7 @@
               </a:defRPr>
             </a:pPr>
             <a:r>
-              <a:t>Verify tracking for every trial.</a:t>
+              <a:t>Use the supplied notebook: run the provided cells, keep requested figures, and write your own answers. No programming is assigned.</a:t>
             </a:r>
           </a:p>
           <a:p>
@@ -6607,7 +6622,7 @@
               </a:defRPr>
             </a:pPr>
             <a:r>
-              <a:t>Record initial angle, frame rate, calibration distance, l, M, m, and file names.</a:t>
+              <a:t>Task 1: compare point-mass and compound-pendulum frequencies.</a:t>
             </a:r>
           </a:p>
           <a:p>
@@ -6623,7 +6638,23 @@
               </a:defRPr>
             </a:pPr>
             <a:r>
-              <a:t>Check one theta(t) plot and one spectrum with the GTA.</a:t>
+              <a:t>Task 2: predict behavior before running the supplied simulation.</a:t>
+            </a:r>
+          </a:p>
+          <a:p>
+            <a:pPr>
+              <a:spcAft>
+                <a:spcPts val="1100"/>
+              </a:spcAft>
+              <a:defRPr sz="2100">
+                <a:solidFill>
+                  <a:srgbClr val="161616"/>
+                </a:solidFill>
+                <a:latin typeface="Aptos"/>
+              </a:defRPr>
+            </a:pPr>
+            <a:r>
+              <a:t>Tasks 3-6: explain finite-angle behavior, coordinates, frame rate, and the laboratory plan.</a:t>
             </a:r>
           </a:p>
         </p:txBody>
@@ -6637,6 +6668,681 @@
 </file>
 
 <file path=ppt/slides/slide23.xml><?xml version="1.0" encoding="utf-8"?>
+<p:sld xmlns:a="http://schemas.openxmlformats.org/drawingml/2006/main" xmlns:p="http://schemas.openxmlformats.org/presentationml/2006/main" xmlns:r="http://schemas.openxmlformats.org/officeDocument/2006/relationships">
+  <p:cSld>
+    <p:spTree>
+      <p:nvGrpSpPr>
+        <p:cNvPr id="1" name=""/>
+        <p:cNvGrpSpPr/>
+        <p:nvPr/>
+      </p:nvGrpSpPr>
+      <p:grpSpPr/>
+      <p:sp>
+        <p:nvSpPr>
+          <p:cNvPr id="2" name="TextBox 1"/>
+          <p:cNvSpPr txBox="1"/>
+          <p:nvPr/>
+        </p:nvSpPr>
+        <p:spPr>
+          <a:xfrm>
+            <a:off x="256032" y="164592"/>
+            <a:ext cx="4114800" cy="274320"/>
+          </a:xfrm>
+          <a:prstGeom prst="rect">
+            <a:avLst/>
+          </a:prstGeom>
+          <a:noFill/>
+        </p:spPr>
+        <p:txBody>
+          <a:bodyPr wrap="square">
+            <a:spAutoFit/>
+          </a:bodyPr>
+          <a:lstStyle/>
+          <a:p>
+            <a:pPr>
+              <a:defRPr sz="1200" b="1">
+                <a:solidFill>
+                  <a:srgbClr val="881C1C"/>
+                </a:solidFill>
+                <a:latin typeface="Aptos"/>
+              </a:defRPr>
+            </a:pPr>
+            <a:r>
+              <a:t>MIE 402  |  ME LAB II</a:t>
+            </a:r>
+          </a:p>
+        </p:txBody>
+      </p:sp>
+      <p:sp>
+        <p:nvSpPr>
+          <p:cNvPr id="3" name="TextBox 2"/>
+          <p:cNvSpPr txBox="1"/>
+          <p:nvPr/>
+        </p:nvSpPr>
+        <p:spPr>
+          <a:xfrm>
+            <a:off x="8869680" y="164592"/>
+            <a:ext cx="2743200" cy="274320"/>
+          </a:xfrm>
+          <a:prstGeom prst="rect">
+            <a:avLst/>
+          </a:prstGeom>
+          <a:noFill/>
+        </p:spPr>
+        <p:txBody>
+          <a:bodyPr wrap="square">
+            <a:spAutoFit/>
+          </a:bodyPr>
+          <a:lstStyle/>
+          <a:p>
+            <a:pPr algn="r">
+              <a:defRPr sz="1200" b="0">
+                <a:solidFill>
+                  <a:srgbClr val="666666"/>
+                </a:solidFill>
+                <a:latin typeface="Aptos"/>
+              </a:defRPr>
+            </a:pPr>
+            <a:r>
+              <a:t>45-47 min</a:t>
+            </a:r>
+          </a:p>
+        </p:txBody>
+      </p:sp>
+      <p:sp>
+        <p:nvSpPr>
+          <p:cNvPr id="4" name="TextBox 3"/>
+          <p:cNvSpPr txBox="1"/>
+          <p:nvPr/>
+        </p:nvSpPr>
+        <p:spPr>
+          <a:xfrm>
+            <a:off x="256032" y="685800"/>
+            <a:ext cx="11338560" cy="594360"/>
+          </a:xfrm>
+          <a:prstGeom prst="rect">
+            <a:avLst/>
+          </a:prstGeom>
+          <a:noFill/>
+        </p:spPr>
+        <p:txBody>
+          <a:bodyPr wrap="square">
+            <a:spAutoFit/>
+          </a:bodyPr>
+          <a:lstStyle/>
+          <a:p>
+            <a:pPr>
+              <a:defRPr sz="2900" b="1">
+                <a:solidFill>
+                  <a:srgbClr val="161616"/>
+                </a:solidFill>
+                <a:latin typeface="Aptos"/>
+              </a:defRPr>
+            </a:pPr>
+            <a:r>
+              <a:t>Evidence for combined Lab 2 and 3 report</a:t>
+            </a:r>
+          </a:p>
+        </p:txBody>
+      </p:sp>
+      <p:sp>
+        <p:nvSpPr>
+          <p:cNvPr id="5" name="TextBox 4"/>
+          <p:cNvSpPr txBox="1"/>
+          <p:nvPr/>
+        </p:nvSpPr>
+        <p:spPr>
+          <a:xfrm>
+            <a:off x="685800" y="1508760"/>
+            <a:ext cx="10698480" cy="4480560"/>
+          </a:xfrm>
+          <a:prstGeom prst="rect">
+            <a:avLst/>
+          </a:prstGeom>
+          <a:noFill/>
+        </p:spPr>
+        <p:txBody>
+          <a:bodyPr wrap="square">
+            <a:spAutoFit/>
+          </a:bodyPr>
+          <a:lstStyle/>
+          <a:p>
+            <a:pPr>
+              <a:spcAft>
+                <a:spcPts val="1100"/>
+              </a:spcAft>
+              <a:defRPr sz="2100">
+                <a:solidFill>
+                  <a:srgbClr val="161616"/>
+                </a:solidFill>
+                <a:latin typeface="Aptos"/>
+              </a:defRPr>
+            </a:pPr>
+            <a:r>
+              <a:t>Schematic: pivot, l, M, m, theta, and positive direction.</a:t>
+            </a:r>
+          </a:p>
+          <a:p>
+            <a:pPr>
+              <a:spcAft>
+                <a:spcPts val="1100"/>
+              </a:spcAft>
+              <a:defRPr sz="2100">
+                <a:solidFill>
+                  <a:srgbClr val="161616"/>
+                </a:solidFill>
+                <a:latin typeface="Aptos"/>
+              </a:defRPr>
+            </a:pPr>
+            <a:r>
+              <a:t>Table: measured parameters and analytical, nonlinear, time-domain, and FFT frequencies.</a:t>
+            </a:r>
+          </a:p>
+          <a:p>
+            <a:pPr>
+              <a:spcAft>
+                <a:spcPts val="1100"/>
+              </a:spcAft>
+              <a:defRPr sz="2100">
+                <a:solidFill>
+                  <a:srgbClr val="161616"/>
+                </a:solidFill>
+                <a:latin typeface="Aptos"/>
+              </a:defRPr>
+            </a:pPr>
+            <a:r>
+              <a:t>Plots: theta(t), omega(t), and spectra with units.</a:t>
+            </a:r>
+          </a:p>
+          <a:p>
+            <a:pPr>
+              <a:spcAft>
+                <a:spcPts val="1100"/>
+              </a:spcAft>
+              <a:defRPr sz="2100">
+                <a:solidFill>
+                  <a:srgbClr val="161616"/>
+                </a:solidFill>
+                <a:latin typeface="Aptos"/>
+              </a:defRPr>
+            </a:pPr>
+            <a:r>
+              <a:t>Discussion: separate model limitations from measurement errors.</a:t>
+            </a:r>
+          </a:p>
+        </p:txBody>
+      </p:sp>
+    </p:spTree>
+  </p:cSld>
+  <p:clrMapOvr>
+    <a:masterClrMapping/>
+  </p:clrMapOvr>
+</p:sld>
+</file>
+
+<file path=ppt/slides/slide24.xml><?xml version="1.0" encoding="utf-8"?>
+<p:sld xmlns:a="http://schemas.openxmlformats.org/drawingml/2006/main" xmlns:p="http://schemas.openxmlformats.org/presentationml/2006/main" xmlns:r="http://schemas.openxmlformats.org/officeDocument/2006/relationships">
+  <p:cSld>
+    <p:spTree>
+      <p:nvGrpSpPr>
+        <p:cNvPr id="1" name=""/>
+        <p:cNvGrpSpPr/>
+        <p:nvPr/>
+      </p:nvGrpSpPr>
+      <p:grpSpPr/>
+      <p:sp>
+        <p:nvSpPr>
+          <p:cNvPr id="2" name="TextBox 1"/>
+          <p:cNvSpPr txBox="1"/>
+          <p:nvPr/>
+        </p:nvSpPr>
+        <p:spPr>
+          <a:xfrm>
+            <a:off x="256032" y="164592"/>
+            <a:ext cx="4114800" cy="274320"/>
+          </a:xfrm>
+          <a:prstGeom prst="rect">
+            <a:avLst/>
+          </a:prstGeom>
+          <a:noFill/>
+        </p:spPr>
+        <p:txBody>
+          <a:bodyPr wrap="square">
+            <a:spAutoFit/>
+          </a:bodyPr>
+          <a:lstStyle/>
+          <a:p>
+            <a:pPr>
+              <a:defRPr sz="1200" b="1">
+                <a:solidFill>
+                  <a:srgbClr val="881C1C"/>
+                </a:solidFill>
+                <a:latin typeface="Aptos"/>
+              </a:defRPr>
+            </a:pPr>
+            <a:r>
+              <a:t>MIE 402  |  ME LAB II</a:t>
+            </a:r>
+          </a:p>
+        </p:txBody>
+      </p:sp>
+      <p:sp>
+        <p:nvSpPr>
+          <p:cNvPr id="3" name="TextBox 2"/>
+          <p:cNvSpPr txBox="1"/>
+          <p:nvPr/>
+        </p:nvSpPr>
+        <p:spPr>
+          <a:xfrm>
+            <a:off x="8869680" y="164592"/>
+            <a:ext cx="2743200" cy="274320"/>
+          </a:xfrm>
+          <a:prstGeom prst="rect">
+            <a:avLst/>
+          </a:prstGeom>
+          <a:noFill/>
+        </p:spPr>
+        <p:txBody>
+          <a:bodyPr wrap="square">
+            <a:spAutoFit/>
+          </a:bodyPr>
+          <a:lstStyle/>
+          <a:p>
+            <a:pPr algn="r">
+              <a:defRPr sz="1200" b="0">
+                <a:solidFill>
+                  <a:srgbClr val="666666"/>
+                </a:solidFill>
+                <a:latin typeface="Aptos"/>
+              </a:defRPr>
+            </a:pPr>
+            <a:r>
+              <a:t>47-49 min</a:t>
+            </a:r>
+          </a:p>
+        </p:txBody>
+      </p:sp>
+      <p:sp>
+        <p:nvSpPr>
+          <p:cNvPr id="4" name="TextBox 3"/>
+          <p:cNvSpPr txBox="1"/>
+          <p:nvPr/>
+        </p:nvSpPr>
+        <p:spPr>
+          <a:xfrm>
+            <a:off x="256032" y="685800"/>
+            <a:ext cx="11338560" cy="594360"/>
+          </a:xfrm>
+          <a:prstGeom prst="rect">
+            <a:avLst/>
+          </a:prstGeom>
+          <a:noFill/>
+        </p:spPr>
+        <p:txBody>
+          <a:bodyPr wrap="square">
+            <a:spAutoFit/>
+          </a:bodyPr>
+          <a:lstStyle/>
+          <a:p>
+            <a:pPr>
+              <a:defRPr sz="2900" b="1">
+                <a:solidFill>
+                  <a:srgbClr val="161616"/>
+                </a:solidFill>
+                <a:latin typeface="Aptos"/>
+              </a:defRPr>
+            </a:pPr>
+            <a:r>
+              <a:t>In-class prediction</a:t>
+            </a:r>
+          </a:p>
+        </p:txBody>
+      </p:sp>
+      <p:sp>
+        <p:nvSpPr>
+          <p:cNvPr id="5" name="TextBox 4"/>
+          <p:cNvSpPr txBox="1"/>
+          <p:nvPr/>
+        </p:nvSpPr>
+        <p:spPr>
+          <a:xfrm>
+            <a:off x="777240" y="1508760"/>
+            <a:ext cx="10698480" cy="548640"/>
+          </a:xfrm>
+          <a:prstGeom prst="rect">
+            <a:avLst/>
+          </a:prstGeom>
+          <a:noFill/>
+        </p:spPr>
+        <p:txBody>
+          <a:bodyPr wrap="square">
+            <a:spAutoFit/>
+          </a:bodyPr>
+          <a:lstStyle/>
+          <a:p>
+            <a:pPr algn="ctr">
+              <a:defRPr sz="2600" b="1">
+                <a:solidFill>
+                  <a:srgbClr val="881C1C"/>
+                </a:solidFill>
+                <a:latin typeface="Aptos"/>
+              </a:defRPr>
+            </a:pPr>
+            <a:r>
+              <a:t>For the same apparatus, which release has the longest period?</a:t>
+            </a:r>
+          </a:p>
+        </p:txBody>
+      </p:sp>
+      <p:sp>
+        <p:nvSpPr>
+          <p:cNvPr id="6" name="TextBox 5"/>
+          <p:cNvSpPr txBox="1"/>
+          <p:nvPr/>
+        </p:nvSpPr>
+        <p:spPr>
+          <a:xfrm>
+            <a:off x="2011680" y="2788920"/>
+            <a:ext cx="8138160" cy="2103120"/>
+          </a:xfrm>
+          <a:prstGeom prst="rect">
+            <a:avLst/>
+          </a:prstGeom>
+          <a:noFill/>
+        </p:spPr>
+        <p:txBody>
+          <a:bodyPr wrap="square">
+            <a:spAutoFit/>
+          </a:bodyPr>
+          <a:lstStyle/>
+          <a:p>
+            <a:pPr>
+              <a:spcAft>
+                <a:spcPts val="1100"/>
+              </a:spcAft>
+              <a:defRPr sz="2400">
+                <a:solidFill>
+                  <a:srgbClr val="161616"/>
+                </a:solidFill>
+                <a:latin typeface="Aptos"/>
+              </a:defRPr>
+            </a:pPr>
+            <a:r>
+              <a:t>A. 8 degrees</a:t>
+            </a:r>
+          </a:p>
+          <a:p>
+            <a:pPr>
+              <a:spcAft>
+                <a:spcPts val="1100"/>
+              </a:spcAft>
+              <a:defRPr sz="2400">
+                <a:solidFill>
+                  <a:srgbClr val="161616"/>
+                </a:solidFill>
+                <a:latin typeface="Aptos"/>
+              </a:defRPr>
+            </a:pPr>
+            <a:r>
+              <a:t>B. 35 degrees</a:t>
+            </a:r>
+          </a:p>
+          <a:p>
+            <a:pPr>
+              <a:spcAft>
+                <a:spcPts val="1100"/>
+              </a:spcAft>
+              <a:defRPr sz="2400">
+                <a:solidFill>
+                  <a:srgbClr val="161616"/>
+                </a:solidFill>
+                <a:latin typeface="Aptos"/>
+              </a:defRPr>
+            </a:pPr>
+            <a:r>
+              <a:t>C. 105 degrees</a:t>
+            </a:r>
+          </a:p>
+          <a:p>
+            <a:pPr>
+              <a:spcAft>
+                <a:spcPts val="1100"/>
+              </a:spcAft>
+              <a:defRPr sz="2400">
+                <a:solidFill>
+                  <a:srgbClr val="161616"/>
+                </a:solidFill>
+                <a:latin typeface="Aptos"/>
+              </a:defRPr>
+            </a:pPr>
+            <a:r>
+              <a:t>Explain using the exact sine restoring torque.</a:t>
+            </a:r>
+          </a:p>
+        </p:txBody>
+      </p:sp>
+    </p:spTree>
+  </p:cSld>
+  <p:clrMapOvr>
+    <a:masterClrMapping/>
+  </p:clrMapOvr>
+</p:sld>
+</file>
+
+<file path=ppt/slides/slide25.xml><?xml version="1.0" encoding="utf-8"?>
+<p:sld xmlns:a="http://schemas.openxmlformats.org/drawingml/2006/main" xmlns:p="http://schemas.openxmlformats.org/presentationml/2006/main" xmlns:r="http://schemas.openxmlformats.org/officeDocument/2006/relationships">
+  <p:cSld>
+    <p:spTree>
+      <p:nvGrpSpPr>
+        <p:cNvPr id="1" name=""/>
+        <p:cNvGrpSpPr/>
+        <p:nvPr/>
+      </p:nvGrpSpPr>
+      <p:grpSpPr/>
+      <p:sp>
+        <p:nvSpPr>
+          <p:cNvPr id="2" name="TextBox 1"/>
+          <p:cNvSpPr txBox="1"/>
+          <p:nvPr/>
+        </p:nvSpPr>
+        <p:spPr>
+          <a:xfrm>
+            <a:off x="256032" y="164592"/>
+            <a:ext cx="4114800" cy="274320"/>
+          </a:xfrm>
+          <a:prstGeom prst="rect">
+            <a:avLst/>
+          </a:prstGeom>
+          <a:noFill/>
+        </p:spPr>
+        <p:txBody>
+          <a:bodyPr wrap="square">
+            <a:spAutoFit/>
+          </a:bodyPr>
+          <a:lstStyle/>
+          <a:p>
+            <a:pPr>
+              <a:defRPr sz="1200" b="1">
+                <a:solidFill>
+                  <a:srgbClr val="881C1C"/>
+                </a:solidFill>
+                <a:latin typeface="Aptos"/>
+              </a:defRPr>
+            </a:pPr>
+            <a:r>
+              <a:t>MIE 402  |  ME LAB II</a:t>
+            </a:r>
+          </a:p>
+        </p:txBody>
+      </p:sp>
+      <p:sp>
+        <p:nvSpPr>
+          <p:cNvPr id="3" name="TextBox 2"/>
+          <p:cNvSpPr txBox="1"/>
+          <p:nvPr/>
+        </p:nvSpPr>
+        <p:spPr>
+          <a:xfrm>
+            <a:off x="8869680" y="164592"/>
+            <a:ext cx="2743200" cy="274320"/>
+          </a:xfrm>
+          <a:prstGeom prst="rect">
+            <a:avLst/>
+          </a:prstGeom>
+          <a:noFill/>
+        </p:spPr>
+        <p:txBody>
+          <a:bodyPr wrap="square">
+            <a:spAutoFit/>
+          </a:bodyPr>
+          <a:lstStyle/>
+          <a:p>
+            <a:pPr algn="r">
+              <a:defRPr sz="1200" b="0">
+                <a:solidFill>
+                  <a:srgbClr val="666666"/>
+                </a:solidFill>
+                <a:latin typeface="Aptos"/>
+              </a:defRPr>
+            </a:pPr>
+            <a:r>
+              <a:t>49-50 min</a:t>
+            </a:r>
+          </a:p>
+        </p:txBody>
+      </p:sp>
+      <p:sp>
+        <p:nvSpPr>
+          <p:cNvPr id="4" name="TextBox 3"/>
+          <p:cNvSpPr txBox="1"/>
+          <p:nvPr/>
+        </p:nvSpPr>
+        <p:spPr>
+          <a:xfrm>
+            <a:off x="256032" y="685800"/>
+            <a:ext cx="11338560" cy="594360"/>
+          </a:xfrm>
+          <a:prstGeom prst="rect">
+            <a:avLst/>
+          </a:prstGeom>
+          <a:noFill/>
+        </p:spPr>
+        <p:txBody>
+          <a:bodyPr wrap="square">
+            <a:spAutoFit/>
+          </a:bodyPr>
+          <a:lstStyle/>
+          <a:p>
+            <a:pPr>
+              <a:defRPr sz="2900" b="1">
+                <a:solidFill>
+                  <a:srgbClr val="161616"/>
+                </a:solidFill>
+                <a:latin typeface="Aptos"/>
+              </a:defRPr>
+            </a:pPr>
+            <a:r>
+              <a:t>Before leaving laboratory</a:t>
+            </a:r>
+          </a:p>
+        </p:txBody>
+      </p:sp>
+      <p:sp>
+        <p:nvSpPr>
+          <p:cNvPr id="5" name="TextBox 4"/>
+          <p:cNvSpPr txBox="1"/>
+          <p:nvPr/>
+        </p:nvSpPr>
+        <p:spPr>
+          <a:xfrm>
+            <a:off x="685800" y="1508760"/>
+            <a:ext cx="10698480" cy="4480560"/>
+          </a:xfrm>
+          <a:prstGeom prst="rect">
+            <a:avLst/>
+          </a:prstGeom>
+          <a:noFill/>
+        </p:spPr>
+        <p:txBody>
+          <a:bodyPr wrap="square">
+            <a:spAutoFit/>
+          </a:bodyPr>
+          <a:lstStyle/>
+          <a:p>
+            <a:pPr>
+              <a:spcAft>
+                <a:spcPts val="1100"/>
+              </a:spcAft>
+              <a:defRPr sz="2100">
+                <a:solidFill>
+                  <a:srgbClr val="161616"/>
+                </a:solidFill>
+                <a:latin typeface="Aptos"/>
+              </a:defRPr>
+            </a:pPr>
+            <a:r>
+              <a:t>Save and back up every video and MAT output.</a:t>
+            </a:r>
+          </a:p>
+          <a:p>
+            <a:pPr>
+              <a:spcAft>
+                <a:spcPts val="1100"/>
+              </a:spcAft>
+              <a:defRPr sz="2100">
+                <a:solidFill>
+                  <a:srgbClr val="161616"/>
+                </a:solidFill>
+                <a:latin typeface="Aptos"/>
+              </a:defRPr>
+            </a:pPr>
+            <a:r>
+              <a:t>Verify tracking for every trial.</a:t>
+            </a:r>
+          </a:p>
+          <a:p>
+            <a:pPr>
+              <a:spcAft>
+                <a:spcPts val="1100"/>
+              </a:spcAft>
+              <a:defRPr sz="2100">
+                <a:solidFill>
+                  <a:srgbClr val="161616"/>
+                </a:solidFill>
+                <a:latin typeface="Aptos"/>
+              </a:defRPr>
+            </a:pPr>
+            <a:r>
+              <a:t>Record initial angle, frame rate, calibration distance, l, M, m, and file names.</a:t>
+            </a:r>
+          </a:p>
+          <a:p>
+            <a:pPr>
+              <a:spcAft>
+                <a:spcPts val="1100"/>
+              </a:spcAft>
+              <a:defRPr sz="2100">
+                <a:solidFill>
+                  <a:srgbClr val="161616"/>
+                </a:solidFill>
+                <a:latin typeface="Aptos"/>
+              </a:defRPr>
+            </a:pPr>
+            <a:r>
+              <a:t>Check one theta(t) plot and one spectrum with the GTA.</a:t>
+            </a:r>
+          </a:p>
+        </p:txBody>
+      </p:sp>
+    </p:spTree>
+  </p:cSld>
+  <p:clrMapOvr>
+    <a:masterClrMapping/>
+  </p:clrMapOvr>
+</p:sld>
+</file>
+
+<file path=ppt/slides/slide26.xml><?xml version="1.0" encoding="utf-8"?>
 <p:sld xmlns:a="http://schemas.openxmlformats.org/drawingml/2006/main" xmlns:p="http://schemas.openxmlformats.org/presentationml/2006/main" xmlns:r="http://schemas.openxmlformats.org/officeDocument/2006/relationships">
   <p:cSld>
     <p:spTree>

</xml_diff>

<commit_message>
Embed Fourier series video in Lab 2 lecture
</commit_message>
<xml_diff>
--- a/site/docs/MIE402_Lecture03_Single_Pendulum_PreLab2_Fall2026.pptx
+++ b/site/docs/MIE402_Lecture03_Single_Pendulum_PreLab2_Fall2026.pptx
@@ -31,6 +31,7 @@
     <p:sldId id="279" r:id="rId30"/>
     <p:sldId id="280" r:id="rId31"/>
     <p:sldId id="281" r:id="rId32"/>
+    <p:sldId id="282" r:id="rId33"/>
   </p:sldIdLst>
   <p:sldSz cx="12191695" cy="6858000" type="screen4x3"/>
   <p:notesSz cx="6858000" cy="9144000"/>
@@ -5093,7 +5094,7 @@
               </a:defRPr>
             </a:pPr>
             <a:r>
-              <a:t>33-35 min</a:t>
+              <a:t>33-34 min</a:t>
             </a:r>
           </a:p>
         </p:txBody>
@@ -5129,29 +5130,38 @@
               </a:defRPr>
             </a:pPr>
             <a:r>
-              <a:t>What the FFT means physically</a:t>
+              <a:t>What this video shows: Fourier synthesis</a:t>
             </a:r>
           </a:p>
         </p:txBody>
       </p:sp>
       <p:pic>
         <p:nvPicPr>
-          <p:cNvPr id="5" name="Picture 4" descr="fft_physical.png"/>
+          <p:cNvPr id="5" name="linkedin-video.mp4">
+            <a:hlinkClick r:id="" action="ppaction://media"/>
+          </p:cNvPr>
           <p:cNvPicPr>
             <a:picLocks noChangeAspect="1"/>
           </p:cNvPicPr>
-          <p:nvPr/>
+          <p:nvPr>
+            <a:videoFile r:link="rId3"/>
+            <p:extLst>
+              <p:ext uri="{DAA4B4D4-6D71-4841-9C94-3DE7FCFB9230}">
+                <p14:media xmlns:p14="http://schemas.microsoft.com/office/powerpoint/2010/main" r:embed="rId2"/>
+              </p:ext>
+            </p:extLst>
+          </p:nvPr>
         </p:nvPicPr>
         <p:blipFill>
-          <a:blip r:embed="rId2"/>
+          <a:blip r:embed="rId4"/>
           <a:stretch>
             <a:fillRect/>
           </a:stretch>
         </p:blipFill>
         <p:spPr>
           <a:xfrm>
-            <a:off x="502920" y="1325880"/>
-            <a:ext cx="11201400" cy="4480560"/>
+            <a:off x="685800" y="1234440"/>
+            <a:ext cx="5120640" cy="4983480"/>
           </a:xfrm>
           <a:prstGeom prst="rect">
             <a:avLst/>
@@ -5166,8 +5176,44 @@
         </p:nvSpPr>
         <p:spPr>
           <a:xfrm>
-            <a:off x="731520" y="5806440"/>
-            <a:ext cx="10698480" cy="566928"/>
+            <a:off x="6172200" y="1417320"/>
+            <a:ext cx="5166360" cy="502920"/>
+          </a:xfrm>
+          <a:prstGeom prst="rect">
+            <a:avLst/>
+          </a:prstGeom>
+          <a:noFill/>
+        </p:spPr>
+        <p:txBody>
+          <a:bodyPr wrap="square">
+            <a:spAutoFit/>
+          </a:bodyPr>
+          <a:lstStyle/>
+          <a:p>
+            <a:pPr>
+              <a:defRPr sz="2100" b="1">
+                <a:solidFill>
+                  <a:srgbClr val="881C1C"/>
+                </a:solidFill>
+                <a:latin typeface="Aptos"/>
+              </a:defRPr>
+            </a:pPr>
+            <a:r>
+              <a:t>Watch the embedded 29-second video</a:t>
+            </a:r>
+          </a:p>
+        </p:txBody>
+      </p:sp>
+      <p:sp>
+        <p:nvSpPr>
+          <p:cNvPr id="7" name="TextBox 6"/>
+          <p:cNvSpPr txBox="1"/>
+          <p:nvPr/>
+        </p:nvSpPr>
+        <p:spPr>
+          <a:xfrm>
+            <a:off x="6172200" y="2011680"/>
+            <a:ext cx="4983480" cy="3474720"/>
           </a:xfrm>
           <a:prstGeom prst="rect">
             <a:avLst/>
@@ -5184,15 +5230,15 @@
               <a:spcAft>
                 <a:spcPts val="1100"/>
               </a:spcAft>
-              <a:defRPr sz="1500">
-                <a:solidFill>
-                  <a:srgbClr val="161616"/>
-                </a:solidFill>
-                <a:latin typeface="Aptos"/>
-              </a:defRPr>
-            </a:pPr>
-            <a:r>
-              <a:t>The FFT asks: how strongly does the measured theta(t) contain a sinusoid at each candidate frequency?</a:t>
+              <a:defRPr sz="1700">
+                <a:solidFill>
+                  <a:srgbClr val="161616"/>
+                </a:solidFill>
+                <a:latin typeface="Aptos"/>
+              </a:defRPr>
+            </a:pPr>
+            <a:r>
+              <a:t>The colored circles are rotating vectors (phasors), each representing one sinusoidal component with its own amplitude, frequency, and phase.</a:t>
             </a:r>
           </a:p>
           <a:p>
@@ -5200,15 +5246,15 @@
               <a:spcAft>
                 <a:spcPts val="1100"/>
               </a:spcAft>
-              <a:defRPr sz="1500">
-                <a:solidFill>
-                  <a:srgbClr val="161616"/>
-                </a:solidFill>
-                <a:latin typeface="Aptos"/>
-              </a:defRPr>
-            </a:pPr>
-            <a:r>
-              <a:t>A tall peak near the pendulum frequency means that oscillation is the dominant repeating motion.</a:t>
+              <a:defRPr sz="1700">
+                <a:solidFill>
+                  <a:srgbClr val="161616"/>
+                </a:solidFill>
+                <a:latin typeface="Aptos"/>
+              </a:defRPr>
+            </a:pPr>
+            <a:r>
+              <a:t>The trace at right is their instantaneous sum. The video therefore builds a waveform from known components: this is Fourier synthesis or a Fourier series.</a:t>
             </a:r>
           </a:p>
           <a:p>
@@ -5216,15 +5262,31 @@
               <a:spcAft>
                 <a:spcPts val="1100"/>
               </a:spcAft>
-              <a:defRPr sz="1500">
-                <a:solidFill>
-                  <a:srgbClr val="161616"/>
-                </a:solidFill>
-                <a:latin typeface="Aptos"/>
-              </a:defRPr>
-            </a:pPr>
-            <a:r>
-              <a:t>The FFT does not create a new physical tone; it reorganizes the same recorded motion by frequency.</a:t>
+              <a:defRPr sz="1700">
+                <a:solidFill>
+                  <a:srgbClr val="161616"/>
+                </a:solidFill>
+                <a:latin typeface="Aptos"/>
+              </a:defRPr>
+            </a:pPr>
+            <a:r>
+              <a:t>It is not an FFT calculation and it is not pendulum data. Use it as a visual model for the phrase “a signal can be represented by sinusoidal components.”</a:t>
+            </a:r>
+          </a:p>
+          <a:p>
+            <a:pPr>
+              <a:spcAft>
+                <a:spcPts val="1100"/>
+              </a:spcAft>
+              <a:defRPr sz="1700">
+                <a:solidFill>
+                  <a:srgbClr val="161616"/>
+                </a:solidFill>
+                <a:latin typeface="Aptos"/>
+              </a:defRPr>
+            </a:pPr>
+            <a:r>
+              <a:t>In Lab 2 we do the reverse: we start with measured theta(t), and the FFT estimates the components that best describe that record.</a:t>
             </a:r>
           </a:p>
         </p:txBody>
@@ -5234,6 +5296,28 @@
   <p:clrMapOvr>
     <a:masterClrMapping/>
   </p:clrMapOvr>
+  <p:timing>
+    <p:tnLst>
+      <p:par>
+        <p:cTn id="1" dur="indefinite" restart="never" nodeType="tmRoot">
+          <p:childTnLst>
+            <p:video>
+              <p:cMediaNode vol="80000">
+                <p:cTn id="2" fill="hold" display="0">
+                  <p:stCondLst>
+                    <p:cond delay="indefinite"/>
+                  </p:stCondLst>
+                </p:cTn>
+                <p:tgtEl>
+                  <p:spTgt spid="5"/>
+                </p:tgtEl>
+              </p:cMediaNode>
+            </p:video>
+          </p:childTnLst>
+        </p:cTn>
+      </p:par>
+    </p:tnLst>
+  </p:timing>
 </p:sld>
 </file>
 
@@ -5314,7 +5398,7 @@
               </a:defRPr>
             </a:pPr>
             <a:r>
-              <a:t>35-37 min</a:t>
+              <a:t>34-35.5 min</a:t>
             </a:r>
           </a:p>
         </p:txBody>
@@ -5350,14 +5434,14 @@
               </a:defRPr>
             </a:pPr>
             <a:r>
-              <a:t>FFT algorithm: same DFT, fewer repeated calculations</a:t>
+              <a:t>What the FFT means physically</a:t>
             </a:r>
           </a:p>
         </p:txBody>
       </p:sp>
       <p:pic>
         <p:nvPicPr>
-          <p:cNvPr id="5" name="Picture 4" descr="fft_dft-black.png"/>
+          <p:cNvPr id="5" name="Picture 4" descr="fft_physical.png"/>
           <p:cNvPicPr>
             <a:picLocks noChangeAspect="1"/>
           </p:cNvPicPr>
@@ -5371,48 +5455,24 @@
         </p:blipFill>
         <p:spPr>
           <a:xfrm>
-            <a:off x="2852928" y="1234440"/>
-            <a:ext cx="6492240" cy="640080"/>
+            <a:off x="502920" y="1325880"/>
+            <a:ext cx="11201400" cy="4480560"/>
           </a:xfrm>
           <a:prstGeom prst="rect">
             <a:avLst/>
           </a:prstGeom>
         </p:spPr>
       </p:pic>
-      <p:pic>
-        <p:nvPicPr>
-          <p:cNvPr id="6" name="Picture 5" descr="fft_algorithm.png"/>
-          <p:cNvPicPr>
-            <a:picLocks noChangeAspect="1"/>
-          </p:cNvPicPr>
-          <p:nvPr/>
-        </p:nvPicPr>
-        <p:blipFill>
-          <a:blip r:embed="rId3"/>
-          <a:stretch>
-            <a:fillRect/>
-          </a:stretch>
-        </p:blipFill>
-        <p:spPr>
-          <a:xfrm>
-            <a:off x="502920" y="1874519"/>
-            <a:ext cx="11201400" cy="3429000"/>
-          </a:xfrm>
-          <a:prstGeom prst="rect">
-            <a:avLst/>
-          </a:prstGeom>
-        </p:spPr>
-      </p:pic>
-      <p:sp>
-        <p:nvSpPr>
-          <p:cNvPr id="7" name="TextBox 6"/>
-          <p:cNvSpPr txBox="1"/>
-          <p:nvPr/>
-        </p:nvSpPr>
-        <p:spPr>
-          <a:xfrm>
-            <a:off x="731520" y="5422392"/>
-            <a:ext cx="10698480" cy="658368"/>
+      <p:sp>
+        <p:nvSpPr>
+          <p:cNvPr id="6" name="TextBox 5"/>
+          <p:cNvSpPr txBox="1"/>
+          <p:nvPr/>
+        </p:nvSpPr>
+        <p:spPr>
+          <a:xfrm>
+            <a:off x="731520" y="5806440"/>
+            <a:ext cx="10698480" cy="566928"/>
           </a:xfrm>
           <a:prstGeom prst="rect">
             <a:avLst/>
@@ -5429,15 +5489,15 @@
               <a:spcAft>
                 <a:spcPts val="1100"/>
               </a:spcAft>
-              <a:defRPr sz="1400">
-                <a:solidFill>
-                  <a:srgbClr val="161616"/>
-                </a:solidFill>
-                <a:latin typeface="Aptos"/>
-              </a:defRPr>
-            </a:pPr>
-            <a:r>
-              <a:t>The DFT compares the record with complex sinusoids. The FFT is an efficient algorithm for computing that same DFT.</a:t>
+              <a:defRPr sz="1500">
+                <a:solidFill>
+                  <a:srgbClr val="161616"/>
+                </a:solidFill>
+                <a:latin typeface="Aptos"/>
+              </a:defRPr>
+            </a:pPr>
+            <a:r>
+              <a:t>The FFT asks: how strongly does the measured theta(t) contain a sinusoid at each candidate frequency?</a:t>
             </a:r>
           </a:p>
           <a:p>
@@ -5445,15 +5505,15 @@
               <a:spcAft>
                 <a:spcPts val="1100"/>
               </a:spcAft>
-              <a:defRPr sz="1400">
-                <a:solidFill>
-                  <a:srgbClr val="161616"/>
-                </a:solidFill>
-                <a:latin typeface="Aptos"/>
-              </a:defRPr>
-            </a:pPr>
-            <a:r>
-              <a:t>It splits the samples into even and odd groups, solves smaller transforms, then combines them.</a:t>
+              <a:defRPr sz="1500">
+                <a:solidFill>
+                  <a:srgbClr val="161616"/>
+                </a:solidFill>
+                <a:latin typeface="Aptos"/>
+              </a:defRPr>
+            </a:pPr>
+            <a:r>
+              <a:t>A tall peak near the pendulum frequency means that oscillation is the dominant repeating motion.</a:t>
             </a:r>
           </a:p>
           <a:p>
@@ -5461,15 +5521,15 @@
               <a:spcAft>
                 <a:spcPts val="1100"/>
               </a:spcAft>
-              <a:defRPr sz="1400">
-                <a:solidFill>
-                  <a:srgbClr val="161616"/>
-                </a:solidFill>
-                <a:latin typeface="Aptos"/>
-              </a:defRPr>
-            </a:pPr>
-            <a:r>
-              <a:t>For Lab 2, MATLAB performs this calculation. You must understand the input, the frequency axis, and the physical meaning of the peak.</a:t>
+              <a:defRPr sz="1500">
+                <a:solidFill>
+                  <a:srgbClr val="161616"/>
+                </a:solidFill>
+                <a:latin typeface="Aptos"/>
+              </a:defRPr>
+            </a:pPr>
+            <a:r>
+              <a:t>The FFT does not create a new physical tone; it reorganizes the same recorded motion by frequency.</a:t>
             </a:r>
           </a:p>
         </p:txBody>
@@ -5559,7 +5619,7 @@
               </a:defRPr>
             </a:pPr>
             <a:r>
-              <a:t>37-39 min</a:t>
+              <a:t>35.5-37 min</a:t>
             </a:r>
           </a:p>
         </p:txBody>
@@ -5595,14 +5655,14 @@
               </a:defRPr>
             </a:pPr>
             <a:r>
-              <a:t>Using FFT results in Lab 2</a:t>
+              <a:t>FFT algorithm: same DFT, fewer repeated calculations</a:t>
             </a:r>
           </a:p>
         </p:txBody>
       </p:sp>
       <p:pic>
         <p:nvPicPr>
-          <p:cNvPr id="5" name="Picture 4" descr="fft_bins-black.png"/>
+          <p:cNvPr id="5" name="Picture 4" descr="fft_dft-black.png"/>
           <p:cNvPicPr>
             <a:picLocks noChangeAspect="1"/>
           </p:cNvPicPr>
@@ -5616,8 +5676,8 @@
         </p:blipFill>
         <p:spPr>
           <a:xfrm>
-            <a:off x="3611880" y="1417320"/>
-            <a:ext cx="5029200" cy="658368"/>
+            <a:off x="2852928" y="1234440"/>
+            <a:ext cx="6492240" cy="640080"/>
           </a:xfrm>
           <a:prstGeom prst="rect">
             <a:avLst/>
@@ -5626,7 +5686,7 @@
       </p:pic>
       <p:pic>
         <p:nvPicPr>
-          <p:cNvPr id="6" name="Picture 5" descr="resolution-black.png"/>
+          <p:cNvPr id="6" name="Picture 5" descr="fft_algorithm.png"/>
           <p:cNvPicPr>
             <a:picLocks noChangeAspect="1"/>
           </p:cNvPicPr>
@@ -5640,8 +5700,8 @@
         </p:blipFill>
         <p:spPr>
           <a:xfrm>
-            <a:off x="4251960" y="2331720"/>
-            <a:ext cx="3657600" cy="594360"/>
+            <a:off x="502920" y="1874519"/>
+            <a:ext cx="11201400" cy="3429000"/>
           </a:xfrm>
           <a:prstGeom prst="rect">
             <a:avLst/>
@@ -5656,8 +5716,8 @@
         </p:nvSpPr>
         <p:spPr>
           <a:xfrm>
-            <a:off x="685800" y="3337560"/>
-            <a:ext cx="10789920" cy="2194560"/>
+            <a:off x="731520" y="5422392"/>
+            <a:ext cx="10698480" cy="658368"/>
           </a:xfrm>
           <a:prstGeom prst="rect">
             <a:avLst/>
@@ -5674,15 +5734,15 @@
               <a:spcAft>
                 <a:spcPts val="1100"/>
               </a:spcAft>
-              <a:defRPr sz="1800">
-                <a:solidFill>
-                  <a:srgbClr val="161616"/>
-                </a:solidFill>
-                <a:latin typeface="Aptos"/>
-              </a:defRPr>
-            </a:pPr>
-            <a:r>
-              <a:t>Start with the usable theta(t) segment. Remove its mean before the FFT.</a:t>
+              <a:defRPr sz="1400">
+                <a:solidFill>
+                  <a:srgbClr val="161616"/>
+                </a:solidFill>
+                <a:latin typeface="Aptos"/>
+              </a:defRPr>
+            </a:pPr>
+            <a:r>
+              <a:t>The DFT compares the record with complex sinusoids. The FFT is an efficient algorithm for computing that same DFT.</a:t>
             </a:r>
           </a:p>
           <a:p>
@@ -5690,15 +5750,15 @@
               <a:spcAft>
                 <a:spcPts val="1100"/>
               </a:spcAft>
-              <a:defRPr sz="1800">
-                <a:solidFill>
-                  <a:srgbClr val="161616"/>
-                </a:solidFill>
-                <a:latin typeface="Aptos"/>
-              </a:defRPr>
-            </a:pPr>
-            <a:r>
-              <a:t>Nₛ samples at frame rate fₛ give record duration Tᵣ = Nₛ/fₛ and bin spacing Delta f = 1/Tᵣ.</a:t>
+              <a:defRPr sz="1400">
+                <a:solidFill>
+                  <a:srgbClr val="161616"/>
+                </a:solidFill>
+                <a:latin typeface="Aptos"/>
+              </a:defRPr>
+            </a:pPr>
+            <a:r>
+              <a:t>It splits the samples into even and odd groups, solves smaller transforms, then combines them.</a:t>
             </a:r>
           </a:p>
           <a:p>
@@ -5706,31 +5766,15 @@
               <a:spcAft>
                 <a:spcPts val="1100"/>
               </a:spcAft>
-              <a:defRPr sz="1800">
-                <a:solidFill>
-                  <a:srgbClr val="161616"/>
-                </a:solidFill>
-                <a:latin typeface="Aptos"/>
-              </a:defRPr>
-            </a:pPr>
-            <a:r>
-              <a:t>Read f_peak from the largest physically meaningful peak, then use T_FFT = 1/f_peak.</a:t>
-            </a:r>
-          </a:p>
-          <a:p>
-            <a:pPr>
-              <a:spcAft>
-                <a:spcPts val="1100"/>
-              </a:spcAft>
-              <a:defRPr sz="1800">
-                <a:solidFill>
-                  <a:srgbClr val="161616"/>
-                </a:solidFill>
-                <a:latin typeface="Aptos"/>
-              </a:defRPr>
-            </a:pPr>
-            <a:r>
-              <a:t>A longer usable record narrows the bins. Zero-padding can make a smoother plot but does not improve the true resolution.</a:t>
+              <a:defRPr sz="1400">
+                <a:solidFill>
+                  <a:srgbClr val="161616"/>
+                </a:solidFill>
+                <a:latin typeface="Aptos"/>
+              </a:defRPr>
+            </a:pPr>
+            <a:r>
+              <a:t>For Lab 2, MATLAB performs this calculation. You must understand the input, the frequency axis, and the physical meaning of the peak.</a:t>
             </a:r>
           </a:p>
         </p:txBody>
@@ -6057,7 +6101,7 @@
               </a:defRPr>
             </a:pPr>
             <a:r>
-              <a:t>39-41 min</a:t>
+              <a:t>37-38.5 min</a:t>
             </a:r>
           </a:p>
         </p:txBody>
@@ -6093,21 +6137,69 @@
               </a:defRPr>
             </a:pPr>
             <a:r>
-              <a:t>Lab 2 trial matrix</a:t>
-            </a:r>
-          </a:p>
-        </p:txBody>
-      </p:sp>
-      <p:sp>
-        <p:nvSpPr>
-          <p:cNvPr id="5" name="TextBox 4"/>
-          <p:cNvSpPr txBox="1"/>
-          <p:nvPr/>
-        </p:nvSpPr>
-        <p:spPr>
-          <a:xfrm>
-            <a:off x="685800" y="1508760"/>
-            <a:ext cx="10698480" cy="4480560"/>
+              <a:t>Using FFT results in Lab 2</a:t>
+            </a:r>
+          </a:p>
+        </p:txBody>
+      </p:sp>
+      <p:pic>
+        <p:nvPicPr>
+          <p:cNvPr id="5" name="Picture 4" descr="fft_bins-black.png"/>
+          <p:cNvPicPr>
+            <a:picLocks noChangeAspect="1"/>
+          </p:cNvPicPr>
+          <p:nvPr/>
+        </p:nvPicPr>
+        <p:blipFill>
+          <a:blip r:embed="rId2"/>
+          <a:stretch>
+            <a:fillRect/>
+          </a:stretch>
+        </p:blipFill>
+        <p:spPr>
+          <a:xfrm>
+            <a:off x="3611880" y="1417320"/>
+            <a:ext cx="5029200" cy="658368"/>
+          </a:xfrm>
+          <a:prstGeom prst="rect">
+            <a:avLst/>
+          </a:prstGeom>
+        </p:spPr>
+      </p:pic>
+      <p:pic>
+        <p:nvPicPr>
+          <p:cNvPr id="6" name="Picture 5" descr="resolution-black.png"/>
+          <p:cNvPicPr>
+            <a:picLocks noChangeAspect="1"/>
+          </p:cNvPicPr>
+          <p:nvPr/>
+        </p:nvPicPr>
+        <p:blipFill>
+          <a:blip r:embed="rId3"/>
+          <a:stretch>
+            <a:fillRect/>
+          </a:stretch>
+        </p:blipFill>
+        <p:spPr>
+          <a:xfrm>
+            <a:off x="4251960" y="2331720"/>
+            <a:ext cx="3657600" cy="594360"/>
+          </a:xfrm>
+          <a:prstGeom prst="rect">
+            <a:avLst/>
+          </a:prstGeom>
+        </p:spPr>
+      </p:pic>
+      <p:sp>
+        <p:nvSpPr>
+          <p:cNvPr id="7" name="TextBox 6"/>
+          <p:cNvSpPr txBox="1"/>
+          <p:nvPr/>
+        </p:nvSpPr>
+        <p:spPr>
+          <a:xfrm>
+            <a:off x="685800" y="3337560"/>
+            <a:ext cx="10789920" cy="2194560"/>
           </a:xfrm>
           <a:prstGeom prst="rect">
             <a:avLst/>
@@ -6124,15 +6216,15 @@
               <a:spcAft>
                 <a:spcPts val="1100"/>
               </a:spcAft>
-              <a:defRPr sz="2100">
-                <a:solidFill>
-                  <a:srgbClr val="161616"/>
-                </a:solidFill>
-                <a:latin typeface="Aptos"/>
-              </a:defRPr>
-            </a:pPr>
-            <a:r>
-              <a:t>Trial A: theta0 below 10 degrees. Closest test of small-angle theory.</a:t>
+              <a:defRPr sz="1800">
+                <a:solidFill>
+                  <a:srgbClr val="161616"/>
+                </a:solidFill>
+                <a:latin typeface="Aptos"/>
+              </a:defRPr>
+            </a:pPr>
+            <a:r>
+              <a:t>Start with the usable theta(t) segment. Remove its mean before the FFT.</a:t>
             </a:r>
           </a:p>
           <a:p>
@@ -6140,15 +6232,15 @@
               <a:spcAft>
                 <a:spcPts val="1100"/>
               </a:spcAft>
-              <a:defRPr sz="2100">
-                <a:solidFill>
-                  <a:srgbClr val="161616"/>
-                </a:solidFill>
-                <a:latin typeface="Aptos"/>
-              </a:defRPr>
-            </a:pPr>
-            <a:r>
-              <a:t>Trial B: theta0 from 10 to 90 degrees. Observe period change.</a:t>
+              <a:defRPr sz="1800">
+                <a:solidFill>
+                  <a:srgbClr val="161616"/>
+                </a:solidFill>
+                <a:latin typeface="Aptos"/>
+              </a:defRPr>
+            </a:pPr>
+            <a:r>
+              <a:t>Nₛ samples at frame rate fₛ give record duration Tᵣ = Nₛ/fₛ and bin spacing Delta f = 1/Tᵣ.</a:t>
             </a:r>
           </a:p>
           <a:p>
@@ -6156,15 +6248,15 @@
               <a:spcAft>
                 <a:spcPts val="1100"/>
               </a:spcAft>
-              <a:defRPr sz="2100">
-                <a:solidFill>
-                  <a:srgbClr val="161616"/>
-                </a:solidFill>
-                <a:latin typeface="Aptos"/>
-              </a:defRPr>
-            </a:pPr>
-            <a:r>
-              <a:t>Trial C: theta0 above 90 degrees only when approved by the GTA and the full swing stays in frame.</a:t>
+              <a:defRPr sz="1800">
+                <a:solidFill>
+                  <a:srgbClr val="161616"/>
+                </a:solidFill>
+                <a:latin typeface="Aptos"/>
+              </a:defRPr>
+            </a:pPr>
+            <a:r>
+              <a:t>Read f_peak from the largest physically meaningful peak, then use T_FFT = 1/f_peak.</a:t>
             </a:r>
           </a:p>
           <a:p>
@@ -6172,15 +6264,15 @@
               <a:spcAft>
                 <a:spcPts val="1100"/>
               </a:spcAft>
-              <a:defRPr sz="2100">
-                <a:solidFill>
-                  <a:srgbClr val="161616"/>
-                </a:solidFill>
-                <a:latin typeface="Aptos"/>
-              </a:defRPr>
-            </a:pPr>
-            <a:r>
-              <a:t>All releases start from rest. Record theta0 from protractor; do not push the bob.</a:t>
+              <a:defRPr sz="1800">
+                <a:solidFill>
+                  <a:srgbClr val="161616"/>
+                </a:solidFill>
+                <a:latin typeface="Aptos"/>
+              </a:defRPr>
+            </a:pPr>
+            <a:r>
+              <a:t>A longer usable record narrows the bins. Zero-padding can make a smoother plot but does not improve the true resolution.</a:t>
             </a:r>
           </a:p>
         </p:txBody>
@@ -6270,7 +6362,7 @@
               </a:defRPr>
             </a:pPr>
             <a:r>
-              <a:t>41-43 min</a:t>
+              <a:t>38.5-40 min</a:t>
             </a:r>
           </a:p>
         </p:txBody>
@@ -6306,7 +6398,7 @@
               </a:defRPr>
             </a:pPr>
             <a:r>
-              <a:t>Data quality before accepting video</a:t>
+              <a:t>Lab 2 trial matrix</a:t>
             </a:r>
           </a:p>
         </p:txBody>
@@ -6345,7 +6437,7 @@
               </a:defRPr>
             </a:pPr>
             <a:r>
-              <a:t>Bob remains in frame.</a:t>
+              <a:t>Trial A: theta0 below 10 degrees. Closest test of small-angle theory.</a:t>
             </a:r>
           </a:p>
           <a:p>
@@ -6361,7 +6453,7 @@
               </a:defRPr>
             </a:pPr>
             <a:r>
-              <a:t>Bob edge and center are visible without glare.</a:t>
+              <a:t>Trial B: theta0 from 10 to 90 degrees. Observe period change.</a:t>
             </a:r>
           </a:p>
           <a:p>
@@ -6377,7 +6469,7 @@
               </a:defRPr>
             </a:pPr>
             <a:r>
-              <a:t>Pivot and calibration marks are visible.</a:t>
+              <a:t>Trial C: theta0 above 90 degrees only when approved by the GTA and the full swing stays in frame.</a:t>
             </a:r>
           </a:p>
           <a:p>
@@ -6393,39 +6485,7 @@
               </a:defRPr>
             </a:pPr>
             <a:r>
-              <a:t>Release begins from rest.</a:t>
-            </a:r>
-          </a:p>
-          <a:p>
-            <a:pPr>
-              <a:spcAft>
-                <a:spcPts val="1100"/>
-              </a:spcAft>
-              <a:defRPr sz="2100">
-                <a:solidFill>
-                  <a:srgbClr val="161616"/>
-                </a:solidFill>
-                <a:latin typeface="Aptos"/>
-              </a:defRPr>
-            </a:pPr>
-            <a:r>
-              <a:t>Quick Review follows bob for nearly all frames.</a:t>
-            </a:r>
-          </a:p>
-          <a:p>
-            <a:pPr>
-              <a:spcAft>
-                <a:spcPts val="1100"/>
-              </a:spcAft>
-              <a:defRPr sz="2100">
-                <a:solidFill>
-                  <a:srgbClr val="161616"/>
-                </a:solidFill>
-                <a:latin typeface="Aptos"/>
-              </a:defRPr>
-            </a:pPr>
-            <a:r>
-              <a:t>Notes include file name, angle, frame rate, and calibration distance.</a:t>
+              <a:t>All releases start from rest. Record theta0 from protractor; do not push the bob.</a:t>
             </a:r>
           </a:p>
         </p:txBody>
@@ -6515,7 +6575,7 @@
               </a:defRPr>
             </a:pPr>
             <a:r>
-              <a:t>43-45 min</a:t>
+              <a:t>41-43 min</a:t>
             </a:r>
           </a:p>
         </p:txBody>
@@ -6551,7 +6611,7 @@
               </a:defRPr>
             </a:pPr>
             <a:r>
-              <a:t>Pre-Lab 2: what you submit</a:t>
+              <a:t>Data quality before accepting video</a:t>
             </a:r>
           </a:p>
         </p:txBody>
@@ -6590,7 +6650,7 @@
               </a:defRPr>
             </a:pPr>
             <a:r>
-              <a:t>One Word or PDF before laboratory section.</a:t>
+              <a:t>Bob remains in frame.</a:t>
             </a:r>
           </a:p>
           <a:p>
@@ -6606,7 +6666,7 @@
               </a:defRPr>
             </a:pPr>
             <a:r>
-              <a:t>Use the supplied notebook: run the provided cells, keep requested figures, and write your own answers. No programming is assigned.</a:t>
+              <a:t>Bob edge and center are visible without glare.</a:t>
             </a:r>
           </a:p>
           <a:p>
@@ -6622,7 +6682,7 @@
               </a:defRPr>
             </a:pPr>
             <a:r>
-              <a:t>Task 1: compare point-mass and compound-pendulum frequencies.</a:t>
+              <a:t>Pivot and calibration marks are visible.</a:t>
             </a:r>
           </a:p>
           <a:p>
@@ -6638,7 +6698,7 @@
               </a:defRPr>
             </a:pPr>
             <a:r>
-              <a:t>Task 2: predict behavior before running the supplied simulation.</a:t>
+              <a:t>Release begins from rest.</a:t>
             </a:r>
           </a:p>
           <a:p>
@@ -6654,7 +6714,23 @@
               </a:defRPr>
             </a:pPr>
             <a:r>
-              <a:t>Tasks 3-6: explain finite-angle behavior, coordinates, frame rate, and the laboratory plan.</a:t>
+              <a:t>Quick Review follows bob for nearly all frames.</a:t>
+            </a:r>
+          </a:p>
+          <a:p>
+            <a:pPr>
+              <a:spcAft>
+                <a:spcPts val="1100"/>
+              </a:spcAft>
+              <a:defRPr sz="2100">
+                <a:solidFill>
+                  <a:srgbClr val="161616"/>
+                </a:solidFill>
+                <a:latin typeface="Aptos"/>
+              </a:defRPr>
+            </a:pPr>
+            <a:r>
+              <a:t>Notes include file name, angle, frame rate, and calibration distance.</a:t>
             </a:r>
           </a:p>
         </p:txBody>
@@ -6744,7 +6820,7 @@
               </a:defRPr>
             </a:pPr>
             <a:r>
-              <a:t>45-47 min</a:t>
+              <a:t>43-45 min</a:t>
             </a:r>
           </a:p>
         </p:txBody>
@@ -6780,7 +6856,7 @@
               </a:defRPr>
             </a:pPr>
             <a:r>
-              <a:t>Evidence for combined Lab 2 and 3 report</a:t>
+              <a:t>Pre-Lab 2: what you submit</a:t>
             </a:r>
           </a:p>
         </p:txBody>
@@ -6819,7 +6895,7 @@
               </a:defRPr>
             </a:pPr>
             <a:r>
-              <a:t>Schematic: pivot, l, M, m, theta, and positive direction.</a:t>
+              <a:t>One Word or PDF before laboratory section.</a:t>
             </a:r>
           </a:p>
           <a:p>
@@ -6835,7 +6911,7 @@
               </a:defRPr>
             </a:pPr>
             <a:r>
-              <a:t>Table: measured parameters and analytical, nonlinear, time-domain, and FFT frequencies.</a:t>
+              <a:t>Use the supplied notebook: run the provided cells, keep requested figures, and write your own answers. No programming is assigned.</a:t>
             </a:r>
           </a:p>
           <a:p>
@@ -6851,7 +6927,7 @@
               </a:defRPr>
             </a:pPr>
             <a:r>
-              <a:t>Plots: theta(t), omega(t), and spectra with units.</a:t>
+              <a:t>Task 1: compare point-mass and compound-pendulum frequencies.</a:t>
             </a:r>
           </a:p>
           <a:p>
@@ -6867,7 +6943,23 @@
               </a:defRPr>
             </a:pPr>
             <a:r>
-              <a:t>Discussion: separate model limitations from measurement errors.</a:t>
+              <a:t>Task 2: predict behavior before running the supplied simulation.</a:t>
+            </a:r>
+          </a:p>
+          <a:p>
+            <a:pPr>
+              <a:spcAft>
+                <a:spcPts val="1100"/>
+              </a:spcAft>
+              <a:defRPr sz="2100">
+                <a:solidFill>
+                  <a:srgbClr val="161616"/>
+                </a:solidFill>
+                <a:latin typeface="Aptos"/>
+              </a:defRPr>
+            </a:pPr>
+            <a:r>
+              <a:t>Tasks 3-6: explain finite-angle behavior, coordinates, frame rate, and the laboratory plan.</a:t>
             </a:r>
           </a:p>
         </p:txBody>
@@ -6957,7 +7049,7 @@
               </a:defRPr>
             </a:pPr>
             <a:r>
-              <a:t>47-49 min</a:t>
+              <a:t>45-47 min</a:t>
             </a:r>
           </a:p>
         </p:txBody>
@@ -6993,7 +7085,7 @@
               </a:defRPr>
             </a:pPr>
             <a:r>
-              <a:t>In-class prediction</a:t>
+              <a:t>Evidence for combined Lab 2 and 3 report</a:t>
             </a:r>
           </a:p>
         </p:txBody>
@@ -7006,44 +7098,8 @@
         </p:nvSpPr>
         <p:spPr>
           <a:xfrm>
-            <a:off x="777240" y="1508760"/>
-            <a:ext cx="10698480" cy="548640"/>
-          </a:xfrm>
-          <a:prstGeom prst="rect">
-            <a:avLst/>
-          </a:prstGeom>
-          <a:noFill/>
-        </p:spPr>
-        <p:txBody>
-          <a:bodyPr wrap="square">
-            <a:spAutoFit/>
-          </a:bodyPr>
-          <a:lstStyle/>
-          <a:p>
-            <a:pPr algn="ctr">
-              <a:defRPr sz="2600" b="1">
-                <a:solidFill>
-                  <a:srgbClr val="881C1C"/>
-                </a:solidFill>
-                <a:latin typeface="Aptos"/>
-              </a:defRPr>
-            </a:pPr>
-            <a:r>
-              <a:t>For the same apparatus, which release has the longest period?</a:t>
-            </a:r>
-          </a:p>
-        </p:txBody>
-      </p:sp>
-      <p:sp>
-        <p:nvSpPr>
-          <p:cNvPr id="6" name="TextBox 5"/>
-          <p:cNvSpPr txBox="1"/>
-          <p:nvPr/>
-        </p:nvSpPr>
-        <p:spPr>
-          <a:xfrm>
-            <a:off x="2011680" y="2788920"/>
-            <a:ext cx="8138160" cy="2103120"/>
+            <a:off x="685800" y="1508760"/>
+            <a:ext cx="10698480" cy="4480560"/>
           </a:xfrm>
           <a:prstGeom prst="rect">
             <a:avLst/>
@@ -7060,15 +7116,15 @@
               <a:spcAft>
                 <a:spcPts val="1100"/>
               </a:spcAft>
-              <a:defRPr sz="2400">
-                <a:solidFill>
-                  <a:srgbClr val="161616"/>
-                </a:solidFill>
-                <a:latin typeface="Aptos"/>
-              </a:defRPr>
-            </a:pPr>
-            <a:r>
-              <a:t>A. 8 degrees</a:t>
+              <a:defRPr sz="2100">
+                <a:solidFill>
+                  <a:srgbClr val="161616"/>
+                </a:solidFill>
+                <a:latin typeface="Aptos"/>
+              </a:defRPr>
+            </a:pPr>
+            <a:r>
+              <a:t>Schematic: pivot, l, M, m, theta, and positive direction.</a:t>
             </a:r>
           </a:p>
           <a:p>
@@ -7076,15 +7132,15 @@
               <a:spcAft>
                 <a:spcPts val="1100"/>
               </a:spcAft>
-              <a:defRPr sz="2400">
-                <a:solidFill>
-                  <a:srgbClr val="161616"/>
-                </a:solidFill>
-                <a:latin typeface="Aptos"/>
-              </a:defRPr>
-            </a:pPr>
-            <a:r>
-              <a:t>B. 35 degrees</a:t>
+              <a:defRPr sz="2100">
+                <a:solidFill>
+                  <a:srgbClr val="161616"/>
+                </a:solidFill>
+                <a:latin typeface="Aptos"/>
+              </a:defRPr>
+            </a:pPr>
+            <a:r>
+              <a:t>Table: measured parameters and analytical, nonlinear, time-domain, and FFT frequencies.</a:t>
             </a:r>
           </a:p>
           <a:p>
@@ -7092,15 +7148,15 @@
               <a:spcAft>
                 <a:spcPts val="1100"/>
               </a:spcAft>
-              <a:defRPr sz="2400">
-                <a:solidFill>
-                  <a:srgbClr val="161616"/>
-                </a:solidFill>
-                <a:latin typeface="Aptos"/>
-              </a:defRPr>
-            </a:pPr>
-            <a:r>
-              <a:t>C. 105 degrees</a:t>
+              <a:defRPr sz="2100">
+                <a:solidFill>
+                  <a:srgbClr val="161616"/>
+                </a:solidFill>
+                <a:latin typeface="Aptos"/>
+              </a:defRPr>
+            </a:pPr>
+            <a:r>
+              <a:t>Plots: theta(t), omega(t), and spectra with units.</a:t>
             </a:r>
           </a:p>
           <a:p>
@@ -7108,15 +7164,15 @@
               <a:spcAft>
                 <a:spcPts val="1100"/>
               </a:spcAft>
-              <a:defRPr sz="2400">
-                <a:solidFill>
-                  <a:srgbClr val="161616"/>
-                </a:solidFill>
-                <a:latin typeface="Aptos"/>
-              </a:defRPr>
-            </a:pPr>
-            <a:r>
-              <a:t>Explain using the exact sine restoring torque.</a:t>
+              <a:defRPr sz="2100">
+                <a:solidFill>
+                  <a:srgbClr val="161616"/>
+                </a:solidFill>
+                <a:latin typeface="Aptos"/>
+              </a:defRPr>
+            </a:pPr>
+            <a:r>
+              <a:t>Discussion: separate model limitations from measurement errors.</a:t>
             </a:r>
           </a:p>
         </p:txBody>
@@ -7206,7 +7262,7 @@
               </a:defRPr>
             </a:pPr>
             <a:r>
-              <a:t>49-50 min</a:t>
+              <a:t>47-49 min</a:t>
             </a:r>
           </a:p>
         </p:txBody>
@@ -7242,7 +7298,7 @@
               </a:defRPr>
             </a:pPr>
             <a:r>
-              <a:t>Before leaving laboratory</a:t>
+              <a:t>In-class prediction</a:t>
             </a:r>
           </a:p>
         </p:txBody>
@@ -7255,8 +7311,44 @@
         </p:nvSpPr>
         <p:spPr>
           <a:xfrm>
-            <a:off x="685800" y="1508760"/>
-            <a:ext cx="10698480" cy="4480560"/>
+            <a:off x="777240" y="1508760"/>
+            <a:ext cx="10698480" cy="548640"/>
+          </a:xfrm>
+          <a:prstGeom prst="rect">
+            <a:avLst/>
+          </a:prstGeom>
+          <a:noFill/>
+        </p:spPr>
+        <p:txBody>
+          <a:bodyPr wrap="square">
+            <a:spAutoFit/>
+          </a:bodyPr>
+          <a:lstStyle/>
+          <a:p>
+            <a:pPr algn="ctr">
+              <a:defRPr sz="2600" b="1">
+                <a:solidFill>
+                  <a:srgbClr val="881C1C"/>
+                </a:solidFill>
+                <a:latin typeface="Aptos"/>
+              </a:defRPr>
+            </a:pPr>
+            <a:r>
+              <a:t>For the same apparatus, which release has the longest period?</a:t>
+            </a:r>
+          </a:p>
+        </p:txBody>
+      </p:sp>
+      <p:sp>
+        <p:nvSpPr>
+          <p:cNvPr id="6" name="TextBox 5"/>
+          <p:cNvSpPr txBox="1"/>
+          <p:nvPr/>
+        </p:nvSpPr>
+        <p:spPr>
+          <a:xfrm>
+            <a:off x="2011680" y="2788920"/>
+            <a:ext cx="8138160" cy="2103120"/>
           </a:xfrm>
           <a:prstGeom prst="rect">
             <a:avLst/>
@@ -7273,15 +7365,15 @@
               <a:spcAft>
                 <a:spcPts val="1100"/>
               </a:spcAft>
-              <a:defRPr sz="2100">
-                <a:solidFill>
-                  <a:srgbClr val="161616"/>
-                </a:solidFill>
-                <a:latin typeface="Aptos"/>
-              </a:defRPr>
-            </a:pPr>
-            <a:r>
-              <a:t>Save and back up every video and MAT output.</a:t>
+              <a:defRPr sz="2400">
+                <a:solidFill>
+                  <a:srgbClr val="161616"/>
+                </a:solidFill>
+                <a:latin typeface="Aptos"/>
+              </a:defRPr>
+            </a:pPr>
+            <a:r>
+              <a:t>A. 8 degrees</a:t>
             </a:r>
           </a:p>
           <a:p>
@@ -7289,15 +7381,15 @@
               <a:spcAft>
                 <a:spcPts val="1100"/>
               </a:spcAft>
-              <a:defRPr sz="2100">
-                <a:solidFill>
-                  <a:srgbClr val="161616"/>
-                </a:solidFill>
-                <a:latin typeface="Aptos"/>
-              </a:defRPr>
-            </a:pPr>
-            <a:r>
-              <a:t>Verify tracking for every trial.</a:t>
+              <a:defRPr sz="2400">
+                <a:solidFill>
+                  <a:srgbClr val="161616"/>
+                </a:solidFill>
+                <a:latin typeface="Aptos"/>
+              </a:defRPr>
+            </a:pPr>
+            <a:r>
+              <a:t>B. 35 degrees</a:t>
             </a:r>
           </a:p>
           <a:p>
@@ -7305,15 +7397,15 @@
               <a:spcAft>
                 <a:spcPts val="1100"/>
               </a:spcAft>
-              <a:defRPr sz="2100">
-                <a:solidFill>
-                  <a:srgbClr val="161616"/>
-                </a:solidFill>
-                <a:latin typeface="Aptos"/>
-              </a:defRPr>
-            </a:pPr>
-            <a:r>
-              <a:t>Record initial angle, frame rate, calibration distance, l, M, m, and file names.</a:t>
+              <a:defRPr sz="2400">
+                <a:solidFill>
+                  <a:srgbClr val="161616"/>
+                </a:solidFill>
+                <a:latin typeface="Aptos"/>
+              </a:defRPr>
+            </a:pPr>
+            <a:r>
+              <a:t>C. 105 degrees</a:t>
             </a:r>
           </a:p>
           <a:p>
@@ -7321,15 +7413,15 @@
               <a:spcAft>
                 <a:spcPts val="1100"/>
               </a:spcAft>
-              <a:defRPr sz="2100">
-                <a:solidFill>
-                  <a:srgbClr val="161616"/>
-                </a:solidFill>
-                <a:latin typeface="Aptos"/>
-              </a:defRPr>
-            </a:pPr>
-            <a:r>
-              <a:t>Check one theta(t) plot and one spectrum with the GTA.</a:t>
+              <a:defRPr sz="2400">
+                <a:solidFill>
+                  <a:srgbClr val="161616"/>
+                </a:solidFill>
+                <a:latin typeface="Aptos"/>
+              </a:defRPr>
+            </a:pPr>
+            <a:r>
+              <a:t>Explain using the exact sine restoring torque.</a:t>
             </a:r>
           </a:p>
         </p:txBody>
@@ -7343,6 +7435,219 @@
 </file>
 
 <file path=ppt/slides/slide26.xml><?xml version="1.0" encoding="utf-8"?>
+<p:sld xmlns:a="http://schemas.openxmlformats.org/drawingml/2006/main" xmlns:p="http://schemas.openxmlformats.org/presentationml/2006/main" xmlns:r="http://schemas.openxmlformats.org/officeDocument/2006/relationships">
+  <p:cSld>
+    <p:spTree>
+      <p:nvGrpSpPr>
+        <p:cNvPr id="1" name=""/>
+        <p:cNvGrpSpPr/>
+        <p:nvPr/>
+      </p:nvGrpSpPr>
+      <p:grpSpPr/>
+      <p:sp>
+        <p:nvSpPr>
+          <p:cNvPr id="2" name="TextBox 1"/>
+          <p:cNvSpPr txBox="1"/>
+          <p:nvPr/>
+        </p:nvSpPr>
+        <p:spPr>
+          <a:xfrm>
+            <a:off x="256032" y="164592"/>
+            <a:ext cx="4114800" cy="274320"/>
+          </a:xfrm>
+          <a:prstGeom prst="rect">
+            <a:avLst/>
+          </a:prstGeom>
+          <a:noFill/>
+        </p:spPr>
+        <p:txBody>
+          <a:bodyPr wrap="square">
+            <a:spAutoFit/>
+          </a:bodyPr>
+          <a:lstStyle/>
+          <a:p>
+            <a:pPr>
+              <a:defRPr sz="1200" b="1">
+                <a:solidFill>
+                  <a:srgbClr val="881C1C"/>
+                </a:solidFill>
+                <a:latin typeface="Aptos"/>
+              </a:defRPr>
+            </a:pPr>
+            <a:r>
+              <a:t>MIE 402  |  ME LAB II</a:t>
+            </a:r>
+          </a:p>
+        </p:txBody>
+      </p:sp>
+      <p:sp>
+        <p:nvSpPr>
+          <p:cNvPr id="3" name="TextBox 2"/>
+          <p:cNvSpPr txBox="1"/>
+          <p:nvPr/>
+        </p:nvSpPr>
+        <p:spPr>
+          <a:xfrm>
+            <a:off x="8869680" y="164592"/>
+            <a:ext cx="2743200" cy="274320"/>
+          </a:xfrm>
+          <a:prstGeom prst="rect">
+            <a:avLst/>
+          </a:prstGeom>
+          <a:noFill/>
+        </p:spPr>
+        <p:txBody>
+          <a:bodyPr wrap="square">
+            <a:spAutoFit/>
+          </a:bodyPr>
+          <a:lstStyle/>
+          <a:p>
+            <a:pPr algn="r">
+              <a:defRPr sz="1200" b="0">
+                <a:solidFill>
+                  <a:srgbClr val="666666"/>
+                </a:solidFill>
+                <a:latin typeface="Aptos"/>
+              </a:defRPr>
+            </a:pPr>
+            <a:r>
+              <a:t>49-50 min</a:t>
+            </a:r>
+          </a:p>
+        </p:txBody>
+      </p:sp>
+      <p:sp>
+        <p:nvSpPr>
+          <p:cNvPr id="4" name="TextBox 3"/>
+          <p:cNvSpPr txBox="1"/>
+          <p:nvPr/>
+        </p:nvSpPr>
+        <p:spPr>
+          <a:xfrm>
+            <a:off x="256032" y="685800"/>
+            <a:ext cx="11338560" cy="594360"/>
+          </a:xfrm>
+          <a:prstGeom prst="rect">
+            <a:avLst/>
+          </a:prstGeom>
+          <a:noFill/>
+        </p:spPr>
+        <p:txBody>
+          <a:bodyPr wrap="square">
+            <a:spAutoFit/>
+          </a:bodyPr>
+          <a:lstStyle/>
+          <a:p>
+            <a:pPr>
+              <a:defRPr sz="2900" b="1">
+                <a:solidFill>
+                  <a:srgbClr val="161616"/>
+                </a:solidFill>
+                <a:latin typeface="Aptos"/>
+              </a:defRPr>
+            </a:pPr>
+            <a:r>
+              <a:t>Before leaving laboratory</a:t>
+            </a:r>
+          </a:p>
+        </p:txBody>
+      </p:sp>
+      <p:sp>
+        <p:nvSpPr>
+          <p:cNvPr id="5" name="TextBox 4"/>
+          <p:cNvSpPr txBox="1"/>
+          <p:nvPr/>
+        </p:nvSpPr>
+        <p:spPr>
+          <a:xfrm>
+            <a:off x="685800" y="1508760"/>
+            <a:ext cx="10698480" cy="4480560"/>
+          </a:xfrm>
+          <a:prstGeom prst="rect">
+            <a:avLst/>
+          </a:prstGeom>
+          <a:noFill/>
+        </p:spPr>
+        <p:txBody>
+          <a:bodyPr wrap="square">
+            <a:spAutoFit/>
+          </a:bodyPr>
+          <a:lstStyle/>
+          <a:p>
+            <a:pPr>
+              <a:spcAft>
+                <a:spcPts val="1100"/>
+              </a:spcAft>
+              <a:defRPr sz="2100">
+                <a:solidFill>
+                  <a:srgbClr val="161616"/>
+                </a:solidFill>
+                <a:latin typeface="Aptos"/>
+              </a:defRPr>
+            </a:pPr>
+            <a:r>
+              <a:t>Save and back up every video and MAT output.</a:t>
+            </a:r>
+          </a:p>
+          <a:p>
+            <a:pPr>
+              <a:spcAft>
+                <a:spcPts val="1100"/>
+              </a:spcAft>
+              <a:defRPr sz="2100">
+                <a:solidFill>
+                  <a:srgbClr val="161616"/>
+                </a:solidFill>
+                <a:latin typeface="Aptos"/>
+              </a:defRPr>
+            </a:pPr>
+            <a:r>
+              <a:t>Verify tracking for every trial.</a:t>
+            </a:r>
+          </a:p>
+          <a:p>
+            <a:pPr>
+              <a:spcAft>
+                <a:spcPts val="1100"/>
+              </a:spcAft>
+              <a:defRPr sz="2100">
+                <a:solidFill>
+                  <a:srgbClr val="161616"/>
+                </a:solidFill>
+                <a:latin typeface="Aptos"/>
+              </a:defRPr>
+            </a:pPr>
+            <a:r>
+              <a:t>Record initial angle, frame rate, calibration distance, l, M, m, and file names.</a:t>
+            </a:r>
+          </a:p>
+          <a:p>
+            <a:pPr>
+              <a:spcAft>
+                <a:spcPts val="1100"/>
+              </a:spcAft>
+              <a:defRPr sz="2100">
+                <a:solidFill>
+                  <a:srgbClr val="161616"/>
+                </a:solidFill>
+                <a:latin typeface="Aptos"/>
+              </a:defRPr>
+            </a:pPr>
+            <a:r>
+              <a:t>Check one theta(t) plot and one spectrum with the GTA.</a:t>
+            </a:r>
+          </a:p>
+        </p:txBody>
+      </p:sp>
+    </p:spTree>
+  </p:cSld>
+  <p:clrMapOvr>
+    <a:masterClrMapping/>
+  </p:clrMapOvr>
+</p:sld>
+</file>
+
+<file path=ppt/slides/slide27.xml><?xml version="1.0" encoding="utf-8"?>
 <p:sld xmlns:a="http://schemas.openxmlformats.org/drawingml/2006/main" xmlns:p="http://schemas.openxmlformats.org/presentationml/2006/main" xmlns:r="http://schemas.openxmlformats.org/officeDocument/2006/relationships">
   <p:cSld>
     <p:spTree>

</xml_diff>